<commit_message>
line number need to be added, commit before jump off
</commit_message>
<xml_diff>
--- a/figures/Figures-EDL202605-manuscript.pptx
+++ b/figures/Figures-EDL202605-manuscript.pptx
@@ -11735,13 +11735,13 @@
           <p:nvPr>
             <p:extLst>
               <p:ext uri="{D42A27DB-BD31-4B8C-83A1-F6EECF244321}">
-                <p14:modId xmlns:p14="http://schemas.microsoft.com/office/powerpoint/2010/main" val="3082154376"/>
+                <p14:modId xmlns:p14="http://schemas.microsoft.com/office/powerpoint/2010/main" val="908189444"/>
               </p:ext>
             </p:extLst>
           </p:nvPr>
         </p:nvGraphicFramePr>
         <p:xfrm>
-          <a:off x="2319557" y="4045272"/>
+          <a:off x="2266217" y="4045272"/>
           <a:ext cx="1104369" cy="1112522"/>
         </p:xfrm>
         <a:graphic>
@@ -11801,7 +11801,7 @@
                           <a:latin typeface="Times New Roman" panose="02020603050405020304" pitchFamily="18" charset="0"/>
                           <a:cs typeface="Times New Roman" panose="02020603050405020304" pitchFamily="18" charset="0"/>
                         </a:rPr>
-                        <a:t>Trap Profile [8]</a:t>
+                        <a:t>Trap profile [6], [9]</a:t>
                       </a:r>
                       <a:endParaRPr lang="ko-KR" altLang="en-US" sz="700" dirty="0">
                         <a:latin typeface="Times New Roman" panose="02020603050405020304" pitchFamily="18" charset="0"/>
@@ -12740,7 +12740,7 @@
         </p:nvSpPr>
         <p:spPr>
           <a:xfrm>
-            <a:off x="684634" y="5484178"/>
+            <a:off x="813926" y="6361323"/>
             <a:ext cx="360492" cy="215444"/>
           </a:xfrm>
           <a:prstGeom prst="rect">
@@ -12783,13 +12783,13 @@
           <p:nvPr>
             <p:extLst>
               <p:ext uri="{D42A27DB-BD31-4B8C-83A1-F6EECF244321}">
-                <p14:modId xmlns:p14="http://schemas.microsoft.com/office/powerpoint/2010/main" val="3207995038"/>
+                <p14:modId xmlns:p14="http://schemas.microsoft.com/office/powerpoint/2010/main" val="1986194788"/>
               </p:ext>
             </p:extLst>
           </p:nvPr>
         </p:nvGraphicFramePr>
         <p:xfrm>
-          <a:off x="1754707" y="5547691"/>
+          <a:off x="1883999" y="6424836"/>
           <a:ext cx="1490637" cy="1309517"/>
         </p:xfrm>
         <a:graphic>
@@ -12823,7 +12823,7 @@
                     </p:blipFill>
                     <p:spPr>
                       <a:xfrm>
-                        <a:off x="1754707" y="5547691"/>
+                        <a:off x="1883999" y="6424836"/>
                         <a:ext cx="1490637" cy="1309517"/>
                       </a:xfrm>
                       <a:prstGeom prst="rect">
@@ -12852,13 +12852,13 @@
           <p:nvPr>
             <p:extLst>
               <p:ext uri="{D42A27DB-BD31-4B8C-83A1-F6EECF244321}">
-                <p14:modId xmlns:p14="http://schemas.microsoft.com/office/powerpoint/2010/main" val="3657693473"/>
+                <p14:modId xmlns:p14="http://schemas.microsoft.com/office/powerpoint/2010/main" val="2067809473"/>
               </p:ext>
             </p:extLst>
           </p:nvPr>
         </p:nvGraphicFramePr>
         <p:xfrm>
-          <a:off x="696036" y="5555602"/>
+          <a:off x="825328" y="6432747"/>
           <a:ext cx="1195151" cy="1123893"/>
         </p:xfrm>
         <a:graphic>
@@ -12892,7 +12892,7 @@
                     </p:blipFill>
                     <p:spPr>
                       <a:xfrm>
-                        <a:off x="696036" y="5555602"/>
+                        <a:off x="825328" y="6432747"/>
                         <a:ext cx="1195151" cy="1123893"/>
                       </a:xfrm>
                       <a:prstGeom prst="rect">
@@ -12920,7 +12920,7 @@
         </p:nvSpPr>
         <p:spPr>
           <a:xfrm>
-            <a:off x="1905414" y="5484178"/>
+            <a:off x="2034706" y="6361323"/>
             <a:ext cx="360492" cy="215444"/>
           </a:xfrm>
           <a:prstGeom prst="rect">
@@ -13004,7 +13004,7 @@
         </p:nvSpPr>
         <p:spPr>
           <a:xfrm>
-            <a:off x="471489" y="5265737"/>
+            <a:off x="600781" y="6142882"/>
             <a:ext cx="332519" cy="198726"/>
           </a:xfrm>
           <a:prstGeom prst="rect">
@@ -13047,7 +13047,7 @@
           <p:nvPr>
             <p:extLst>
               <p:ext uri="{D42A27DB-BD31-4B8C-83A1-F6EECF244321}">
-                <p14:modId xmlns:p14="http://schemas.microsoft.com/office/powerpoint/2010/main" val="2221658377"/>
+                <p14:modId xmlns:p14="http://schemas.microsoft.com/office/powerpoint/2010/main" val="1789443614"/>
               </p:ext>
             </p:extLst>
           </p:nvPr>
@@ -13960,7 +13960,7 @@
           <p:nvPr>
             <p:extLst>
               <p:ext uri="{D42A27DB-BD31-4B8C-83A1-F6EECF244321}">
-                <p14:modId xmlns:p14="http://schemas.microsoft.com/office/powerpoint/2010/main" val="3634708730"/>
+                <p14:modId xmlns:p14="http://schemas.microsoft.com/office/powerpoint/2010/main" val="3177278495"/>
               </p:ext>
             </p:extLst>
           </p:nvPr>
@@ -14242,7 +14242,7 @@
                           <a:latin typeface="Times New Roman" panose="02020603050405020304" pitchFamily="18" charset="0"/>
                           <a:cs typeface="Times New Roman" panose="02020603050405020304" pitchFamily="18" charset="0"/>
                         </a:rPr>
-                        <a:t>0.1 [7]</a:t>
+                        <a:t>0.1 [8]</a:t>
                       </a:r>
                       <a:endParaRPr lang="ko-KR" altLang="en-US" sz="600" dirty="0">
                         <a:latin typeface="Times New Roman" panose="02020603050405020304" pitchFamily="18" charset="0"/>
@@ -14444,7 +14444,7 @@
                           <a:latin typeface="Times New Roman" panose="02020603050405020304" pitchFamily="18" charset="0"/>
                           <a:cs typeface="Times New Roman" panose="02020603050405020304" pitchFamily="18" charset="0"/>
                         </a:rPr>
-                        <a:t>1e-16 [7]</a:t>
+                        <a:t>1e-16 [8]</a:t>
                       </a:r>
                       <a:endParaRPr lang="ko-KR" altLang="en-US" sz="600" dirty="0">
                         <a:latin typeface="Times New Roman" panose="02020603050405020304" pitchFamily="18" charset="0"/>
@@ -14674,7 +14674,7 @@
                           <a:latin typeface="Times New Roman" panose="02020603050405020304" pitchFamily="18" charset="0"/>
                           <a:cs typeface="Times New Roman" panose="02020603050405020304" pitchFamily="18" charset="0"/>
                         </a:rPr>
-                        <a:t> [8]</a:t>
+                        <a:t> [9]</a:t>
                       </a:r>
                       <a:endParaRPr lang="ko-KR" altLang="en-US" sz="600" baseline="-25000" dirty="0">
                         <a:latin typeface="Times New Roman" panose="02020603050405020304" pitchFamily="18" charset="0"/>
@@ -15418,282 +15418,240 @@
           </a:p>
         </p:txBody>
       </p:sp>
-      <p:grpSp>
-        <p:nvGrpSpPr>
-          <p:cNvPr id="42" name="그룹 41">
+      <p:graphicFrame>
+        <p:nvGraphicFramePr>
+          <p:cNvPr id="34" name="개체 33">
             <a:extLst>
               <a:ext uri="{FF2B5EF4-FFF2-40B4-BE49-F238E27FC236}">
-                <a16:creationId xmlns:a16="http://schemas.microsoft.com/office/drawing/2014/main" id="{8ED174BB-0D21-BFB9-EF88-98BFF28A978E}"/>
+                <a16:creationId xmlns:a16="http://schemas.microsoft.com/office/drawing/2014/main" id="{32DB6798-4516-1212-D064-B5BCCDF489E7}"/>
               </a:ext>
             </a:extLst>
           </p:cNvPr>
-          <p:cNvGrpSpPr/>
+          <p:cNvGraphicFramePr>
+            <a:graphicFrameLocks noChangeAspect="1"/>
+          </p:cNvGraphicFramePr>
+          <p:nvPr>
+            <p:extLst>
+              <p:ext uri="{D42A27DB-BD31-4B8C-83A1-F6EECF244321}">
+                <p14:modId xmlns:p14="http://schemas.microsoft.com/office/powerpoint/2010/main" val="2023929375"/>
+              </p:ext>
+            </p:extLst>
+          </p:nvPr>
+        </p:nvGraphicFramePr>
+        <p:xfrm>
+          <a:off x="676202" y="3105282"/>
+          <a:ext cx="939996" cy="838653"/>
+        </p:xfrm>
+        <a:graphic>
+          <a:graphicData uri="http://schemas.openxmlformats.org/presentationml/2006/ole">
+            <mc:AlternateContent xmlns:mc="http://schemas.openxmlformats.org/markup-compatibility/2006">
+              <mc:Choice xmlns:v="urn:schemas-microsoft-com:vml" Requires="v">
+                <p:oleObj name="Graph" r:id="rId11" imgW="2032395" imgH="1812415" progId="Origin50.Graph">
+                  <p:embed/>
+                </p:oleObj>
+              </mc:Choice>
+              <mc:Fallback>
+                <p:oleObj name="Graph" r:id="rId11" imgW="2032395" imgH="1812415" progId="Origin50.Graph">
+                  <p:embed/>
+                  <p:pic>
+                    <p:nvPicPr>
+                      <p:cNvPr id="0" name=""/>
+                      <p:cNvPicPr/>
+                      <p:nvPr/>
+                    </p:nvPicPr>
+                    <p:blipFill>
+                      <a:blip r:embed="rId12"/>
+                      <a:stretch>
+                        <a:fillRect/>
+                      </a:stretch>
+                    </p:blipFill>
+                    <p:spPr>
+                      <a:xfrm>
+                        <a:off x="676202" y="3105282"/>
+                        <a:ext cx="939996" cy="838653"/>
+                      </a:xfrm>
+                      <a:prstGeom prst="rect">
+                        <a:avLst/>
+                      </a:prstGeom>
+                    </p:spPr>
+                  </p:pic>
+                </p:oleObj>
+              </mc:Fallback>
+            </mc:AlternateContent>
+          </a:graphicData>
+        </a:graphic>
+      </p:graphicFrame>
+      <p:cxnSp>
+        <p:nvCxnSpPr>
+          <p:cNvPr id="25" name="직선 화살표 연결선 24">
+            <a:extLst>
+              <a:ext uri="{FF2B5EF4-FFF2-40B4-BE49-F238E27FC236}">
+                <a16:creationId xmlns:a16="http://schemas.microsoft.com/office/drawing/2014/main" id="{4D7A2743-1EB3-7279-A55E-50E052EECFF4}"/>
+              </a:ext>
+            </a:extLst>
+          </p:cNvPr>
+          <p:cNvCxnSpPr>
+            <a:cxnSpLocks/>
+          </p:cNvCxnSpPr>
           <p:nvPr/>
-        </p:nvGrpSpPr>
-        <p:grpSpPr>
+        </p:nvCxnSpPr>
+        <p:spPr>
           <a:xfrm>
-            <a:off x="684634" y="3105282"/>
-            <a:ext cx="1020918" cy="838653"/>
-            <a:chOff x="1773808" y="3291829"/>
-            <a:chExt cx="1020918" cy="838653"/>
+            <a:off x="684634" y="3801330"/>
+            <a:ext cx="821003" cy="0"/>
           </a:xfrm>
-        </p:grpSpPr>
-        <p:grpSp>
-          <p:nvGrpSpPr>
-            <p:cNvPr id="39" name="그룹 38">
-              <a:extLst>
-                <a:ext uri="{FF2B5EF4-FFF2-40B4-BE49-F238E27FC236}">
-                  <a16:creationId xmlns:a16="http://schemas.microsoft.com/office/drawing/2014/main" id="{5F9220A9-2AC0-3BC8-ACE5-6FC3458D527D}"/>
-                </a:ext>
-              </a:extLst>
-            </p:cNvPr>
-            <p:cNvGrpSpPr/>
-            <p:nvPr/>
-          </p:nvGrpSpPr>
-          <p:grpSpPr>
-            <a:xfrm>
-              <a:off x="1773808" y="3291829"/>
-              <a:ext cx="1020918" cy="838653"/>
-              <a:chOff x="1194773" y="3291829"/>
-              <a:chExt cx="1020918" cy="838653"/>
-            </a:xfrm>
-          </p:grpSpPr>
-          <p:graphicFrame>
-            <p:nvGraphicFramePr>
-              <p:cNvPr id="34" name="개체 33">
-                <a:extLst>
-                  <a:ext uri="{FF2B5EF4-FFF2-40B4-BE49-F238E27FC236}">
-                    <a16:creationId xmlns:a16="http://schemas.microsoft.com/office/drawing/2014/main" id="{32DB6798-4516-1212-D064-B5BCCDF489E7}"/>
-                  </a:ext>
-                </a:extLst>
-              </p:cNvPr>
-              <p:cNvGraphicFramePr>
-                <a:graphicFrameLocks noChangeAspect="1"/>
-              </p:cNvGraphicFramePr>
-              <p:nvPr>
-                <p:extLst>
-                  <p:ext uri="{D42A27DB-BD31-4B8C-83A1-F6EECF244321}">
-                    <p14:modId xmlns:p14="http://schemas.microsoft.com/office/powerpoint/2010/main" val="2901495951"/>
-                  </p:ext>
-                </p:extLst>
-              </p:nvPr>
-            </p:nvGraphicFramePr>
-            <p:xfrm>
-              <a:off x="1239681" y="3291829"/>
-              <a:ext cx="939996" cy="838653"/>
-            </p:xfrm>
-            <a:graphic>
-              <a:graphicData uri="http://schemas.openxmlformats.org/presentationml/2006/ole">
-                <mc:AlternateContent xmlns:mc="http://schemas.openxmlformats.org/markup-compatibility/2006">
-                  <mc:Choice xmlns:v="urn:schemas-microsoft-com:vml" Requires="v">
-                    <p:oleObj name="Graph" r:id="rId11" imgW="2032395" imgH="1812415" progId="Origin50.Graph">
-                      <p:embed/>
-                    </p:oleObj>
-                  </mc:Choice>
-                  <mc:Fallback>
-                    <p:oleObj name="Graph" r:id="rId11" imgW="2032395" imgH="1812415" progId="Origin50.Graph">
-                      <p:embed/>
-                      <p:pic>
-                        <p:nvPicPr>
-                          <p:cNvPr id="0" name=""/>
-                          <p:cNvPicPr/>
-                          <p:nvPr/>
-                        </p:nvPicPr>
-                        <p:blipFill>
-                          <a:blip r:embed="rId12"/>
-                          <a:stretch>
-                            <a:fillRect/>
-                          </a:stretch>
-                        </p:blipFill>
-                        <p:spPr>
-                          <a:xfrm>
-                            <a:off x="1239681" y="3291829"/>
-                            <a:ext cx="939996" cy="838653"/>
-                          </a:xfrm>
-                          <a:prstGeom prst="rect">
-                            <a:avLst/>
-                          </a:prstGeom>
-                        </p:spPr>
-                      </p:pic>
-                    </p:oleObj>
-                  </mc:Fallback>
-                </mc:AlternateContent>
-              </a:graphicData>
-            </a:graphic>
-          </p:graphicFrame>
-          <p:cxnSp>
-            <p:nvCxnSpPr>
-              <p:cNvPr id="25" name="직선 화살표 연결선 24">
-                <a:extLst>
-                  <a:ext uri="{FF2B5EF4-FFF2-40B4-BE49-F238E27FC236}">
-                    <a16:creationId xmlns:a16="http://schemas.microsoft.com/office/drawing/2014/main" id="{4D7A2743-1EB3-7279-A55E-50E052EECFF4}"/>
-                  </a:ext>
-                </a:extLst>
-              </p:cNvPr>
-              <p:cNvCxnSpPr>
-                <a:cxnSpLocks/>
-              </p:cNvCxnSpPr>
-              <p:nvPr/>
-            </p:nvCxnSpPr>
-            <p:spPr>
-              <a:xfrm>
-                <a:off x="1194773" y="3987877"/>
-                <a:ext cx="1020918" cy="0"/>
-              </a:xfrm>
-              <a:prstGeom prst="straightConnector1">
-                <a:avLst/>
-              </a:prstGeom>
-              <a:ln>
-                <a:solidFill>
-                  <a:schemeClr val="tx1"/>
-                </a:solidFill>
-                <a:tailEnd type="triangle"/>
-              </a:ln>
-            </p:spPr>
-            <p:style>
-              <a:lnRef idx="2">
-                <a:schemeClr val="accent1"/>
-              </a:lnRef>
-              <a:fillRef idx="0">
-                <a:schemeClr val="accent1"/>
-              </a:fillRef>
-              <a:effectRef idx="1">
-                <a:schemeClr val="accent1"/>
-              </a:effectRef>
-              <a:fontRef idx="minor">
-                <a:schemeClr val="tx1"/>
-              </a:fontRef>
-            </p:style>
-          </p:cxnSp>
-        </p:grpSp>
-        <p:sp>
-          <p:nvSpPr>
-            <p:cNvPr id="26" name="TextBox 25">
-              <a:extLst>
-                <a:ext uri="{FF2B5EF4-FFF2-40B4-BE49-F238E27FC236}">
-                  <a16:creationId xmlns:a16="http://schemas.microsoft.com/office/drawing/2014/main" id="{923994BD-F94A-7C41-450E-EBDF18DFB03C}"/>
-                </a:ext>
-              </a:extLst>
-            </p:cNvPr>
-            <p:cNvSpPr txBox="1"/>
-            <p:nvPr/>
-          </p:nvSpPr>
-          <p:spPr>
-            <a:xfrm>
-              <a:off x="2452740" y="3847328"/>
-              <a:ext cx="72136" cy="107722"/>
-            </a:xfrm>
-            <a:prstGeom prst="rect">
-              <a:avLst/>
-            </a:prstGeom>
-            <a:noFill/>
-          </p:spPr>
-          <p:txBody>
-            <a:bodyPr wrap="none" lIns="0" tIns="0" rIns="0" bIns="0" rtlCol="0">
-              <a:spAutoFit/>
-            </a:bodyPr>
-            <a:lstStyle/>
-            <a:p>
-              <a:pPr algn="ctr"/>
-              <a:r>
-                <a:rPr lang="en-US" altLang="ko-KR" sz="700" b="1" dirty="0" err="1"/>
-                <a:t>n</a:t>
-              </a:r>
-              <a:r>
-                <a:rPr lang="en-US" altLang="ko-KR" sz="700" b="1" baseline="-25000" dirty="0" err="1"/>
-                <a:t>t</a:t>
-              </a:r>
-              <a:endParaRPr lang="ko-KR" altLang="en-US" sz="700" b="1" baseline="-25000" dirty="0"/>
-            </a:p>
-          </p:txBody>
-        </p:sp>
-        <p:cxnSp>
-          <p:nvCxnSpPr>
-            <p:cNvPr id="28" name="직선 화살표 연결선 27">
-              <a:extLst>
-                <a:ext uri="{FF2B5EF4-FFF2-40B4-BE49-F238E27FC236}">
-                  <a16:creationId xmlns:a16="http://schemas.microsoft.com/office/drawing/2014/main" id="{2A2D6978-618F-27AB-667E-497F46FCFAD5}"/>
-                </a:ext>
-              </a:extLst>
-            </p:cNvPr>
-            <p:cNvCxnSpPr>
-              <a:cxnSpLocks/>
-            </p:cNvCxnSpPr>
-            <p:nvPr/>
-          </p:nvCxnSpPr>
-          <p:spPr>
-            <a:xfrm>
-              <a:off x="1943584" y="3783875"/>
-              <a:ext cx="629486" cy="0"/>
-            </a:xfrm>
-            <a:prstGeom prst="straightConnector1">
-              <a:avLst/>
-            </a:prstGeom>
-            <a:ln w="9525">
-              <a:solidFill>
-                <a:schemeClr val="tx1"/>
-              </a:solidFill>
-              <a:headEnd type="triangle" w="sm" len="sm"/>
-              <a:tailEnd type="triangle" w="sm" len="sm"/>
-            </a:ln>
-          </p:spPr>
-          <p:style>
-            <a:lnRef idx="2">
-              <a:schemeClr val="accent1"/>
-            </a:lnRef>
-            <a:fillRef idx="0">
-              <a:schemeClr val="accent1"/>
-            </a:fillRef>
-            <a:effectRef idx="1">
-              <a:schemeClr val="accent1"/>
-            </a:effectRef>
-            <a:fontRef idx="minor">
+          <a:prstGeom prst="straightConnector1">
+            <a:avLst/>
+          </a:prstGeom>
+          <a:ln>
+            <a:solidFill>
               <a:schemeClr val="tx1"/>
-            </a:fontRef>
-          </p:style>
-        </p:cxnSp>
-        <p:sp>
-          <p:nvSpPr>
-            <p:cNvPr id="29" name="TextBox 28">
-              <a:extLst>
-                <a:ext uri="{FF2B5EF4-FFF2-40B4-BE49-F238E27FC236}">
-                  <a16:creationId xmlns:a16="http://schemas.microsoft.com/office/drawing/2014/main" id="{B7C00377-887B-7B53-5E7A-C388903212D4}"/>
-                </a:ext>
-              </a:extLst>
-            </p:cNvPr>
-            <p:cNvSpPr txBox="1"/>
-            <p:nvPr/>
-          </p:nvSpPr>
-          <p:spPr>
-            <a:xfrm>
-              <a:off x="2082150" y="3614384"/>
-              <a:ext cx="407298" cy="215444"/>
-            </a:xfrm>
-            <a:prstGeom prst="rect">
-              <a:avLst/>
-            </a:prstGeom>
-            <a:noFill/>
-          </p:spPr>
-          <p:txBody>
-            <a:bodyPr wrap="square" rtlCol="0">
-              <a:spAutoFit/>
-            </a:bodyPr>
-            <a:lstStyle/>
-            <a:p>
-              <a:pPr algn="ctr"/>
-              <a:r>
-                <a:rPr lang="en-US" altLang="ko-KR" sz="800"/>
-                <a:t>t</a:t>
-              </a:r>
-              <a:r>
-                <a:rPr lang="en-US" altLang="ko-KR" sz="800" baseline="-25000"/>
-                <a:t>CTN</a:t>
-              </a:r>
-              <a:endParaRPr lang="ko-KR" altLang="en-US" sz="800" baseline="-25000" dirty="0"/>
-            </a:p>
-          </p:txBody>
-        </p:sp>
-      </p:grpSp>
+            </a:solidFill>
+            <a:tailEnd type="triangle"/>
+          </a:ln>
+        </p:spPr>
+        <p:style>
+          <a:lnRef idx="2">
+            <a:schemeClr val="accent1"/>
+          </a:lnRef>
+          <a:fillRef idx="0">
+            <a:schemeClr val="accent1"/>
+          </a:fillRef>
+          <a:effectRef idx="1">
+            <a:schemeClr val="accent1"/>
+          </a:effectRef>
+          <a:fontRef idx="minor">
+            <a:schemeClr val="tx1"/>
+          </a:fontRef>
+        </p:style>
+      </p:cxnSp>
+      <p:sp>
+        <p:nvSpPr>
+          <p:cNvPr id="26" name="TextBox 25">
+            <a:extLst>
+              <a:ext uri="{FF2B5EF4-FFF2-40B4-BE49-F238E27FC236}">
+                <a16:creationId xmlns:a16="http://schemas.microsoft.com/office/drawing/2014/main" id="{923994BD-F94A-7C41-450E-EBDF18DFB03C}"/>
+              </a:ext>
+            </a:extLst>
+          </p:cNvPr>
+          <p:cNvSpPr txBox="1"/>
+          <p:nvPr/>
+        </p:nvSpPr>
+        <p:spPr>
+          <a:xfrm>
+            <a:off x="1254634" y="3660781"/>
+            <a:ext cx="72136" cy="107722"/>
+          </a:xfrm>
+          <a:prstGeom prst="rect">
+            <a:avLst/>
+          </a:prstGeom>
+          <a:noFill/>
+        </p:spPr>
+        <p:txBody>
+          <a:bodyPr wrap="none" lIns="0" tIns="0" rIns="0" bIns="0" rtlCol="0">
+            <a:spAutoFit/>
+          </a:bodyPr>
+          <a:lstStyle/>
+          <a:p>
+            <a:pPr algn="ctr"/>
+            <a:r>
+              <a:rPr lang="en-US" altLang="ko-KR" sz="700" b="1" dirty="0" err="1"/>
+              <a:t>n</a:t>
+            </a:r>
+            <a:r>
+              <a:rPr lang="en-US" altLang="ko-KR" sz="700" b="1" baseline="-25000" dirty="0" err="1"/>
+              <a:t>t</a:t>
+            </a:r>
+            <a:endParaRPr lang="ko-KR" altLang="en-US" sz="700" b="1" baseline="-25000" dirty="0"/>
+          </a:p>
+        </p:txBody>
+      </p:sp>
+      <p:cxnSp>
+        <p:nvCxnSpPr>
+          <p:cNvPr id="28" name="직선 화살표 연결선 27">
+            <a:extLst>
+              <a:ext uri="{FF2B5EF4-FFF2-40B4-BE49-F238E27FC236}">
+                <a16:creationId xmlns:a16="http://schemas.microsoft.com/office/drawing/2014/main" id="{2A2D6978-618F-27AB-667E-497F46FCFAD5}"/>
+              </a:ext>
+            </a:extLst>
+          </p:cNvPr>
+          <p:cNvCxnSpPr>
+            <a:cxnSpLocks/>
+          </p:cNvCxnSpPr>
+          <p:nvPr/>
+        </p:nvCxnSpPr>
+        <p:spPr>
+          <a:xfrm>
+            <a:off x="746316" y="3597328"/>
+            <a:ext cx="629486" cy="0"/>
+          </a:xfrm>
+          <a:prstGeom prst="straightConnector1">
+            <a:avLst/>
+          </a:prstGeom>
+          <a:ln w="9525">
+            <a:solidFill>
+              <a:schemeClr val="tx1"/>
+            </a:solidFill>
+            <a:headEnd type="triangle" w="sm" len="sm"/>
+            <a:tailEnd type="triangle" w="sm" len="sm"/>
+          </a:ln>
+        </p:spPr>
+        <p:style>
+          <a:lnRef idx="2">
+            <a:schemeClr val="accent1"/>
+          </a:lnRef>
+          <a:fillRef idx="0">
+            <a:schemeClr val="accent1"/>
+          </a:fillRef>
+          <a:effectRef idx="1">
+            <a:schemeClr val="accent1"/>
+          </a:effectRef>
+          <a:fontRef idx="minor">
+            <a:schemeClr val="tx1"/>
+          </a:fontRef>
+        </p:style>
+      </p:cxnSp>
+      <p:sp>
+        <p:nvSpPr>
+          <p:cNvPr id="29" name="TextBox 28">
+            <a:extLst>
+              <a:ext uri="{FF2B5EF4-FFF2-40B4-BE49-F238E27FC236}">
+                <a16:creationId xmlns:a16="http://schemas.microsoft.com/office/drawing/2014/main" id="{B7C00377-887B-7B53-5E7A-C388903212D4}"/>
+              </a:ext>
+            </a:extLst>
+          </p:cNvPr>
+          <p:cNvSpPr txBox="1"/>
+          <p:nvPr/>
+        </p:nvSpPr>
+        <p:spPr>
+          <a:xfrm>
+            <a:off x="879325" y="3427837"/>
+            <a:ext cx="407298" cy="215444"/>
+          </a:xfrm>
+          <a:prstGeom prst="rect">
+            <a:avLst/>
+          </a:prstGeom>
+          <a:noFill/>
+        </p:spPr>
+        <p:txBody>
+          <a:bodyPr wrap="square" rtlCol="0">
+            <a:spAutoFit/>
+          </a:bodyPr>
+          <a:lstStyle/>
+          <a:p>
+            <a:pPr algn="ctr"/>
+            <a:r>
+              <a:rPr lang="en-US" altLang="ko-KR" sz="800" dirty="0" err="1"/>
+              <a:t>t</a:t>
+            </a:r>
+            <a:r>
+              <a:rPr lang="en-US" altLang="ko-KR" sz="800" baseline="-25000" dirty="0" err="1"/>
+              <a:t>CTN</a:t>
+            </a:r>
+            <a:endParaRPr lang="ko-KR" altLang="en-US" sz="800" baseline="-25000" dirty="0"/>
+          </a:p>
+        </p:txBody>
+      </p:sp>
       <p:sp>
         <p:nvSpPr>
           <p:cNvPr id="43" name="TextBox 42">
@@ -15708,8 +15666,8 @@
         </p:nvSpPr>
         <p:spPr>
           <a:xfrm>
-            <a:off x="1769781" y="3325930"/>
-            <a:ext cx="1654145" cy="400110"/>
+            <a:off x="1364141" y="3282160"/>
+            <a:ext cx="744510" cy="523220"/>
           </a:xfrm>
           <a:prstGeom prst="rect">
             <a:avLst/>
@@ -15722,21 +15680,678 @@
           </a:bodyPr>
           <a:lstStyle/>
           <a:p>
-            <a:pPr algn="r"/>
             <a:r>
-              <a:rPr lang="en-US" altLang="ko-KR" sz="1000" dirty="0">
+              <a:rPr lang="en-US" altLang="ko-KR" sz="700" dirty="0">
                 <a:latin typeface="Arial" panose="020B0604020202020204" pitchFamily="34" charset="0"/>
                 <a:cs typeface="Arial" panose="020B0604020202020204" pitchFamily="34" charset="0"/>
               </a:rPr>
-              <a:t>Radial charge distribution modeled as [5], [6]</a:t>
+              <a:t>Radial charge distribution modeled as [6], [7]</a:t>
             </a:r>
-            <a:endParaRPr lang="ko-KR" altLang="en-US" sz="1000" dirty="0">
+            <a:endParaRPr lang="ko-KR" altLang="en-US" sz="700" dirty="0">
               <a:latin typeface="Arial" panose="020B0604020202020204" pitchFamily="34" charset="0"/>
               <a:cs typeface="Arial" panose="020B0604020202020204" pitchFamily="34" charset="0"/>
             </a:endParaRPr>
           </a:p>
         </p:txBody>
       </p:sp>
+      <p:graphicFrame>
+        <p:nvGraphicFramePr>
+          <p:cNvPr id="10" name="표 9">
+            <a:extLst>
+              <a:ext uri="{FF2B5EF4-FFF2-40B4-BE49-F238E27FC236}">
+                <a16:creationId xmlns:a16="http://schemas.microsoft.com/office/drawing/2014/main" id="{E74AC430-D25F-8BCD-984F-F8AAC25DE45B}"/>
+              </a:ext>
+            </a:extLst>
+          </p:cNvPr>
+          <p:cNvGraphicFramePr>
+            <a:graphicFrameLocks noGrp="1"/>
+          </p:cNvGraphicFramePr>
+          <p:nvPr>
+            <p:extLst>
+              <p:ext uri="{D42A27DB-BD31-4B8C-83A1-F6EECF244321}">
+                <p14:modId xmlns:p14="http://schemas.microsoft.com/office/powerpoint/2010/main" val="343717858"/>
+              </p:ext>
+            </p:extLst>
+          </p:nvPr>
+        </p:nvGraphicFramePr>
+        <p:xfrm>
+          <a:off x="2034801" y="3222965"/>
+          <a:ext cx="1335785" cy="656162"/>
+        </p:xfrm>
+        <a:graphic>
+          <a:graphicData uri="http://schemas.openxmlformats.org/drawingml/2006/table">
+            <a:tbl>
+              <a:tblPr firstRow="1" bandRow="1">
+                <a:tableStyleId>{5940675A-B579-460E-94D1-54222C63F5DA}</a:tableStyleId>
+              </a:tblPr>
+              <a:tblGrid>
+                <a:gridCol w="427459">
+                  <a:extLst>
+                    <a:ext uri="{9D8B030D-6E8A-4147-A177-3AD203B41FA5}">
+                      <a16:colId xmlns:a16="http://schemas.microsoft.com/office/drawing/2014/main" val="1036565899"/>
+                    </a:ext>
+                  </a:extLst>
+                </a:gridCol>
+                <a:gridCol w="534946">
+                  <a:extLst>
+                    <a:ext uri="{9D8B030D-6E8A-4147-A177-3AD203B41FA5}">
+                      <a16:colId xmlns:a16="http://schemas.microsoft.com/office/drawing/2014/main" val="1832300329"/>
+                    </a:ext>
+                  </a:extLst>
+                </a:gridCol>
+                <a:gridCol w="373380">
+                  <a:extLst>
+                    <a:ext uri="{9D8B030D-6E8A-4147-A177-3AD203B41FA5}">
+                      <a16:colId xmlns:a16="http://schemas.microsoft.com/office/drawing/2014/main" val="1373664809"/>
+                    </a:ext>
+                  </a:extLst>
+                </a:gridCol>
+              </a:tblGrid>
+              <a:tr h="199802">
+                <a:tc gridSpan="3">
+                  <a:txBody>
+                    <a:bodyPr/>
+                    <a:lstStyle/>
+                    <a:p>
+                      <a:pPr marL="0" marR="0" lvl="0" indent="0" algn="ctr" defTabSz="685800" rtl="0" eaLnBrk="1" fontAlgn="auto" latinLnBrk="1" hangingPunct="1">
+                        <a:lnSpc>
+                          <a:spcPct val="100000"/>
+                        </a:lnSpc>
+                        <a:spcBef>
+                          <a:spcPts val="0"/>
+                        </a:spcBef>
+                        <a:spcAft>
+                          <a:spcPts val="0"/>
+                        </a:spcAft>
+                        <a:buClrTx/>
+                        <a:buSzTx/>
+                        <a:buFontTx/>
+                        <a:buNone/>
+                        <a:tabLst/>
+                        <a:defRPr/>
+                      </a:pPr>
+                      <a:r>
+                        <a:rPr lang="en-US" altLang="ko-KR" sz="700" dirty="0">
+                          <a:latin typeface="Times New Roman" panose="02020603050405020304" pitchFamily="18" charset="0"/>
+                          <a:cs typeface="Times New Roman" panose="02020603050405020304" pitchFamily="18" charset="0"/>
+                        </a:rPr>
+                        <a:t>Trap density [6], [9]</a:t>
+                      </a:r>
+                      <a:endParaRPr lang="ko-KR" altLang="en-US" sz="700" dirty="0">
+                        <a:latin typeface="Times New Roman" panose="02020603050405020304" pitchFamily="18" charset="0"/>
+                        <a:cs typeface="Times New Roman" panose="02020603050405020304" pitchFamily="18" charset="0"/>
+                      </a:endParaRPr>
+                    </a:p>
+                  </a:txBody>
+                  <a:tcPr anchor="ctr">
+                    <a:lnL w="6350" cap="flat" cmpd="sng" algn="ctr">
+                      <a:solidFill>
+                        <a:schemeClr val="tx1"/>
+                      </a:solidFill>
+                      <a:prstDash val="solid"/>
+                      <a:round/>
+                      <a:headEnd type="none" w="med" len="med"/>
+                      <a:tailEnd type="none" w="med" len="med"/>
+                    </a:lnL>
+                    <a:lnR w="6350" cap="flat" cmpd="sng" algn="ctr">
+                      <a:solidFill>
+                        <a:schemeClr val="tx1"/>
+                      </a:solidFill>
+                      <a:prstDash val="solid"/>
+                      <a:round/>
+                      <a:headEnd type="none" w="med" len="med"/>
+                      <a:tailEnd type="none" w="med" len="med"/>
+                    </a:lnR>
+                    <a:lnT w="6350" cap="flat" cmpd="sng" algn="ctr">
+                      <a:solidFill>
+                        <a:schemeClr val="tx1"/>
+                      </a:solidFill>
+                      <a:prstDash val="solid"/>
+                      <a:round/>
+                      <a:headEnd type="none" w="med" len="med"/>
+                      <a:tailEnd type="none" w="med" len="med"/>
+                    </a:lnT>
+                    <a:lnB w="6350" cap="flat" cmpd="sng" algn="ctr">
+                      <a:solidFill>
+                        <a:schemeClr val="tx1"/>
+                      </a:solidFill>
+                      <a:prstDash val="solid"/>
+                      <a:round/>
+                      <a:headEnd type="none" w="med" len="med"/>
+                      <a:tailEnd type="none" w="med" len="med"/>
+                    </a:lnB>
+                  </a:tcPr>
+                </a:tc>
+                <a:tc hMerge="1">
+                  <a:txBody>
+                    <a:bodyPr/>
+                    <a:lstStyle/>
+                    <a:p>
+                      <a:pPr algn="ctr" latinLnBrk="1"/>
+                      <a:endParaRPr lang="ko-KR" altLang="en-US" sz="700" dirty="0">
+                        <a:latin typeface="Times New Roman" panose="02020603050405020304" pitchFamily="18" charset="0"/>
+                        <a:cs typeface="Times New Roman" panose="02020603050405020304" pitchFamily="18" charset="0"/>
+                      </a:endParaRPr>
+                    </a:p>
+                  </a:txBody>
+                  <a:tcPr anchor="ctr">
+                    <a:lnL w="6350" cap="flat" cmpd="sng" algn="ctr">
+                      <a:solidFill>
+                        <a:schemeClr val="tx1"/>
+                      </a:solidFill>
+                      <a:prstDash val="solid"/>
+                      <a:round/>
+                      <a:headEnd type="none" w="med" len="med"/>
+                      <a:tailEnd type="none" w="med" len="med"/>
+                    </a:lnL>
+                    <a:lnR w="3175" cap="flat" cmpd="sng" algn="ctr">
+                      <a:solidFill>
+                        <a:schemeClr val="bg1"/>
+                      </a:solidFill>
+                      <a:prstDash val="solid"/>
+                      <a:round/>
+                      <a:headEnd type="none" w="med" len="med"/>
+                      <a:tailEnd type="none" w="med" len="med"/>
+                    </a:lnR>
+                    <a:lnT w="6350" cap="flat" cmpd="sng" algn="ctr">
+                      <a:solidFill>
+                        <a:schemeClr val="tx1"/>
+                      </a:solidFill>
+                      <a:prstDash val="solid"/>
+                      <a:round/>
+                      <a:headEnd type="none" w="med" len="med"/>
+                      <a:tailEnd type="none" w="med" len="med"/>
+                    </a:lnT>
+                    <a:lnB w="6350" cap="flat" cmpd="sng" algn="ctr">
+                      <a:solidFill>
+                        <a:schemeClr val="tx1"/>
+                      </a:solidFill>
+                      <a:prstDash val="solid"/>
+                      <a:round/>
+                      <a:headEnd type="none" w="med" len="med"/>
+                      <a:tailEnd type="none" w="med" len="med"/>
+                    </a:lnB>
+                  </a:tcPr>
+                </a:tc>
+                <a:tc hMerge="1">
+                  <a:txBody>
+                    <a:bodyPr/>
+                    <a:lstStyle/>
+                    <a:p>
+                      <a:pPr algn="ctr" latinLnBrk="1"/>
+                      <a:endParaRPr lang="ko-KR" altLang="en-US" sz="700" dirty="0">
+                        <a:latin typeface="Times New Roman" panose="02020603050405020304" pitchFamily="18" charset="0"/>
+                        <a:cs typeface="Times New Roman" panose="02020603050405020304" pitchFamily="18" charset="0"/>
+                      </a:endParaRPr>
+                    </a:p>
+                  </a:txBody>
+                  <a:tcPr anchor="ctr">
+                    <a:lnL w="3175" cap="flat" cmpd="sng" algn="ctr">
+                      <a:solidFill>
+                        <a:schemeClr val="bg1"/>
+                      </a:solidFill>
+                      <a:prstDash val="solid"/>
+                      <a:round/>
+                      <a:headEnd type="none" w="med" len="med"/>
+                      <a:tailEnd type="none" w="med" len="med"/>
+                    </a:lnL>
+                    <a:lnR w="6350" cap="flat" cmpd="sng" algn="ctr">
+                      <a:solidFill>
+                        <a:schemeClr val="tx1"/>
+                      </a:solidFill>
+                      <a:prstDash val="solid"/>
+                      <a:round/>
+                      <a:headEnd type="none" w="med" len="med"/>
+                      <a:tailEnd type="none" w="med" len="med"/>
+                    </a:lnR>
+                    <a:lnT w="6350" cap="flat" cmpd="sng" algn="ctr">
+                      <a:solidFill>
+                        <a:schemeClr val="tx1"/>
+                      </a:solidFill>
+                      <a:prstDash val="solid"/>
+                      <a:round/>
+                      <a:headEnd type="none" w="med" len="med"/>
+                      <a:tailEnd type="none" w="med" len="med"/>
+                    </a:lnT>
+                    <a:lnB w="6350" cap="flat" cmpd="sng" algn="ctr">
+                      <a:solidFill>
+                        <a:schemeClr val="tx1"/>
+                      </a:solidFill>
+                      <a:prstDash val="solid"/>
+                      <a:round/>
+                      <a:headEnd type="none" w="med" len="med"/>
+                      <a:tailEnd type="none" w="med" len="med"/>
+                    </a:lnB>
+                  </a:tcPr>
+                </a:tc>
+                <a:extLst>
+                  <a:ext uri="{0D108BD9-81ED-4DB2-BD59-A6C34878D82A}">
+                    <a16:rowId xmlns:a16="http://schemas.microsoft.com/office/drawing/2014/main" val="2943176738"/>
+                  </a:ext>
+                </a:extLst>
+              </a:tr>
+              <a:tr h="228180">
+                <a:tc>
+                  <a:txBody>
+                    <a:bodyPr/>
+                    <a:lstStyle/>
+                    <a:p>
+                      <a:pPr algn="ctr" latinLnBrk="1"/>
+                      <a:r>
+                        <a:rPr lang="en-US" altLang="ko-KR" sz="600" dirty="0" err="1">
+                          <a:latin typeface="Times New Roman" panose="02020603050405020304" pitchFamily="18" charset="0"/>
+                          <a:cs typeface="Times New Roman" panose="02020603050405020304" pitchFamily="18" charset="0"/>
+                        </a:rPr>
+                        <a:t>n</a:t>
+                      </a:r>
+                      <a:r>
+                        <a:rPr lang="en-US" altLang="ko-KR" sz="600" baseline="-25000" dirty="0" err="1">
+                          <a:latin typeface="Times New Roman" panose="02020603050405020304" pitchFamily="18" charset="0"/>
+                          <a:cs typeface="Times New Roman" panose="02020603050405020304" pitchFamily="18" charset="0"/>
+                        </a:rPr>
+                        <a:t>t</a:t>
+                      </a:r>
+                      <a:r>
+                        <a:rPr lang="en-US" altLang="ko-KR" sz="600" baseline="-25000" dirty="0">
+                          <a:latin typeface="Times New Roman" panose="02020603050405020304" pitchFamily="18" charset="0"/>
+                          <a:cs typeface="Times New Roman" panose="02020603050405020304" pitchFamily="18" charset="0"/>
+                        </a:rPr>
+                        <a:t>, shallow</a:t>
+                      </a:r>
+                      <a:endParaRPr lang="ko-KR" altLang="en-US" sz="600" baseline="-25000" dirty="0">
+                        <a:latin typeface="Times New Roman" panose="02020603050405020304" pitchFamily="18" charset="0"/>
+                        <a:cs typeface="Times New Roman" panose="02020603050405020304" pitchFamily="18" charset="0"/>
+                      </a:endParaRPr>
+                    </a:p>
+                  </a:txBody>
+                  <a:tcPr anchor="ctr">
+                    <a:lnL w="6350" cap="flat" cmpd="sng" algn="ctr">
+                      <a:solidFill>
+                        <a:schemeClr val="tx1"/>
+                      </a:solidFill>
+                      <a:prstDash val="solid"/>
+                      <a:round/>
+                      <a:headEnd type="none" w="med" len="med"/>
+                      <a:tailEnd type="none" w="med" len="med"/>
+                    </a:lnL>
+                    <a:lnR w="6350" cap="flat" cmpd="sng" algn="ctr">
+                      <a:solidFill>
+                        <a:schemeClr val="tx1"/>
+                      </a:solidFill>
+                      <a:prstDash val="solid"/>
+                      <a:round/>
+                      <a:headEnd type="none" w="med" len="med"/>
+                      <a:tailEnd type="none" w="med" len="med"/>
+                    </a:lnR>
+                    <a:lnT w="6350" cap="flat" cmpd="sng" algn="ctr">
+                      <a:solidFill>
+                        <a:schemeClr val="tx1"/>
+                      </a:solidFill>
+                      <a:prstDash val="solid"/>
+                      <a:round/>
+                      <a:headEnd type="none" w="med" len="med"/>
+                      <a:tailEnd type="none" w="med" len="med"/>
+                    </a:lnT>
+                    <a:lnB w="6350" cap="flat" cmpd="sng" algn="ctr">
+                      <a:solidFill>
+                        <a:schemeClr val="tx1"/>
+                      </a:solidFill>
+                      <a:prstDash val="solid"/>
+                      <a:round/>
+                      <a:headEnd type="none" w="med" len="med"/>
+                      <a:tailEnd type="none" w="med" len="med"/>
+                    </a:lnB>
+                  </a:tcPr>
+                </a:tc>
+                <a:tc>
+                  <a:txBody>
+                    <a:bodyPr/>
+                    <a:lstStyle/>
+                    <a:p>
+                      <a:pPr algn="ctr" latinLnBrk="1"/>
+                      <a:r>
+                        <a:rPr lang="en-US" altLang="ko-KR" sz="700" dirty="0">
+                          <a:latin typeface="Times New Roman" panose="02020603050405020304" pitchFamily="18" charset="0"/>
+                          <a:cs typeface="Times New Roman" panose="02020603050405020304" pitchFamily="18" charset="0"/>
+                        </a:rPr>
+                        <a:t>1.15e19</a:t>
+                      </a:r>
+                      <a:endParaRPr lang="ko-KR" altLang="en-US" sz="700" dirty="0">
+                        <a:latin typeface="Times New Roman" panose="02020603050405020304" pitchFamily="18" charset="0"/>
+                        <a:cs typeface="Times New Roman" panose="02020603050405020304" pitchFamily="18" charset="0"/>
+                      </a:endParaRPr>
+                    </a:p>
+                  </a:txBody>
+                  <a:tcPr anchor="ctr">
+                    <a:lnL w="6350" cap="flat" cmpd="sng" algn="ctr">
+                      <a:solidFill>
+                        <a:schemeClr val="tx1"/>
+                      </a:solidFill>
+                      <a:prstDash val="solid"/>
+                      <a:round/>
+                      <a:headEnd type="none" w="med" len="med"/>
+                      <a:tailEnd type="none" w="med" len="med"/>
+                    </a:lnL>
+                    <a:lnR w="3175" cap="flat" cmpd="sng" algn="ctr">
+                      <a:solidFill>
+                        <a:schemeClr val="bg1"/>
+                      </a:solidFill>
+                      <a:prstDash val="solid"/>
+                      <a:round/>
+                      <a:headEnd type="none" w="med" len="med"/>
+                      <a:tailEnd type="none" w="med" len="med"/>
+                    </a:lnR>
+                    <a:lnT w="6350" cap="flat" cmpd="sng" algn="ctr">
+                      <a:solidFill>
+                        <a:schemeClr val="tx1"/>
+                      </a:solidFill>
+                      <a:prstDash val="solid"/>
+                      <a:round/>
+                      <a:headEnd type="none" w="med" len="med"/>
+                      <a:tailEnd type="none" w="med" len="med"/>
+                    </a:lnT>
+                    <a:lnB w="6350" cap="flat" cmpd="sng" algn="ctr">
+                      <a:solidFill>
+                        <a:schemeClr val="tx1"/>
+                      </a:solidFill>
+                      <a:prstDash val="solid"/>
+                      <a:round/>
+                      <a:headEnd type="none" w="med" len="med"/>
+                      <a:tailEnd type="none" w="med" len="med"/>
+                    </a:lnB>
+                  </a:tcPr>
+                </a:tc>
+                <a:tc>
+                  <a:txBody>
+                    <a:bodyPr/>
+                    <a:lstStyle/>
+                    <a:p>
+                      <a:pPr algn="ctr" latinLnBrk="1"/>
+                      <a:r>
+                        <a:rPr lang="en-US" altLang="ko-KR" sz="700" dirty="0">
+                          <a:latin typeface="Times New Roman" panose="02020603050405020304" pitchFamily="18" charset="0"/>
+                          <a:cs typeface="Times New Roman" panose="02020603050405020304" pitchFamily="18" charset="0"/>
+                        </a:rPr>
+                        <a:t>[cm</a:t>
+                      </a:r>
+                      <a:r>
+                        <a:rPr lang="en-US" altLang="ko-KR" sz="700" baseline="30000" dirty="0">
+                          <a:latin typeface="Times New Roman" panose="02020603050405020304" pitchFamily="18" charset="0"/>
+                          <a:cs typeface="Times New Roman" panose="02020603050405020304" pitchFamily="18" charset="0"/>
+                        </a:rPr>
+                        <a:t>-3</a:t>
+                      </a:r>
+                      <a:r>
+                        <a:rPr lang="en-US" altLang="ko-KR" sz="700" dirty="0">
+                          <a:latin typeface="Times New Roman" panose="02020603050405020304" pitchFamily="18" charset="0"/>
+                          <a:cs typeface="Times New Roman" panose="02020603050405020304" pitchFamily="18" charset="0"/>
+                        </a:rPr>
+                        <a:t>]</a:t>
+                      </a:r>
+                      <a:endParaRPr lang="ko-KR" altLang="en-US" sz="700" dirty="0">
+                        <a:latin typeface="Times New Roman" panose="02020603050405020304" pitchFamily="18" charset="0"/>
+                        <a:cs typeface="Times New Roman" panose="02020603050405020304" pitchFamily="18" charset="0"/>
+                      </a:endParaRPr>
+                    </a:p>
+                  </a:txBody>
+                  <a:tcPr anchor="ctr">
+                    <a:lnL w="3175" cap="flat" cmpd="sng" algn="ctr">
+                      <a:solidFill>
+                        <a:schemeClr val="bg1"/>
+                      </a:solidFill>
+                      <a:prstDash val="solid"/>
+                      <a:round/>
+                      <a:headEnd type="none" w="med" len="med"/>
+                      <a:tailEnd type="none" w="med" len="med"/>
+                    </a:lnL>
+                    <a:lnR w="6350" cap="flat" cmpd="sng" algn="ctr">
+                      <a:solidFill>
+                        <a:schemeClr val="tx1"/>
+                      </a:solidFill>
+                      <a:prstDash val="solid"/>
+                      <a:round/>
+                      <a:headEnd type="none" w="med" len="med"/>
+                      <a:tailEnd type="none" w="med" len="med"/>
+                    </a:lnR>
+                    <a:lnT w="6350" cap="flat" cmpd="sng" algn="ctr">
+                      <a:solidFill>
+                        <a:schemeClr val="tx1"/>
+                      </a:solidFill>
+                      <a:prstDash val="solid"/>
+                      <a:round/>
+                      <a:headEnd type="none" w="med" len="med"/>
+                      <a:tailEnd type="none" w="med" len="med"/>
+                    </a:lnT>
+                    <a:lnB w="6350" cap="flat" cmpd="sng" algn="ctr">
+                      <a:solidFill>
+                        <a:schemeClr val="tx1"/>
+                      </a:solidFill>
+                      <a:prstDash val="solid"/>
+                      <a:round/>
+                      <a:headEnd type="none" w="med" len="med"/>
+                      <a:tailEnd type="none" w="med" len="med"/>
+                    </a:lnB>
+                  </a:tcPr>
+                </a:tc>
+                <a:extLst>
+                  <a:ext uri="{0D108BD9-81ED-4DB2-BD59-A6C34878D82A}">
+                    <a16:rowId xmlns:a16="http://schemas.microsoft.com/office/drawing/2014/main" val="3059166257"/>
+                  </a:ext>
+                </a:extLst>
+              </a:tr>
+              <a:tr h="228180">
+                <a:tc>
+                  <a:txBody>
+                    <a:bodyPr/>
+                    <a:lstStyle/>
+                    <a:p>
+                      <a:pPr algn="ctr" latinLnBrk="1"/>
+                      <a:r>
+                        <a:rPr lang="en-US" altLang="ko-KR" sz="600" dirty="0" err="1">
+                          <a:latin typeface="Times New Roman" panose="02020603050405020304" pitchFamily="18" charset="0"/>
+                          <a:cs typeface="Times New Roman" panose="02020603050405020304" pitchFamily="18" charset="0"/>
+                        </a:rPr>
+                        <a:t>n</a:t>
+                      </a:r>
+                      <a:r>
+                        <a:rPr lang="en-US" altLang="ko-KR" sz="600" baseline="-25000" dirty="0" err="1">
+                          <a:latin typeface="Times New Roman" panose="02020603050405020304" pitchFamily="18" charset="0"/>
+                          <a:cs typeface="Times New Roman" panose="02020603050405020304" pitchFamily="18" charset="0"/>
+                        </a:rPr>
+                        <a:t>t</a:t>
+                      </a:r>
+                      <a:r>
+                        <a:rPr lang="en-US" altLang="ko-KR" sz="600" baseline="-25000" dirty="0">
+                          <a:latin typeface="Times New Roman" panose="02020603050405020304" pitchFamily="18" charset="0"/>
+                          <a:cs typeface="Times New Roman" panose="02020603050405020304" pitchFamily="18" charset="0"/>
+                        </a:rPr>
+                        <a:t>, deep</a:t>
+                      </a:r>
+                      <a:endParaRPr lang="ko-KR" altLang="en-US" sz="600" baseline="-25000" dirty="0">
+                        <a:latin typeface="Times New Roman" panose="02020603050405020304" pitchFamily="18" charset="0"/>
+                        <a:cs typeface="Times New Roman" panose="02020603050405020304" pitchFamily="18" charset="0"/>
+                      </a:endParaRPr>
+                    </a:p>
+                  </a:txBody>
+                  <a:tcPr anchor="ctr">
+                    <a:lnL w="6350" cap="flat" cmpd="sng" algn="ctr">
+                      <a:solidFill>
+                        <a:schemeClr val="tx1"/>
+                      </a:solidFill>
+                      <a:prstDash val="solid"/>
+                      <a:round/>
+                      <a:headEnd type="none" w="med" len="med"/>
+                      <a:tailEnd type="none" w="med" len="med"/>
+                    </a:lnL>
+                    <a:lnR w="6350" cap="flat" cmpd="sng" algn="ctr">
+                      <a:solidFill>
+                        <a:schemeClr val="tx1"/>
+                      </a:solidFill>
+                      <a:prstDash val="solid"/>
+                      <a:round/>
+                      <a:headEnd type="none" w="med" len="med"/>
+                      <a:tailEnd type="none" w="med" len="med"/>
+                    </a:lnR>
+                    <a:lnT w="6350" cap="flat" cmpd="sng" algn="ctr">
+                      <a:solidFill>
+                        <a:schemeClr val="tx1"/>
+                      </a:solidFill>
+                      <a:prstDash val="solid"/>
+                      <a:round/>
+                      <a:headEnd type="none" w="med" len="med"/>
+                      <a:tailEnd type="none" w="med" len="med"/>
+                    </a:lnT>
+                    <a:lnB w="6350" cap="flat" cmpd="sng" algn="ctr">
+                      <a:solidFill>
+                        <a:schemeClr val="tx1"/>
+                      </a:solidFill>
+                      <a:prstDash val="solid"/>
+                      <a:round/>
+                      <a:headEnd type="none" w="med" len="med"/>
+                      <a:tailEnd type="none" w="med" len="med"/>
+                    </a:lnB>
+                  </a:tcPr>
+                </a:tc>
+                <a:tc>
+                  <a:txBody>
+                    <a:bodyPr/>
+                    <a:lstStyle/>
+                    <a:p>
+                      <a:pPr algn="ctr" latinLnBrk="1"/>
+                      <a:r>
+                        <a:rPr lang="en-US" altLang="ko-KR" sz="700" dirty="0">
+                          <a:latin typeface="Times New Roman" panose="02020603050405020304" pitchFamily="18" charset="0"/>
+                          <a:cs typeface="Times New Roman" panose="02020603050405020304" pitchFamily="18" charset="0"/>
+                        </a:rPr>
+                        <a:t>3.5e19</a:t>
+                      </a:r>
+                      <a:endParaRPr lang="ko-KR" altLang="en-US" sz="700" dirty="0">
+                        <a:latin typeface="Times New Roman" panose="02020603050405020304" pitchFamily="18" charset="0"/>
+                        <a:cs typeface="Times New Roman" panose="02020603050405020304" pitchFamily="18" charset="0"/>
+                      </a:endParaRPr>
+                    </a:p>
+                  </a:txBody>
+                  <a:tcPr anchor="ctr">
+                    <a:lnL w="6350" cap="flat" cmpd="sng" algn="ctr">
+                      <a:solidFill>
+                        <a:schemeClr val="tx1"/>
+                      </a:solidFill>
+                      <a:prstDash val="solid"/>
+                      <a:round/>
+                      <a:headEnd type="none" w="med" len="med"/>
+                      <a:tailEnd type="none" w="med" len="med"/>
+                    </a:lnL>
+                    <a:lnR w="3175" cap="flat" cmpd="sng" algn="ctr">
+                      <a:solidFill>
+                        <a:schemeClr val="bg1"/>
+                      </a:solidFill>
+                      <a:prstDash val="solid"/>
+                      <a:round/>
+                      <a:headEnd type="none" w="med" len="med"/>
+                      <a:tailEnd type="none" w="med" len="med"/>
+                    </a:lnR>
+                    <a:lnT w="6350" cap="flat" cmpd="sng" algn="ctr">
+                      <a:solidFill>
+                        <a:schemeClr val="tx1"/>
+                      </a:solidFill>
+                      <a:prstDash val="solid"/>
+                      <a:round/>
+                      <a:headEnd type="none" w="med" len="med"/>
+                      <a:tailEnd type="none" w="med" len="med"/>
+                    </a:lnT>
+                    <a:lnB w="6350" cap="flat" cmpd="sng" algn="ctr">
+                      <a:solidFill>
+                        <a:schemeClr val="tx1"/>
+                      </a:solidFill>
+                      <a:prstDash val="solid"/>
+                      <a:round/>
+                      <a:headEnd type="none" w="med" len="med"/>
+                      <a:tailEnd type="none" w="med" len="med"/>
+                    </a:lnB>
+                  </a:tcPr>
+                </a:tc>
+                <a:tc>
+                  <a:txBody>
+                    <a:bodyPr/>
+                    <a:lstStyle/>
+                    <a:p>
+                      <a:pPr algn="ctr" latinLnBrk="1"/>
+                      <a:r>
+                        <a:rPr lang="en-US" altLang="ko-KR" sz="700" dirty="0">
+                          <a:latin typeface="Times New Roman" panose="02020603050405020304" pitchFamily="18" charset="0"/>
+                          <a:cs typeface="Times New Roman" panose="02020603050405020304" pitchFamily="18" charset="0"/>
+                        </a:rPr>
+                        <a:t>[cm</a:t>
+                      </a:r>
+                      <a:r>
+                        <a:rPr lang="en-US" altLang="ko-KR" sz="700" baseline="30000" dirty="0">
+                          <a:latin typeface="Times New Roman" panose="02020603050405020304" pitchFamily="18" charset="0"/>
+                          <a:cs typeface="Times New Roman" panose="02020603050405020304" pitchFamily="18" charset="0"/>
+                        </a:rPr>
+                        <a:t>-3</a:t>
+                      </a:r>
+                      <a:r>
+                        <a:rPr lang="en-US" altLang="ko-KR" sz="700" dirty="0">
+                          <a:latin typeface="Times New Roman" panose="02020603050405020304" pitchFamily="18" charset="0"/>
+                          <a:cs typeface="Times New Roman" panose="02020603050405020304" pitchFamily="18" charset="0"/>
+                        </a:rPr>
+                        <a:t>]</a:t>
+                      </a:r>
+                      <a:endParaRPr lang="ko-KR" altLang="en-US" sz="700" dirty="0">
+                        <a:latin typeface="Times New Roman" panose="02020603050405020304" pitchFamily="18" charset="0"/>
+                        <a:cs typeface="Times New Roman" panose="02020603050405020304" pitchFamily="18" charset="0"/>
+                      </a:endParaRPr>
+                    </a:p>
+                  </a:txBody>
+                  <a:tcPr anchor="ctr">
+                    <a:lnL w="3175" cap="flat" cmpd="sng" algn="ctr">
+                      <a:solidFill>
+                        <a:schemeClr val="bg1"/>
+                      </a:solidFill>
+                      <a:prstDash val="solid"/>
+                      <a:round/>
+                      <a:headEnd type="none" w="med" len="med"/>
+                      <a:tailEnd type="none" w="med" len="med"/>
+                    </a:lnL>
+                    <a:lnR w="6350" cap="flat" cmpd="sng" algn="ctr">
+                      <a:solidFill>
+                        <a:schemeClr val="tx1"/>
+                      </a:solidFill>
+                      <a:prstDash val="solid"/>
+                      <a:round/>
+                      <a:headEnd type="none" w="med" len="med"/>
+                      <a:tailEnd type="none" w="med" len="med"/>
+                    </a:lnR>
+                    <a:lnT w="6350" cap="flat" cmpd="sng" algn="ctr">
+                      <a:solidFill>
+                        <a:schemeClr val="tx1"/>
+                      </a:solidFill>
+                      <a:prstDash val="solid"/>
+                      <a:round/>
+                      <a:headEnd type="none" w="med" len="med"/>
+                      <a:tailEnd type="none" w="med" len="med"/>
+                    </a:lnT>
+                    <a:lnB w="6350" cap="flat" cmpd="sng" algn="ctr">
+                      <a:solidFill>
+                        <a:schemeClr val="tx1"/>
+                      </a:solidFill>
+                      <a:prstDash val="solid"/>
+                      <a:round/>
+                      <a:headEnd type="none" w="med" len="med"/>
+                      <a:tailEnd type="none" w="med" len="med"/>
+                    </a:lnB>
+                  </a:tcPr>
+                </a:tc>
+                <a:extLst>
+                  <a:ext uri="{0D108BD9-81ED-4DB2-BD59-A6C34878D82A}">
+                    <a16:rowId xmlns:a16="http://schemas.microsoft.com/office/drawing/2014/main" val="1021031779"/>
+                  </a:ext>
+                </a:extLst>
+              </a:tr>
+            </a:tbl>
+          </a:graphicData>
+        </a:graphic>
+      </p:graphicFrame>
     </p:spTree>
     <p:extLst>
       <p:ext uri="{BB962C8B-B14F-4D97-AF65-F5344CB8AC3E}">

</xml_diff>

<commit_message>
line number added, abstract modified. Editor Amoroso
</commit_message>
<xml_diff>
--- a/figures/Figures-EDL202605-manuscript.pptx
+++ b/figures/Figures-EDL202605-manuscript.pptx
@@ -208,7 +208,7 @@
           <a:p>
             <a:fld id="{AA311422-0C2E-42D7-924E-F365B5A34ABC}" type="datetimeFigureOut">
               <a:rPr lang="ko-KR" altLang="en-US" smtClean="0"/>
-              <a:t>2026-05-07</a:t>
+              <a:t>2026-05-08</a:t>
             </a:fld>
             <a:endParaRPr lang="ko-KR" altLang="en-US"/>
           </a:p>
@@ -606,7 +606,7 @@
           <a:p>
             <a:fld id="{038C53AF-CD6D-418E-B451-BA3CFECC6915}" type="datetimeFigureOut">
               <a:rPr lang="ko-KR" altLang="en-US" smtClean="0"/>
-              <a:t>2026-05-07</a:t>
+              <a:t>2026-05-08</a:t>
             </a:fld>
             <a:endParaRPr lang="ko-KR" altLang="en-US"/>
           </a:p>
@@ -776,7 +776,7 @@
           <a:p>
             <a:fld id="{038C53AF-CD6D-418E-B451-BA3CFECC6915}" type="datetimeFigureOut">
               <a:rPr lang="ko-KR" altLang="en-US" smtClean="0"/>
-              <a:t>2026-05-07</a:t>
+              <a:t>2026-05-08</a:t>
             </a:fld>
             <a:endParaRPr lang="ko-KR" altLang="en-US"/>
           </a:p>
@@ -956,7 +956,7 @@
           <a:p>
             <a:fld id="{038C53AF-CD6D-418E-B451-BA3CFECC6915}" type="datetimeFigureOut">
               <a:rPr lang="ko-KR" altLang="en-US" smtClean="0"/>
-              <a:t>2026-05-07</a:t>
+              <a:t>2026-05-08</a:t>
             </a:fld>
             <a:endParaRPr lang="ko-KR" altLang="en-US"/>
           </a:p>
@@ -1126,7 +1126,7 @@
           <a:p>
             <a:fld id="{038C53AF-CD6D-418E-B451-BA3CFECC6915}" type="datetimeFigureOut">
               <a:rPr lang="ko-KR" altLang="en-US" smtClean="0"/>
-              <a:t>2026-05-07</a:t>
+              <a:t>2026-05-08</a:t>
             </a:fld>
             <a:endParaRPr lang="ko-KR" altLang="en-US"/>
           </a:p>
@@ -1372,7 +1372,7 @@
           <a:p>
             <a:fld id="{038C53AF-CD6D-418E-B451-BA3CFECC6915}" type="datetimeFigureOut">
               <a:rPr lang="ko-KR" altLang="en-US" smtClean="0"/>
-              <a:t>2026-05-07</a:t>
+              <a:t>2026-05-08</a:t>
             </a:fld>
             <a:endParaRPr lang="ko-KR" altLang="en-US"/>
           </a:p>
@@ -1604,7 +1604,7 @@
           <a:p>
             <a:fld id="{038C53AF-CD6D-418E-B451-BA3CFECC6915}" type="datetimeFigureOut">
               <a:rPr lang="ko-KR" altLang="en-US" smtClean="0"/>
-              <a:t>2026-05-07</a:t>
+              <a:t>2026-05-08</a:t>
             </a:fld>
             <a:endParaRPr lang="ko-KR" altLang="en-US"/>
           </a:p>
@@ -1971,7 +1971,7 @@
           <a:p>
             <a:fld id="{038C53AF-CD6D-418E-B451-BA3CFECC6915}" type="datetimeFigureOut">
               <a:rPr lang="ko-KR" altLang="en-US" smtClean="0"/>
-              <a:t>2026-05-07</a:t>
+              <a:t>2026-05-08</a:t>
             </a:fld>
             <a:endParaRPr lang="ko-KR" altLang="en-US"/>
           </a:p>
@@ -2089,7 +2089,7 @@
           <a:p>
             <a:fld id="{038C53AF-CD6D-418E-B451-BA3CFECC6915}" type="datetimeFigureOut">
               <a:rPr lang="ko-KR" altLang="en-US" smtClean="0"/>
-              <a:t>2026-05-07</a:t>
+              <a:t>2026-05-08</a:t>
             </a:fld>
             <a:endParaRPr lang="ko-KR" altLang="en-US"/>
           </a:p>
@@ -2184,7 +2184,7 @@
           <a:p>
             <a:fld id="{038C53AF-CD6D-418E-B451-BA3CFECC6915}" type="datetimeFigureOut">
               <a:rPr lang="ko-KR" altLang="en-US" smtClean="0"/>
-              <a:t>2026-05-07</a:t>
+              <a:t>2026-05-08</a:t>
             </a:fld>
             <a:endParaRPr lang="ko-KR" altLang="en-US"/>
           </a:p>
@@ -2461,7 +2461,7 @@
           <a:p>
             <a:fld id="{038C53AF-CD6D-418E-B451-BA3CFECC6915}" type="datetimeFigureOut">
               <a:rPr lang="ko-KR" altLang="en-US" smtClean="0"/>
-              <a:t>2026-05-07</a:t>
+              <a:t>2026-05-08</a:t>
             </a:fld>
             <a:endParaRPr lang="ko-KR" altLang="en-US"/>
           </a:p>
@@ -2718,7 +2718,7 @@
           <a:p>
             <a:fld id="{038C53AF-CD6D-418E-B451-BA3CFECC6915}" type="datetimeFigureOut">
               <a:rPr lang="ko-KR" altLang="en-US" smtClean="0"/>
-              <a:t>2026-05-07</a:t>
+              <a:t>2026-05-08</a:t>
             </a:fld>
             <a:endParaRPr lang="ko-KR" altLang="en-US"/>
           </a:p>
@@ -2931,7 +2931,7 @@
           <a:p>
             <a:fld id="{038C53AF-CD6D-418E-B451-BA3CFECC6915}" type="datetimeFigureOut">
               <a:rPr lang="ko-KR" altLang="en-US" smtClean="0"/>
-              <a:t>2026-05-07</a:t>
+              <a:t>2026-05-08</a:t>
             </a:fld>
             <a:endParaRPr lang="ko-KR" altLang="en-US"/>
           </a:p>
@@ -11735,14 +11735,14 @@
           <p:nvPr>
             <p:extLst>
               <p:ext uri="{D42A27DB-BD31-4B8C-83A1-F6EECF244321}">
-                <p14:modId xmlns:p14="http://schemas.microsoft.com/office/powerpoint/2010/main" val="908189444"/>
+                <p14:modId xmlns:p14="http://schemas.microsoft.com/office/powerpoint/2010/main" val="301811885"/>
               </p:ext>
             </p:extLst>
           </p:nvPr>
         </p:nvGraphicFramePr>
         <p:xfrm>
           <a:off x="2266217" y="4045272"/>
-          <a:ext cx="1104369" cy="1112522"/>
+          <a:ext cx="1104369" cy="929640"/>
         </p:xfrm>
         <a:graphic>
           <a:graphicData uri="http://schemas.openxmlformats.org/drawingml/2006/table">
@@ -11773,7 +11773,7 @@
                   </a:extLst>
                 </a:gridCol>
               </a:tblGrid>
-              <a:tr h="199802">
+              <a:tr h="175806">
                 <a:tc gridSpan="3">
                   <a:txBody>
                     <a:bodyPr/>
@@ -11956,7 +11956,7 @@
                   </a:ext>
                 </a:extLst>
               </a:tr>
-              <a:tr h="228180">
+              <a:tr h="175806">
                 <a:tc>
                   <a:txBody>
                     <a:bodyPr/>
@@ -12029,13 +12029,13 @@
                     <a:p>
                       <a:pPr algn="ctr" latinLnBrk="1"/>
                       <a:r>
-                        <a:rPr lang="en-US" altLang="ko-KR" sz="700" dirty="0">
+                        <a:rPr lang="en-US" altLang="ko-KR" sz="600" dirty="0">
                           <a:latin typeface="Times New Roman" panose="02020603050405020304" pitchFamily="18" charset="0"/>
                           <a:cs typeface="Times New Roman" panose="02020603050405020304" pitchFamily="18" charset="0"/>
                         </a:rPr>
                         <a:t>0.84</a:t>
                       </a:r>
-                      <a:endParaRPr lang="ko-KR" altLang="en-US" sz="700" dirty="0">
+                      <a:endParaRPr lang="ko-KR" altLang="en-US" sz="600" dirty="0">
                         <a:latin typeface="Times New Roman" panose="02020603050405020304" pitchFamily="18" charset="0"/>
                         <a:cs typeface="Times New Roman" panose="02020603050405020304" pitchFamily="18" charset="0"/>
                       </a:endParaRPr>
@@ -12087,13 +12087,13 @@
                     <a:p>
                       <a:pPr algn="ctr" latinLnBrk="1"/>
                       <a:r>
-                        <a:rPr lang="en-US" altLang="ko-KR" sz="700" dirty="0">
+                        <a:rPr lang="en-US" altLang="ko-KR" sz="600" dirty="0">
                           <a:latin typeface="Times New Roman" panose="02020603050405020304" pitchFamily="18" charset="0"/>
                           <a:cs typeface="Times New Roman" panose="02020603050405020304" pitchFamily="18" charset="0"/>
                         </a:rPr>
                         <a:t>[eV]</a:t>
                       </a:r>
-                      <a:endParaRPr lang="ko-KR" altLang="en-US" sz="700" dirty="0">
+                      <a:endParaRPr lang="ko-KR" altLang="en-US" sz="600" dirty="0">
                         <a:latin typeface="Times New Roman" panose="02020603050405020304" pitchFamily="18" charset="0"/>
                         <a:cs typeface="Times New Roman" panose="02020603050405020304" pitchFamily="18" charset="0"/>
                       </a:endParaRPr>
@@ -12144,7 +12144,7 @@
                   </a:ext>
                 </a:extLst>
               </a:tr>
-              <a:tr h="228180">
+              <a:tr h="175806">
                 <a:tc>
                   <a:txBody>
                     <a:bodyPr/>
@@ -12224,13 +12224,13 @@
                     <a:p>
                       <a:pPr algn="ctr" latinLnBrk="1"/>
                       <a:r>
-                        <a:rPr lang="en-US" altLang="ko-KR" sz="700" dirty="0">
+                        <a:rPr lang="en-US" altLang="ko-KR" sz="600" dirty="0">
                           <a:latin typeface="Times New Roman" panose="02020603050405020304" pitchFamily="18" charset="0"/>
                           <a:cs typeface="Times New Roman" panose="02020603050405020304" pitchFamily="18" charset="0"/>
                         </a:rPr>
                         <a:t>0.2</a:t>
                       </a:r>
-                      <a:endParaRPr lang="ko-KR" altLang="en-US" sz="700" dirty="0">
+                      <a:endParaRPr lang="ko-KR" altLang="en-US" sz="600" dirty="0">
                         <a:latin typeface="Times New Roman" panose="02020603050405020304" pitchFamily="18" charset="0"/>
                         <a:cs typeface="Times New Roman" panose="02020603050405020304" pitchFamily="18" charset="0"/>
                       </a:endParaRPr>
@@ -12282,13 +12282,13 @@
                     <a:p>
                       <a:pPr algn="ctr" latinLnBrk="1"/>
                       <a:r>
-                        <a:rPr lang="en-US" altLang="ko-KR" sz="700" baseline="0" dirty="0">
+                        <a:rPr lang="en-US" altLang="ko-KR" sz="600" baseline="0" dirty="0">
                           <a:latin typeface="Times New Roman" panose="02020603050405020304" pitchFamily="18" charset="0"/>
                           <a:cs typeface="Times New Roman" panose="02020603050405020304" pitchFamily="18" charset="0"/>
                         </a:rPr>
                         <a:t>[eV]</a:t>
                       </a:r>
-                      <a:endParaRPr lang="ko-KR" altLang="en-US" sz="700" baseline="0" dirty="0">
+                      <a:endParaRPr lang="ko-KR" altLang="en-US" sz="600" baseline="0" dirty="0">
                         <a:latin typeface="Times New Roman" panose="02020603050405020304" pitchFamily="18" charset="0"/>
                         <a:cs typeface="Times New Roman" panose="02020603050405020304" pitchFamily="18" charset="0"/>
                       </a:endParaRPr>
@@ -12339,7 +12339,7 @@
                   </a:ext>
                 </a:extLst>
               </a:tr>
-              <a:tr h="228180">
+              <a:tr h="175806">
                 <a:tc>
                   <a:txBody>
                     <a:bodyPr/>
@@ -12412,13 +12412,13 @@
                     <a:p>
                       <a:pPr algn="ctr" latinLnBrk="1"/>
                       <a:r>
-                        <a:rPr lang="en-US" altLang="ko-KR" sz="700" dirty="0">
+                        <a:rPr lang="en-US" altLang="ko-KR" sz="600" dirty="0">
                           <a:latin typeface="Times New Roman" panose="02020603050405020304" pitchFamily="18" charset="0"/>
                           <a:cs typeface="Times New Roman" panose="02020603050405020304" pitchFamily="18" charset="0"/>
                         </a:rPr>
                         <a:t>1.8</a:t>
                       </a:r>
-                      <a:endParaRPr lang="ko-KR" altLang="en-US" sz="700" dirty="0">
+                      <a:endParaRPr lang="ko-KR" altLang="en-US" sz="600" dirty="0">
                         <a:latin typeface="Times New Roman" panose="02020603050405020304" pitchFamily="18" charset="0"/>
                         <a:cs typeface="Times New Roman" panose="02020603050405020304" pitchFamily="18" charset="0"/>
                       </a:endParaRPr>
@@ -12470,13 +12470,13 @@
                     <a:p>
                       <a:pPr algn="ctr" latinLnBrk="1"/>
                       <a:r>
-                        <a:rPr lang="en-US" altLang="ko-KR" sz="700" baseline="0">
+                        <a:rPr lang="en-US" altLang="ko-KR" sz="600" baseline="0" dirty="0">
                           <a:latin typeface="Times New Roman" panose="02020603050405020304" pitchFamily="18" charset="0"/>
                           <a:cs typeface="Times New Roman" panose="02020603050405020304" pitchFamily="18" charset="0"/>
                         </a:rPr>
                         <a:t>[eV]</a:t>
                       </a:r>
-                      <a:endParaRPr lang="ko-KR" altLang="en-US" sz="700" baseline="0" dirty="0">
+                      <a:endParaRPr lang="ko-KR" altLang="en-US" sz="600" baseline="0" dirty="0">
                         <a:latin typeface="Times New Roman" panose="02020603050405020304" pitchFamily="18" charset="0"/>
                         <a:cs typeface="Times New Roman" panose="02020603050405020304" pitchFamily="18" charset="0"/>
                       </a:endParaRPr>
@@ -12527,7 +12527,7 @@
                   </a:ext>
                 </a:extLst>
               </a:tr>
-              <a:tr h="228180">
+              <a:tr h="175806">
                 <a:tc>
                   <a:txBody>
                     <a:bodyPr/>
@@ -12607,13 +12607,13 @@
                     <a:p>
                       <a:pPr algn="ctr" latinLnBrk="1"/>
                       <a:r>
-                        <a:rPr lang="en-US" altLang="ko-KR" sz="700" dirty="0">
+                        <a:rPr lang="en-US" altLang="ko-KR" sz="600" dirty="0">
                           <a:latin typeface="Times New Roman" panose="02020603050405020304" pitchFamily="18" charset="0"/>
                           <a:cs typeface="Times New Roman" panose="02020603050405020304" pitchFamily="18" charset="0"/>
                         </a:rPr>
                         <a:t>-</a:t>
                       </a:r>
-                      <a:endParaRPr lang="ko-KR" altLang="en-US" sz="700" dirty="0">
+                      <a:endParaRPr lang="ko-KR" altLang="en-US" sz="600" dirty="0">
                         <a:latin typeface="Times New Roman" panose="02020603050405020304" pitchFamily="18" charset="0"/>
                         <a:cs typeface="Times New Roman" panose="02020603050405020304" pitchFamily="18" charset="0"/>
                       </a:endParaRPr>
@@ -12665,13 +12665,13 @@
                     <a:p>
                       <a:pPr algn="ctr" latinLnBrk="1"/>
                       <a:r>
-                        <a:rPr lang="en-US" altLang="ko-KR" sz="700" baseline="0" dirty="0">
+                        <a:rPr lang="en-US" altLang="ko-KR" sz="600" baseline="0" dirty="0">
                           <a:latin typeface="Times New Roman" panose="02020603050405020304" pitchFamily="18" charset="0"/>
                           <a:cs typeface="Times New Roman" panose="02020603050405020304" pitchFamily="18" charset="0"/>
                         </a:rPr>
                         <a:t>[eV]</a:t>
                       </a:r>
-                      <a:endParaRPr lang="ko-KR" altLang="en-US" sz="700" baseline="0" dirty="0">
+                      <a:endParaRPr lang="ko-KR" altLang="en-US" sz="600" baseline="0" dirty="0">
                         <a:latin typeface="Times New Roman" panose="02020603050405020304" pitchFamily="18" charset="0"/>
                         <a:cs typeface="Times New Roman" panose="02020603050405020304" pitchFamily="18" charset="0"/>
                       </a:endParaRPr>
@@ -13047,7 +13047,7 @@
           <p:nvPr>
             <p:extLst>
               <p:ext uri="{D42A27DB-BD31-4B8C-83A1-F6EECF244321}">
-                <p14:modId xmlns:p14="http://schemas.microsoft.com/office/powerpoint/2010/main" val="1789443614"/>
+                <p14:modId xmlns:p14="http://schemas.microsoft.com/office/powerpoint/2010/main" val="4059224792"/>
               </p:ext>
             </p:extLst>
           </p:nvPr>
@@ -13960,14 +13960,14 @@
           <p:nvPr>
             <p:extLst>
               <p:ext uri="{D42A27DB-BD31-4B8C-83A1-F6EECF244321}">
-                <p14:modId xmlns:p14="http://schemas.microsoft.com/office/powerpoint/2010/main" val="3177278495"/>
+                <p14:modId xmlns:p14="http://schemas.microsoft.com/office/powerpoint/2010/main" val="2942027410"/>
               </p:ext>
             </p:extLst>
           </p:nvPr>
         </p:nvGraphicFramePr>
         <p:xfrm>
           <a:off x="684634" y="4048576"/>
-          <a:ext cx="1489020" cy="1112520"/>
+          <a:ext cx="1489020" cy="929640"/>
         </p:xfrm>
         <a:graphic>
           <a:graphicData uri="http://schemas.openxmlformats.org/drawingml/2006/table">
@@ -14977,194 +14977,6 @@
                 <a:extLst>
                   <a:ext uri="{0D108BD9-81ED-4DB2-BD59-A6C34878D82A}">
                     <a16:rowId xmlns:a16="http://schemas.microsoft.com/office/drawing/2014/main" val="2033812994"/>
-                  </a:ext>
-                </a:extLst>
-              </a:tr>
-              <a:tr h="157897">
-                <a:tc>
-                  <a:txBody>
-                    <a:bodyPr/>
-                    <a:lstStyle/>
-                    <a:p>
-                      <a:pPr algn="ctr" latinLnBrk="1"/>
-                      <a:r>
-                        <a:rPr lang="en-US" altLang="ko-KR" sz="600" baseline="0" dirty="0" err="1">
-                          <a:latin typeface="Times New Roman" panose="02020603050405020304" pitchFamily="18" charset="0"/>
-                          <a:cs typeface="Times New Roman" panose="02020603050405020304" pitchFamily="18" charset="0"/>
-                        </a:rPr>
-                        <a:t>ΔV</a:t>
-                      </a:r>
-                      <a:r>
-                        <a:rPr lang="en-US" altLang="ko-KR" sz="600" baseline="-25000" dirty="0" err="1">
-                          <a:latin typeface="Times New Roman" panose="02020603050405020304" pitchFamily="18" charset="0"/>
-                          <a:cs typeface="Times New Roman" panose="02020603050405020304" pitchFamily="18" charset="0"/>
-                        </a:rPr>
-                        <a:t>t</a:t>
-                      </a:r>
-                      <a:endParaRPr lang="ko-KR" altLang="en-US" sz="600" baseline="-25000" dirty="0">
-                        <a:latin typeface="Times New Roman" panose="02020603050405020304" pitchFamily="18" charset="0"/>
-                        <a:cs typeface="Times New Roman" panose="02020603050405020304" pitchFamily="18" charset="0"/>
-                      </a:endParaRPr>
-                    </a:p>
-                  </a:txBody>
-                  <a:tcPr anchor="ctr">
-                    <a:lnL w="6350" cap="flat" cmpd="sng" algn="ctr">
-                      <a:solidFill>
-                        <a:schemeClr val="tx1"/>
-                      </a:solidFill>
-                      <a:prstDash val="solid"/>
-                      <a:round/>
-                      <a:headEnd type="none" w="med" len="med"/>
-                      <a:tailEnd type="none" w="med" len="med"/>
-                    </a:lnL>
-                    <a:lnR w="6350" cap="flat" cmpd="sng" algn="ctr">
-                      <a:solidFill>
-                        <a:schemeClr val="tx1"/>
-                      </a:solidFill>
-                      <a:prstDash val="solid"/>
-                      <a:round/>
-                      <a:headEnd type="none" w="med" len="med"/>
-                      <a:tailEnd type="none" w="med" len="med"/>
-                    </a:lnR>
-                    <a:lnT w="6350" cap="flat" cmpd="sng" algn="ctr">
-                      <a:solidFill>
-                        <a:schemeClr val="tx1"/>
-                      </a:solidFill>
-                      <a:prstDash val="solid"/>
-                      <a:round/>
-                      <a:headEnd type="none" w="med" len="med"/>
-                      <a:tailEnd type="none" w="med" len="med"/>
-                    </a:lnT>
-                    <a:lnB w="6350" cap="flat" cmpd="sng" algn="ctr">
-                      <a:solidFill>
-                        <a:schemeClr val="tx1"/>
-                      </a:solidFill>
-                      <a:prstDash val="solid"/>
-                      <a:round/>
-                      <a:headEnd type="none" w="med" len="med"/>
-                      <a:tailEnd type="none" w="med" len="med"/>
-                    </a:lnB>
-                  </a:tcPr>
-                </a:tc>
-                <a:tc>
-                  <a:txBody>
-                    <a:bodyPr/>
-                    <a:lstStyle/>
-                    <a:p>
-                      <a:pPr algn="ctr" latinLnBrk="1"/>
-                      <a:r>
-                        <a:rPr lang="en-US" altLang="ko-KR" sz="600" dirty="0">
-                          <a:latin typeface="Times New Roman" panose="02020603050405020304" pitchFamily="18" charset="0"/>
-                          <a:cs typeface="Times New Roman" panose="02020603050405020304" pitchFamily="18" charset="0"/>
-                        </a:rPr>
-                        <a:t>1.8</a:t>
-                      </a:r>
-                      <a:endParaRPr lang="ko-KR" altLang="en-US" sz="600" dirty="0">
-                        <a:latin typeface="Times New Roman" panose="02020603050405020304" pitchFamily="18" charset="0"/>
-                        <a:cs typeface="Times New Roman" panose="02020603050405020304" pitchFamily="18" charset="0"/>
-                      </a:endParaRPr>
-                    </a:p>
-                  </a:txBody>
-                  <a:tcPr anchor="ctr">
-                    <a:lnL w="6350" cap="flat" cmpd="sng" algn="ctr">
-                      <a:solidFill>
-                        <a:schemeClr val="tx1"/>
-                      </a:solidFill>
-                      <a:prstDash val="solid"/>
-                      <a:round/>
-                      <a:headEnd type="none" w="med" len="med"/>
-                      <a:tailEnd type="none" w="med" len="med"/>
-                    </a:lnL>
-                    <a:lnR w="3175" cap="flat" cmpd="sng" algn="ctr">
-                      <a:solidFill>
-                        <a:schemeClr val="bg1"/>
-                      </a:solidFill>
-                      <a:prstDash val="solid"/>
-                      <a:round/>
-                      <a:headEnd type="none" w="med" len="med"/>
-                      <a:tailEnd type="none" w="med" len="med"/>
-                    </a:lnR>
-                    <a:lnT w="6350" cap="flat" cmpd="sng" algn="ctr">
-                      <a:solidFill>
-                        <a:schemeClr val="tx1"/>
-                      </a:solidFill>
-                      <a:prstDash val="solid"/>
-                      <a:round/>
-                      <a:headEnd type="none" w="med" len="med"/>
-                      <a:tailEnd type="none" w="med" len="med"/>
-                    </a:lnT>
-                    <a:lnB w="6350" cap="flat" cmpd="sng" algn="ctr">
-                      <a:solidFill>
-                        <a:schemeClr val="tx1"/>
-                      </a:solidFill>
-                      <a:prstDash val="solid"/>
-                      <a:round/>
-                      <a:headEnd type="none" w="med" len="med"/>
-                      <a:tailEnd type="none" w="med" len="med"/>
-                    </a:lnB>
-                  </a:tcPr>
-                </a:tc>
-                <a:tc>
-                  <a:txBody>
-                    <a:bodyPr/>
-                    <a:lstStyle/>
-                    <a:p>
-                      <a:pPr algn="ctr" latinLnBrk="1"/>
-                      <a:r>
-                        <a:rPr lang="en-US" altLang="ko-KR" sz="600" baseline="0" dirty="0">
-                          <a:latin typeface="Times New Roman" panose="02020603050405020304" pitchFamily="18" charset="0"/>
-                          <a:cs typeface="Times New Roman" panose="02020603050405020304" pitchFamily="18" charset="0"/>
-                        </a:rPr>
-                        <a:t>[V]</a:t>
-                      </a:r>
-                      <a:endParaRPr lang="ko-KR" altLang="en-US" sz="600" baseline="0" dirty="0">
-                        <a:latin typeface="Times New Roman" panose="02020603050405020304" pitchFamily="18" charset="0"/>
-                        <a:cs typeface="Times New Roman" panose="02020603050405020304" pitchFamily="18" charset="0"/>
-                      </a:endParaRPr>
-                    </a:p>
-                  </a:txBody>
-                  <a:tcPr anchor="ctr">
-                    <a:lnL w="3175" cap="flat" cmpd="sng" algn="ctr">
-                      <a:solidFill>
-                        <a:schemeClr val="bg1"/>
-                      </a:solidFill>
-                      <a:prstDash val="solid"/>
-                      <a:round/>
-                      <a:headEnd type="none" w="med" len="med"/>
-                      <a:tailEnd type="none" w="med" len="med"/>
-                    </a:lnL>
-                    <a:lnR w="6350" cap="flat" cmpd="sng" algn="ctr">
-                      <a:solidFill>
-                        <a:schemeClr val="tx1"/>
-                      </a:solidFill>
-                      <a:prstDash val="solid"/>
-                      <a:round/>
-                      <a:headEnd type="none" w="med" len="med"/>
-                      <a:tailEnd type="none" w="med" len="med"/>
-                    </a:lnR>
-                    <a:lnT w="6350" cap="flat" cmpd="sng" algn="ctr">
-                      <a:solidFill>
-                        <a:schemeClr val="tx1"/>
-                      </a:solidFill>
-                      <a:prstDash val="solid"/>
-                      <a:round/>
-                      <a:headEnd type="none" w="med" len="med"/>
-                      <a:tailEnd type="none" w="med" len="med"/>
-                    </a:lnT>
-                    <a:lnB w="6350" cap="flat" cmpd="sng" algn="ctr">
-                      <a:solidFill>
-                        <a:schemeClr val="tx1"/>
-                      </a:solidFill>
-                      <a:prstDash val="solid"/>
-                      <a:round/>
-                      <a:headEnd type="none" w="med" len="med"/>
-                      <a:tailEnd type="none" w="med" len="med"/>
-                    </a:lnB>
-                  </a:tcPr>
-                </a:tc>
-                <a:extLst>
-                  <a:ext uri="{0D108BD9-81ED-4DB2-BD59-A6C34878D82A}">
-                    <a16:rowId xmlns:a16="http://schemas.microsoft.com/office/drawing/2014/main" val="4294336834"/>
                   </a:ext>
                 </a:extLst>
               </a:tr>
@@ -15433,7 +15245,7 @@
           <p:nvPr>
             <p:extLst>
               <p:ext uri="{D42A27DB-BD31-4B8C-83A1-F6EECF244321}">
-                <p14:modId xmlns:p14="http://schemas.microsoft.com/office/powerpoint/2010/main" val="2023929375"/>
+                <p14:modId xmlns:p14="http://schemas.microsoft.com/office/powerpoint/2010/main" val="2755199149"/>
               </p:ext>
             </p:extLst>
           </p:nvPr>
@@ -15709,14 +15521,14 @@
           <p:nvPr>
             <p:extLst>
               <p:ext uri="{D42A27DB-BD31-4B8C-83A1-F6EECF244321}">
-                <p14:modId xmlns:p14="http://schemas.microsoft.com/office/powerpoint/2010/main" val="343717858"/>
+                <p14:modId xmlns:p14="http://schemas.microsoft.com/office/powerpoint/2010/main" val="3994320999"/>
               </p:ext>
             </p:extLst>
           </p:nvPr>
         </p:nvGraphicFramePr>
         <p:xfrm>
-          <a:off x="2034801" y="3222965"/>
-          <a:ext cx="1335785" cy="656162"/>
+          <a:off x="2034801" y="3303268"/>
+          <a:ext cx="1335785" cy="563880"/>
         </p:xfrm>
         <a:graphic>
           <a:graphicData uri="http://schemas.openxmlformats.org/drawingml/2006/table">
@@ -15747,7 +15559,7 @@
                   </a:extLst>
                 </a:gridCol>
               </a:tblGrid>
-              <a:tr h="199802">
+              <a:tr h="181679">
                 <a:tc gridSpan="3">
                   <a:txBody>
                     <a:bodyPr/>
@@ -15930,7 +15742,7 @@
                   </a:ext>
                 </a:extLst>
               </a:tr>
-              <a:tr h="228180">
+              <a:tr h="173968">
                 <a:tc>
                   <a:txBody>
                     <a:bodyPr/>
@@ -16010,13 +15822,13 @@
                     <a:p>
                       <a:pPr algn="ctr" latinLnBrk="1"/>
                       <a:r>
-                        <a:rPr lang="en-US" altLang="ko-KR" sz="700" dirty="0">
+                        <a:rPr lang="en-US" altLang="ko-KR" sz="600" dirty="0">
                           <a:latin typeface="Times New Roman" panose="02020603050405020304" pitchFamily="18" charset="0"/>
                           <a:cs typeface="Times New Roman" panose="02020603050405020304" pitchFamily="18" charset="0"/>
                         </a:rPr>
                         <a:t>1.15e19</a:t>
                       </a:r>
-                      <a:endParaRPr lang="ko-KR" altLang="en-US" sz="700" dirty="0">
+                      <a:endParaRPr lang="ko-KR" altLang="en-US" sz="600" dirty="0">
                         <a:latin typeface="Times New Roman" panose="02020603050405020304" pitchFamily="18" charset="0"/>
                         <a:cs typeface="Times New Roman" panose="02020603050405020304" pitchFamily="18" charset="0"/>
                       </a:endParaRPr>
@@ -16068,27 +15880,27 @@
                     <a:p>
                       <a:pPr algn="ctr" latinLnBrk="1"/>
                       <a:r>
-                        <a:rPr lang="en-US" altLang="ko-KR" sz="700" dirty="0">
+                        <a:rPr lang="en-US" altLang="ko-KR" sz="600" dirty="0">
                           <a:latin typeface="Times New Roman" panose="02020603050405020304" pitchFamily="18" charset="0"/>
                           <a:cs typeface="Times New Roman" panose="02020603050405020304" pitchFamily="18" charset="0"/>
                         </a:rPr>
                         <a:t>[cm</a:t>
                       </a:r>
                       <a:r>
-                        <a:rPr lang="en-US" altLang="ko-KR" sz="700" baseline="30000" dirty="0">
+                        <a:rPr lang="en-US" altLang="ko-KR" sz="600" baseline="30000" dirty="0">
                           <a:latin typeface="Times New Roman" panose="02020603050405020304" pitchFamily="18" charset="0"/>
                           <a:cs typeface="Times New Roman" panose="02020603050405020304" pitchFamily="18" charset="0"/>
                         </a:rPr>
                         <a:t>-3</a:t>
                       </a:r>
                       <a:r>
-                        <a:rPr lang="en-US" altLang="ko-KR" sz="700" dirty="0">
+                        <a:rPr lang="en-US" altLang="ko-KR" sz="600" dirty="0">
                           <a:latin typeface="Times New Roman" panose="02020603050405020304" pitchFamily="18" charset="0"/>
                           <a:cs typeface="Times New Roman" panose="02020603050405020304" pitchFamily="18" charset="0"/>
                         </a:rPr>
                         <a:t>]</a:t>
                       </a:r>
-                      <a:endParaRPr lang="ko-KR" altLang="en-US" sz="700" dirty="0">
+                      <a:endParaRPr lang="ko-KR" altLang="en-US" sz="600" dirty="0">
                         <a:latin typeface="Times New Roman" panose="02020603050405020304" pitchFamily="18" charset="0"/>
                         <a:cs typeface="Times New Roman" panose="02020603050405020304" pitchFamily="18" charset="0"/>
                       </a:endParaRPr>
@@ -16139,7 +15951,7 @@
                   </a:ext>
                 </a:extLst>
               </a:tr>
-              <a:tr h="228180">
+              <a:tr h="173968">
                 <a:tc>
                   <a:txBody>
                     <a:bodyPr/>
@@ -16219,13 +16031,13 @@
                     <a:p>
                       <a:pPr algn="ctr" latinLnBrk="1"/>
                       <a:r>
-                        <a:rPr lang="en-US" altLang="ko-KR" sz="700" dirty="0">
+                        <a:rPr lang="en-US" altLang="ko-KR" sz="600" dirty="0">
                           <a:latin typeface="Times New Roman" panose="02020603050405020304" pitchFamily="18" charset="0"/>
                           <a:cs typeface="Times New Roman" panose="02020603050405020304" pitchFamily="18" charset="0"/>
                         </a:rPr>
                         <a:t>3.5e19</a:t>
                       </a:r>
-                      <a:endParaRPr lang="ko-KR" altLang="en-US" sz="700" dirty="0">
+                      <a:endParaRPr lang="ko-KR" altLang="en-US" sz="600" dirty="0">
                         <a:latin typeface="Times New Roman" panose="02020603050405020304" pitchFamily="18" charset="0"/>
                         <a:cs typeface="Times New Roman" panose="02020603050405020304" pitchFamily="18" charset="0"/>
                       </a:endParaRPr>
@@ -16277,27 +16089,27 @@
                     <a:p>
                       <a:pPr algn="ctr" latinLnBrk="1"/>
                       <a:r>
-                        <a:rPr lang="en-US" altLang="ko-KR" sz="700" dirty="0">
+                        <a:rPr lang="en-US" altLang="ko-KR" sz="600" dirty="0">
                           <a:latin typeface="Times New Roman" panose="02020603050405020304" pitchFamily="18" charset="0"/>
                           <a:cs typeface="Times New Roman" panose="02020603050405020304" pitchFamily="18" charset="0"/>
                         </a:rPr>
                         <a:t>[cm</a:t>
                       </a:r>
                       <a:r>
-                        <a:rPr lang="en-US" altLang="ko-KR" sz="700" baseline="30000" dirty="0">
+                        <a:rPr lang="en-US" altLang="ko-KR" sz="600" baseline="30000" dirty="0">
                           <a:latin typeface="Times New Roman" panose="02020603050405020304" pitchFamily="18" charset="0"/>
                           <a:cs typeface="Times New Roman" panose="02020603050405020304" pitchFamily="18" charset="0"/>
                         </a:rPr>
                         <a:t>-3</a:t>
                       </a:r>
                       <a:r>
-                        <a:rPr lang="en-US" altLang="ko-KR" sz="700" dirty="0">
+                        <a:rPr lang="en-US" altLang="ko-KR" sz="600" dirty="0">
                           <a:latin typeface="Times New Roman" panose="02020603050405020304" pitchFamily="18" charset="0"/>
                           <a:cs typeface="Times New Roman" panose="02020603050405020304" pitchFamily="18" charset="0"/>
                         </a:rPr>
                         <a:t>]</a:t>
                       </a:r>
-                      <a:endParaRPr lang="ko-KR" altLang="en-US" sz="700" dirty="0">
+                      <a:endParaRPr lang="ko-KR" altLang="en-US" sz="600" dirty="0">
                         <a:latin typeface="Times New Roman" panose="02020603050405020304" pitchFamily="18" charset="0"/>
                         <a:cs typeface="Times New Roman" panose="02020603050405020304" pitchFamily="18" charset="0"/>
                       </a:endParaRPr>
@@ -16345,6 +16157,251 @@
                 <a:extLst>
                   <a:ext uri="{0D108BD9-81ED-4DB2-BD59-A6C34878D82A}">
                     <a16:rowId xmlns:a16="http://schemas.microsoft.com/office/drawing/2014/main" val="1021031779"/>
+                  </a:ext>
+                </a:extLst>
+              </a:tr>
+            </a:tbl>
+          </a:graphicData>
+        </a:graphic>
+      </p:graphicFrame>
+      <p:graphicFrame>
+        <p:nvGraphicFramePr>
+          <p:cNvPr id="17" name="표 16">
+            <a:extLst>
+              <a:ext uri="{FF2B5EF4-FFF2-40B4-BE49-F238E27FC236}">
+                <a16:creationId xmlns:a16="http://schemas.microsoft.com/office/drawing/2014/main" id="{CB614969-B66A-B5E7-8D26-FE094E3821E4}"/>
+              </a:ext>
+            </a:extLst>
+          </p:cNvPr>
+          <p:cNvGraphicFramePr>
+            <a:graphicFrameLocks noGrp="1"/>
+          </p:cNvGraphicFramePr>
+          <p:nvPr>
+            <p:extLst>
+              <p:ext uri="{D42A27DB-BD31-4B8C-83A1-F6EECF244321}">
+                <p14:modId xmlns:p14="http://schemas.microsoft.com/office/powerpoint/2010/main" val="2531010336"/>
+              </p:ext>
+            </p:extLst>
+          </p:nvPr>
+        </p:nvGraphicFramePr>
+        <p:xfrm>
+          <a:off x="4403408" y="1484756"/>
+          <a:ext cx="1489020" cy="182880"/>
+        </p:xfrm>
+        <a:graphic>
+          <a:graphicData uri="http://schemas.openxmlformats.org/drawingml/2006/table">
+            <a:tbl>
+              <a:tblPr firstRow="1" bandRow="1">
+                <a:tableStyleId>{5940675A-B579-460E-94D1-54222C63F5DA}</a:tableStyleId>
+              </a:tblPr>
+              <a:tblGrid>
+                <a:gridCol w="353811">
+                  <a:extLst>
+                    <a:ext uri="{9D8B030D-6E8A-4147-A177-3AD203B41FA5}">
+                      <a16:colId xmlns:a16="http://schemas.microsoft.com/office/drawing/2014/main" val="1269897319"/>
+                    </a:ext>
+                  </a:extLst>
+                </a:gridCol>
+                <a:gridCol w="656071">
+                  <a:extLst>
+                    <a:ext uri="{9D8B030D-6E8A-4147-A177-3AD203B41FA5}">
+                      <a16:colId xmlns:a16="http://schemas.microsoft.com/office/drawing/2014/main" val="4067252439"/>
+                    </a:ext>
+                  </a:extLst>
+                </a:gridCol>
+                <a:gridCol w="479138">
+                  <a:extLst>
+                    <a:ext uri="{9D8B030D-6E8A-4147-A177-3AD203B41FA5}">
+                      <a16:colId xmlns:a16="http://schemas.microsoft.com/office/drawing/2014/main" val="2850526430"/>
+                    </a:ext>
+                  </a:extLst>
+                </a:gridCol>
+              </a:tblGrid>
+              <a:tr h="157897">
+                <a:tc>
+                  <a:txBody>
+                    <a:bodyPr/>
+                    <a:lstStyle/>
+                    <a:p>
+                      <a:pPr algn="ctr" latinLnBrk="1"/>
+                      <a:r>
+                        <a:rPr lang="en-US" altLang="ko-KR" sz="600" baseline="0" dirty="0" err="1">
+                          <a:latin typeface="Times New Roman" panose="02020603050405020304" pitchFamily="18" charset="0"/>
+                          <a:cs typeface="Times New Roman" panose="02020603050405020304" pitchFamily="18" charset="0"/>
+                        </a:rPr>
+                        <a:t>ΔV</a:t>
+                      </a:r>
+                      <a:r>
+                        <a:rPr lang="en-US" altLang="ko-KR" sz="600" baseline="-25000" dirty="0" err="1">
+                          <a:latin typeface="Times New Roman" panose="02020603050405020304" pitchFamily="18" charset="0"/>
+                          <a:cs typeface="Times New Roman" panose="02020603050405020304" pitchFamily="18" charset="0"/>
+                        </a:rPr>
+                        <a:t>t</a:t>
+                      </a:r>
+                      <a:endParaRPr lang="ko-KR" altLang="en-US" sz="600" baseline="-25000" dirty="0">
+                        <a:latin typeface="Times New Roman" panose="02020603050405020304" pitchFamily="18" charset="0"/>
+                        <a:cs typeface="Times New Roman" panose="02020603050405020304" pitchFamily="18" charset="0"/>
+                      </a:endParaRPr>
+                    </a:p>
+                  </a:txBody>
+                  <a:tcPr anchor="ctr">
+                    <a:lnL w="6350" cap="flat" cmpd="sng" algn="ctr">
+                      <a:solidFill>
+                        <a:schemeClr val="tx1"/>
+                      </a:solidFill>
+                      <a:prstDash val="solid"/>
+                      <a:round/>
+                      <a:headEnd type="none" w="med" len="med"/>
+                      <a:tailEnd type="none" w="med" len="med"/>
+                    </a:lnL>
+                    <a:lnR w="6350" cap="flat" cmpd="sng" algn="ctr">
+                      <a:solidFill>
+                        <a:schemeClr val="tx1"/>
+                      </a:solidFill>
+                      <a:prstDash val="solid"/>
+                      <a:round/>
+                      <a:headEnd type="none" w="med" len="med"/>
+                      <a:tailEnd type="none" w="med" len="med"/>
+                    </a:lnR>
+                    <a:lnT w="6350" cap="flat" cmpd="sng" algn="ctr">
+                      <a:solidFill>
+                        <a:schemeClr val="tx1"/>
+                      </a:solidFill>
+                      <a:prstDash val="solid"/>
+                      <a:round/>
+                      <a:headEnd type="none" w="med" len="med"/>
+                      <a:tailEnd type="none" w="med" len="med"/>
+                    </a:lnT>
+                    <a:lnB w="6350" cap="flat" cmpd="sng" algn="ctr">
+                      <a:solidFill>
+                        <a:schemeClr val="tx1"/>
+                      </a:solidFill>
+                      <a:prstDash val="solid"/>
+                      <a:round/>
+                      <a:headEnd type="none" w="med" len="med"/>
+                      <a:tailEnd type="none" w="med" len="med"/>
+                    </a:lnB>
+                  </a:tcPr>
+                </a:tc>
+                <a:tc>
+                  <a:txBody>
+                    <a:bodyPr/>
+                    <a:lstStyle/>
+                    <a:p>
+                      <a:pPr algn="ctr" latinLnBrk="1"/>
+                      <a:r>
+                        <a:rPr lang="en-US" altLang="ko-KR" sz="600" dirty="0">
+                          <a:latin typeface="Times New Roman" panose="02020603050405020304" pitchFamily="18" charset="0"/>
+                          <a:cs typeface="Times New Roman" panose="02020603050405020304" pitchFamily="18" charset="0"/>
+                        </a:rPr>
+                        <a:t>1.8</a:t>
+                      </a:r>
+                      <a:endParaRPr lang="ko-KR" altLang="en-US" sz="600" dirty="0">
+                        <a:latin typeface="Times New Roman" panose="02020603050405020304" pitchFamily="18" charset="0"/>
+                        <a:cs typeface="Times New Roman" panose="02020603050405020304" pitchFamily="18" charset="0"/>
+                      </a:endParaRPr>
+                    </a:p>
+                  </a:txBody>
+                  <a:tcPr anchor="ctr">
+                    <a:lnL w="6350" cap="flat" cmpd="sng" algn="ctr">
+                      <a:solidFill>
+                        <a:schemeClr val="tx1"/>
+                      </a:solidFill>
+                      <a:prstDash val="solid"/>
+                      <a:round/>
+                      <a:headEnd type="none" w="med" len="med"/>
+                      <a:tailEnd type="none" w="med" len="med"/>
+                    </a:lnL>
+                    <a:lnR w="3175" cap="flat" cmpd="sng" algn="ctr">
+                      <a:solidFill>
+                        <a:schemeClr val="bg1"/>
+                      </a:solidFill>
+                      <a:prstDash val="solid"/>
+                      <a:round/>
+                      <a:headEnd type="none" w="med" len="med"/>
+                      <a:tailEnd type="none" w="med" len="med"/>
+                    </a:lnR>
+                    <a:lnT w="6350" cap="flat" cmpd="sng" algn="ctr">
+                      <a:solidFill>
+                        <a:schemeClr val="tx1"/>
+                      </a:solidFill>
+                      <a:prstDash val="solid"/>
+                      <a:round/>
+                      <a:headEnd type="none" w="med" len="med"/>
+                      <a:tailEnd type="none" w="med" len="med"/>
+                    </a:lnT>
+                    <a:lnB w="6350" cap="flat" cmpd="sng" algn="ctr">
+                      <a:solidFill>
+                        <a:schemeClr val="tx1"/>
+                      </a:solidFill>
+                      <a:prstDash val="solid"/>
+                      <a:round/>
+                      <a:headEnd type="none" w="med" len="med"/>
+                      <a:tailEnd type="none" w="med" len="med"/>
+                    </a:lnB>
+                  </a:tcPr>
+                </a:tc>
+                <a:tc>
+                  <a:txBody>
+                    <a:bodyPr/>
+                    <a:lstStyle/>
+                    <a:p>
+                      <a:pPr algn="ctr" latinLnBrk="1"/>
+                      <a:r>
+                        <a:rPr lang="en-US" altLang="ko-KR" sz="600" baseline="0" dirty="0">
+                          <a:latin typeface="Times New Roman" panose="02020603050405020304" pitchFamily="18" charset="0"/>
+                          <a:cs typeface="Times New Roman" panose="02020603050405020304" pitchFamily="18" charset="0"/>
+                        </a:rPr>
+                        <a:t>[V]</a:t>
+                      </a:r>
+                      <a:endParaRPr lang="ko-KR" altLang="en-US" sz="600" baseline="0" dirty="0">
+                        <a:latin typeface="Times New Roman" panose="02020603050405020304" pitchFamily="18" charset="0"/>
+                        <a:cs typeface="Times New Roman" panose="02020603050405020304" pitchFamily="18" charset="0"/>
+                      </a:endParaRPr>
+                    </a:p>
+                  </a:txBody>
+                  <a:tcPr anchor="ctr">
+                    <a:lnL w="3175" cap="flat" cmpd="sng" algn="ctr">
+                      <a:solidFill>
+                        <a:schemeClr val="bg1"/>
+                      </a:solidFill>
+                      <a:prstDash val="solid"/>
+                      <a:round/>
+                      <a:headEnd type="none" w="med" len="med"/>
+                      <a:tailEnd type="none" w="med" len="med"/>
+                    </a:lnL>
+                    <a:lnR w="6350" cap="flat" cmpd="sng" algn="ctr">
+                      <a:solidFill>
+                        <a:schemeClr val="tx1"/>
+                      </a:solidFill>
+                      <a:prstDash val="solid"/>
+                      <a:round/>
+                      <a:headEnd type="none" w="med" len="med"/>
+                      <a:tailEnd type="none" w="med" len="med"/>
+                    </a:lnR>
+                    <a:lnT w="6350" cap="flat" cmpd="sng" algn="ctr">
+                      <a:solidFill>
+                        <a:schemeClr val="tx1"/>
+                      </a:solidFill>
+                      <a:prstDash val="solid"/>
+                      <a:round/>
+                      <a:headEnd type="none" w="med" len="med"/>
+                      <a:tailEnd type="none" w="med" len="med"/>
+                    </a:lnT>
+                    <a:lnB w="6350" cap="flat" cmpd="sng" algn="ctr">
+                      <a:solidFill>
+                        <a:schemeClr val="tx1"/>
+                      </a:solidFill>
+                      <a:prstDash val="solid"/>
+                      <a:round/>
+                      <a:headEnd type="none" w="med" len="med"/>
+                      <a:tailEnd type="none" w="med" len="med"/>
+                    </a:lnB>
+                  </a:tcPr>
+                </a:tc>
+                <a:extLst>
+                  <a:ext uri="{0D108BD9-81ED-4DB2-BD59-A6C34878D82A}">
+                    <a16:rowId xmlns:a16="http://schemas.microsoft.com/office/drawing/2014/main" val="2970405009"/>
                   </a:ext>
                 </a:extLst>
               </a:tr>

</xml_diff>

<commit_message>
Revision started as pivotting marked version. Todo: fig. 3(c) making within the space, Result and Discussion section revising.
</commit_message>
<xml_diff>
--- a/figures/Figures-EDL202605-manuscript.pptx
+++ b/figures/Figures-EDL202605-manuscript.pptx
@@ -208,7 +208,7 @@
           <a:p>
             <a:fld id="{AA311422-0C2E-42D7-924E-F365B5A34ABC}" type="datetimeFigureOut">
               <a:rPr lang="ko-KR" altLang="en-US" smtClean="0"/>
-              <a:t>2026-05-08</a:t>
+              <a:t>2026-06-07</a:t>
             </a:fld>
             <a:endParaRPr lang="ko-KR" altLang="en-US"/>
           </a:p>
@@ -606,7 +606,7 @@
           <a:p>
             <a:fld id="{038C53AF-CD6D-418E-B451-BA3CFECC6915}" type="datetimeFigureOut">
               <a:rPr lang="ko-KR" altLang="en-US" smtClean="0"/>
-              <a:t>2026-05-08</a:t>
+              <a:t>2026-06-07</a:t>
             </a:fld>
             <a:endParaRPr lang="ko-KR" altLang="en-US"/>
           </a:p>
@@ -776,7 +776,7 @@
           <a:p>
             <a:fld id="{038C53AF-CD6D-418E-B451-BA3CFECC6915}" type="datetimeFigureOut">
               <a:rPr lang="ko-KR" altLang="en-US" smtClean="0"/>
-              <a:t>2026-05-08</a:t>
+              <a:t>2026-06-07</a:t>
             </a:fld>
             <a:endParaRPr lang="ko-KR" altLang="en-US"/>
           </a:p>
@@ -956,7 +956,7 @@
           <a:p>
             <a:fld id="{038C53AF-CD6D-418E-B451-BA3CFECC6915}" type="datetimeFigureOut">
               <a:rPr lang="ko-KR" altLang="en-US" smtClean="0"/>
-              <a:t>2026-05-08</a:t>
+              <a:t>2026-06-07</a:t>
             </a:fld>
             <a:endParaRPr lang="ko-KR" altLang="en-US"/>
           </a:p>
@@ -1126,7 +1126,7 @@
           <a:p>
             <a:fld id="{038C53AF-CD6D-418E-B451-BA3CFECC6915}" type="datetimeFigureOut">
               <a:rPr lang="ko-KR" altLang="en-US" smtClean="0"/>
-              <a:t>2026-05-08</a:t>
+              <a:t>2026-06-07</a:t>
             </a:fld>
             <a:endParaRPr lang="ko-KR" altLang="en-US"/>
           </a:p>
@@ -1372,7 +1372,7 @@
           <a:p>
             <a:fld id="{038C53AF-CD6D-418E-B451-BA3CFECC6915}" type="datetimeFigureOut">
               <a:rPr lang="ko-KR" altLang="en-US" smtClean="0"/>
-              <a:t>2026-05-08</a:t>
+              <a:t>2026-06-07</a:t>
             </a:fld>
             <a:endParaRPr lang="ko-KR" altLang="en-US"/>
           </a:p>
@@ -1604,7 +1604,7 @@
           <a:p>
             <a:fld id="{038C53AF-CD6D-418E-B451-BA3CFECC6915}" type="datetimeFigureOut">
               <a:rPr lang="ko-KR" altLang="en-US" smtClean="0"/>
-              <a:t>2026-05-08</a:t>
+              <a:t>2026-06-07</a:t>
             </a:fld>
             <a:endParaRPr lang="ko-KR" altLang="en-US"/>
           </a:p>
@@ -1971,7 +1971,7 @@
           <a:p>
             <a:fld id="{038C53AF-CD6D-418E-B451-BA3CFECC6915}" type="datetimeFigureOut">
               <a:rPr lang="ko-KR" altLang="en-US" smtClean="0"/>
-              <a:t>2026-05-08</a:t>
+              <a:t>2026-06-07</a:t>
             </a:fld>
             <a:endParaRPr lang="ko-KR" altLang="en-US"/>
           </a:p>
@@ -2089,7 +2089,7 @@
           <a:p>
             <a:fld id="{038C53AF-CD6D-418E-B451-BA3CFECC6915}" type="datetimeFigureOut">
               <a:rPr lang="ko-KR" altLang="en-US" smtClean="0"/>
-              <a:t>2026-05-08</a:t>
+              <a:t>2026-06-07</a:t>
             </a:fld>
             <a:endParaRPr lang="ko-KR" altLang="en-US"/>
           </a:p>
@@ -2184,7 +2184,7 @@
           <a:p>
             <a:fld id="{038C53AF-CD6D-418E-B451-BA3CFECC6915}" type="datetimeFigureOut">
               <a:rPr lang="ko-KR" altLang="en-US" smtClean="0"/>
-              <a:t>2026-05-08</a:t>
+              <a:t>2026-06-07</a:t>
             </a:fld>
             <a:endParaRPr lang="ko-KR" altLang="en-US"/>
           </a:p>
@@ -2461,7 +2461,7 @@
           <a:p>
             <a:fld id="{038C53AF-CD6D-418E-B451-BA3CFECC6915}" type="datetimeFigureOut">
               <a:rPr lang="ko-KR" altLang="en-US" smtClean="0"/>
-              <a:t>2026-05-08</a:t>
+              <a:t>2026-06-07</a:t>
             </a:fld>
             <a:endParaRPr lang="ko-KR" altLang="en-US"/>
           </a:p>
@@ -2718,7 +2718,7 @@
           <a:p>
             <a:fld id="{038C53AF-CD6D-418E-B451-BA3CFECC6915}" type="datetimeFigureOut">
               <a:rPr lang="ko-KR" altLang="en-US" smtClean="0"/>
-              <a:t>2026-05-08</a:t>
+              <a:t>2026-06-07</a:t>
             </a:fld>
             <a:endParaRPr lang="ko-KR" altLang="en-US"/>
           </a:p>
@@ -2931,7 +2931,7 @@
           <a:p>
             <a:fld id="{038C53AF-CD6D-418E-B451-BA3CFECC6915}" type="datetimeFigureOut">
               <a:rPr lang="ko-KR" altLang="en-US" smtClean="0"/>
-              <a:t>2026-05-08</a:t>
+              <a:t>2026-06-07</a:t>
             </a:fld>
             <a:endParaRPr lang="ko-KR" altLang="en-US"/>
           </a:p>
@@ -3595,6 +3595,75 @@
           <a:chExt cx="0" cy="0"/>
         </a:xfrm>
       </p:grpSpPr>
+      <p:graphicFrame>
+        <p:nvGraphicFramePr>
+          <p:cNvPr id="4" name="개체 3">
+            <a:extLst>
+              <a:ext uri="{FF2B5EF4-FFF2-40B4-BE49-F238E27FC236}">
+                <a16:creationId xmlns:a16="http://schemas.microsoft.com/office/drawing/2014/main" id="{059A9E34-AACA-66D2-4637-275D40D28FCF}"/>
+              </a:ext>
+            </a:extLst>
+          </p:cNvPr>
+          <p:cNvGraphicFramePr>
+            <a:graphicFrameLocks noChangeAspect="1"/>
+          </p:cNvGraphicFramePr>
+          <p:nvPr>
+            <p:extLst>
+              <p:ext uri="{D42A27DB-BD31-4B8C-83A1-F6EECF244321}">
+                <p14:modId xmlns:p14="http://schemas.microsoft.com/office/powerpoint/2010/main" val="4003365916"/>
+              </p:ext>
+            </p:extLst>
+          </p:nvPr>
+        </p:nvGraphicFramePr>
+        <p:xfrm>
+          <a:off x="2048591" y="2007559"/>
+          <a:ext cx="1147442" cy="554666"/>
+        </p:xfrm>
+        <a:graphic>
+          <a:graphicData uri="http://schemas.openxmlformats.org/presentationml/2006/ole">
+            <mc:AlternateContent xmlns:mc="http://schemas.openxmlformats.org/markup-compatibility/2006">
+              <mc:Choice xmlns:v="urn:schemas-microsoft-com:vml" Requires="v">
+                <p:oleObj name="Graph" r:id="rId2" imgW="1817568" imgH="1244237" progId="Origin50.Graph">
+                  <p:embed/>
+                </p:oleObj>
+              </mc:Choice>
+              <mc:Fallback>
+                <p:oleObj name="Graph" r:id="rId2" imgW="1817568" imgH="1244237" progId="Origin50.Graph">
+                  <p:embed/>
+                  <p:pic>
+                    <p:nvPicPr>
+                      <p:cNvPr id="34" name="개체 33">
+                        <a:extLst>
+                          <a:ext uri="{FF2B5EF4-FFF2-40B4-BE49-F238E27FC236}">
+                            <a16:creationId xmlns:a16="http://schemas.microsoft.com/office/drawing/2014/main" id="{32DB6798-4516-1212-D064-B5BCCDF489E7}"/>
+                          </a:ext>
+                        </a:extLst>
+                      </p:cNvPr>
+                      <p:cNvPicPr/>
+                      <p:nvPr/>
+                    </p:nvPicPr>
+                    <p:blipFill>
+                      <a:blip r:embed="rId3"/>
+                      <a:stretch>
+                        <a:fillRect/>
+                      </a:stretch>
+                    </p:blipFill>
+                    <p:spPr>
+                      <a:xfrm>
+                        <a:off x="2048591" y="2007559"/>
+                        <a:ext cx="1147442" cy="554666"/>
+                      </a:xfrm>
+                      <a:prstGeom prst="rect">
+                        <a:avLst/>
+                      </a:prstGeom>
+                    </p:spPr>
+                  </p:pic>
+                </p:oleObj>
+              </mc:Fallback>
+            </mc:AlternateContent>
+          </a:graphicData>
+        </a:graphic>
+      </p:graphicFrame>
       <p:sp>
         <p:nvSpPr>
           <p:cNvPr id="5" name="제목 1">
@@ -4275,26 +4344,26 @@
               <a:lstStyle/>
               <a:p>
                 <a:r>
-                  <a:rPr lang="en-US" altLang="ko-KR" sz="700">
+                  <a:rPr lang="en-US" altLang="ko-KR" sz="700" dirty="0" err="1">
                     <a:latin typeface="Arial" panose="020B0604020202020204" pitchFamily="34" charset="0"/>
                     <a:cs typeface="Arial" panose="020B0604020202020204" pitchFamily="34" charset="0"/>
                   </a:rPr>
                   <a:t>Wordline</a:t>
                 </a:r>
                 <a:br>
-                  <a:rPr lang="en-US" altLang="ko-KR" sz="700">
+                  <a:rPr lang="en-US" altLang="ko-KR" sz="700" dirty="0">
                     <a:latin typeface="Arial" panose="020B0604020202020204" pitchFamily="34" charset="0"/>
                     <a:cs typeface="Arial" panose="020B0604020202020204" pitchFamily="34" charset="0"/>
                   </a:rPr>
                 </a:br>
                 <a:r>
-                  <a:rPr lang="en-US" altLang="ko-KR" sz="700">
+                  <a:rPr lang="en-US" altLang="ko-KR" sz="700" dirty="0">
                     <a:latin typeface="Arial" panose="020B0604020202020204" pitchFamily="34" charset="0"/>
                     <a:cs typeface="Arial" panose="020B0604020202020204" pitchFamily="34" charset="0"/>
                   </a:rPr>
                   <a:t>(WL)</a:t>
                 </a:r>
-                <a:endParaRPr lang="ko-KR" altLang="en-US" sz="700">
+                <a:endParaRPr lang="ko-KR" altLang="en-US" sz="700" dirty="0">
                   <a:latin typeface="Arial" panose="020B0604020202020204" pitchFamily="34" charset="0"/>
                   <a:cs typeface="Arial" panose="020B0604020202020204" pitchFamily="34" charset="0"/>
                 </a:endParaRPr>
@@ -5075,10 +5144,10 @@
       </p:pic>
       <p:grpSp>
         <p:nvGrpSpPr>
-          <p:cNvPr id="19" name="그룹 18">
+          <p:cNvPr id="8" name="그룹 7">
             <a:extLst>
               <a:ext uri="{FF2B5EF4-FFF2-40B4-BE49-F238E27FC236}">
-                <a16:creationId xmlns:a16="http://schemas.microsoft.com/office/drawing/2014/main" id="{752DC6FB-E78C-9B45-86A2-B5EA486DFFFF}"/>
+                <a16:creationId xmlns:a16="http://schemas.microsoft.com/office/drawing/2014/main" id="{0EE53E30-3C7D-C6EA-4661-9633E6715C21}"/>
               </a:ext>
             </a:extLst>
           </p:cNvPr>
@@ -5093,654 +5162,512 @@
             <a:chExt cx="1731170" cy="1167341"/>
           </a:xfrm>
         </p:grpSpPr>
-        <p:sp>
-          <p:nvSpPr>
-            <p:cNvPr id="18" name="자유형: 도형 17">
+        <p:cxnSp>
+          <p:nvCxnSpPr>
+            <p:cNvPr id="300" name="직선 연결선 299">
               <a:extLst>
                 <a:ext uri="{FF2B5EF4-FFF2-40B4-BE49-F238E27FC236}">
-                  <a16:creationId xmlns:a16="http://schemas.microsoft.com/office/drawing/2014/main" id="{F299125F-1750-1AB0-BD8D-769D46EEF0C2}"/>
+                  <a16:creationId xmlns:a16="http://schemas.microsoft.com/office/drawing/2014/main" id="{774A86F0-C443-DA34-8985-53F1D3C638BB}"/>
                 </a:ext>
               </a:extLst>
             </p:cNvPr>
-            <p:cNvSpPr/>
+            <p:cNvCxnSpPr>
+              <a:cxnSpLocks/>
+            </p:cNvCxnSpPr>
+            <p:nvPr/>
+          </p:nvCxnSpPr>
+          <p:spPr>
+            <a:xfrm>
+              <a:off x="2126659" y="2092625"/>
+              <a:ext cx="0" cy="981575"/>
+            </a:xfrm>
+            <a:prstGeom prst="line">
+              <a:avLst/>
+            </a:prstGeom>
+            <a:ln w="6350">
+              <a:solidFill>
+                <a:schemeClr val="tx1"/>
+              </a:solidFill>
+              <a:prstDash val="dash"/>
+            </a:ln>
+          </p:spPr>
+          <p:style>
+            <a:lnRef idx="2">
+              <a:schemeClr val="accent1"/>
+            </a:lnRef>
+            <a:fillRef idx="0">
+              <a:schemeClr val="accent1"/>
+            </a:fillRef>
+            <a:effectRef idx="1">
+              <a:schemeClr val="accent1"/>
+            </a:effectRef>
+            <a:fontRef idx="minor">
+              <a:schemeClr val="tx1"/>
+            </a:fontRef>
+          </p:style>
+        </p:cxnSp>
+        <p:cxnSp>
+          <p:nvCxnSpPr>
+            <p:cNvPr id="301" name="직선 연결선 300">
+              <a:extLst>
+                <a:ext uri="{FF2B5EF4-FFF2-40B4-BE49-F238E27FC236}">
+                  <a16:creationId xmlns:a16="http://schemas.microsoft.com/office/drawing/2014/main" id="{AE1A7C84-B0B6-9860-FA27-6C833DB2F93A}"/>
+                </a:ext>
+              </a:extLst>
+            </p:cNvPr>
+            <p:cNvCxnSpPr>
+              <a:cxnSpLocks/>
+            </p:cNvCxnSpPr>
+            <p:nvPr/>
+          </p:nvCxnSpPr>
+          <p:spPr>
+            <a:xfrm>
+              <a:off x="2895007" y="2057400"/>
+              <a:ext cx="0" cy="1008751"/>
+            </a:xfrm>
+            <a:prstGeom prst="line">
+              <a:avLst/>
+            </a:prstGeom>
+            <a:ln w="6350">
+              <a:solidFill>
+                <a:schemeClr val="tx1"/>
+              </a:solidFill>
+              <a:prstDash val="dash"/>
+            </a:ln>
+          </p:spPr>
+          <p:style>
+            <a:lnRef idx="2">
+              <a:schemeClr val="accent1"/>
+            </a:lnRef>
+            <a:fillRef idx="0">
+              <a:schemeClr val="accent1"/>
+            </a:fillRef>
+            <a:effectRef idx="1">
+              <a:schemeClr val="accent1"/>
+            </a:effectRef>
+            <a:fontRef idx="minor">
+              <a:schemeClr val="tx1"/>
+            </a:fontRef>
+          </p:style>
+        </p:cxnSp>
+        <p:cxnSp>
+          <p:nvCxnSpPr>
+            <p:cNvPr id="16" name="직선 화살표 연결선 15">
+              <a:extLst>
+                <a:ext uri="{FF2B5EF4-FFF2-40B4-BE49-F238E27FC236}">
+                  <a16:creationId xmlns:a16="http://schemas.microsoft.com/office/drawing/2014/main" id="{819B03E9-80AF-7243-754C-5E0F2216C4DD}"/>
+                </a:ext>
+              </a:extLst>
+            </p:cNvPr>
+            <p:cNvCxnSpPr>
+              <a:cxnSpLocks/>
+            </p:cNvCxnSpPr>
+            <p:nvPr/>
+          </p:nvCxnSpPr>
+          <p:spPr>
+            <a:xfrm>
+              <a:off x="2004533" y="2403460"/>
+              <a:ext cx="1064186" cy="0"/>
+            </a:xfrm>
+            <a:prstGeom prst="straightConnector1">
+              <a:avLst/>
+            </a:prstGeom>
+            <a:ln>
+              <a:solidFill>
+                <a:schemeClr val="tx1"/>
+              </a:solidFill>
+              <a:tailEnd type="triangle"/>
+            </a:ln>
+          </p:spPr>
+          <p:style>
+            <a:lnRef idx="2">
+              <a:schemeClr val="accent1"/>
+            </a:lnRef>
+            <a:fillRef idx="0">
+              <a:schemeClr val="accent1"/>
+            </a:fillRef>
+            <a:effectRef idx="1">
+              <a:schemeClr val="accent1"/>
+            </a:effectRef>
+            <a:fontRef idx="minor">
+              <a:schemeClr val="tx1"/>
+            </a:fontRef>
+          </p:style>
+        </p:cxnSp>
+        <p:sp>
+          <p:nvSpPr>
+            <p:cNvPr id="283" name="TextBox 282">
+              <a:extLst>
+                <a:ext uri="{FF2B5EF4-FFF2-40B4-BE49-F238E27FC236}">
+                  <a16:creationId xmlns:a16="http://schemas.microsoft.com/office/drawing/2014/main" id="{2EF5FDA5-D0D5-4482-17FF-7298970615AE}"/>
+                </a:ext>
+              </a:extLst>
+            </p:cNvPr>
+            <p:cNvSpPr txBox="1"/>
             <p:nvPr/>
           </p:nvSpPr>
           <p:spPr>
             <a:xfrm>
-              <a:off x="2128838" y="2090738"/>
-              <a:ext cx="776287" cy="309562"/>
+              <a:off x="2463548" y="2223089"/>
+              <a:ext cx="72136" cy="107722"/>
             </a:xfrm>
-            <a:custGeom>
+            <a:prstGeom prst="rect">
               <a:avLst/>
-              <a:gdLst>
-                <a:gd name="csX0" fmla="*/ 0 w 776287"/>
-                <a:gd name="csY0" fmla="*/ 309562 h 309562"/>
-                <a:gd name="csX1" fmla="*/ 0 w 776287"/>
-                <a:gd name="csY1" fmla="*/ 161925 h 309562"/>
-                <a:gd name="csX2" fmla="*/ 685800 w 776287"/>
-                <a:gd name="csY2" fmla="*/ 238125 h 309562"/>
-                <a:gd name="csX3" fmla="*/ 685800 w 776287"/>
-                <a:gd name="csY3" fmla="*/ 0 h 309562"/>
-                <a:gd name="csX4" fmla="*/ 776287 w 776287"/>
-                <a:gd name="csY4" fmla="*/ 0 h 309562"/>
-                <a:gd name="csX5" fmla="*/ 776287 w 776287"/>
-                <a:gd name="csY5" fmla="*/ 304800 h 309562"/>
-                <a:gd name="csX6" fmla="*/ 0 w 776287"/>
-                <a:gd name="csY6" fmla="*/ 309562 h 309562"/>
-              </a:gdLst>
-              <a:ahLst/>
-              <a:cxnLst>
-                <a:cxn ang="0">
-                  <a:pos x="csX0" y="csY0"/>
-                </a:cxn>
-                <a:cxn ang="0">
-                  <a:pos x="csX1" y="csY1"/>
-                </a:cxn>
-                <a:cxn ang="0">
-                  <a:pos x="csX2" y="csY2"/>
-                </a:cxn>
-                <a:cxn ang="0">
-                  <a:pos x="csX3" y="csY3"/>
-                </a:cxn>
-                <a:cxn ang="0">
-                  <a:pos x="csX4" y="csY4"/>
-                </a:cxn>
-                <a:cxn ang="0">
-                  <a:pos x="csX5" y="csY5"/>
-                </a:cxn>
-                <a:cxn ang="0">
-                  <a:pos x="csX6" y="csY6"/>
-                </a:cxn>
-              </a:cxnLst>
-              <a:rect l="l" t="t" r="r" b="b"/>
-              <a:pathLst>
-                <a:path w="776287" h="309562">
-                  <a:moveTo>
-                    <a:pt x="0" y="309562"/>
-                  </a:moveTo>
-                  <a:lnTo>
-                    <a:pt x="0" y="161925"/>
-                  </a:lnTo>
-                  <a:lnTo>
-                    <a:pt x="685800" y="238125"/>
-                  </a:lnTo>
-                  <a:lnTo>
-                    <a:pt x="685800" y="0"/>
-                  </a:lnTo>
-                  <a:lnTo>
-                    <a:pt x="776287" y="0"/>
-                  </a:lnTo>
-                  <a:lnTo>
-                    <a:pt x="776287" y="304800"/>
-                  </a:lnTo>
-                  <a:lnTo>
-                    <a:pt x="0" y="309562"/>
-                  </a:lnTo>
-                  <a:close/>
-                </a:path>
-              </a:pathLst>
-            </a:custGeom>
-            <a:solidFill>
-              <a:srgbClr val="F1D365"/>
-            </a:solidFill>
-            <a:ln>
+            </a:prstGeom>
+            <a:noFill/>
+          </p:spPr>
+          <p:txBody>
+            <a:bodyPr wrap="none" lIns="0" tIns="0" rIns="0" bIns="0" rtlCol="0">
+              <a:spAutoFit/>
+            </a:bodyPr>
+            <a:lstStyle/>
+            <a:p>
+              <a:pPr algn="ctr"/>
+              <a:r>
+                <a:rPr lang="en-US" altLang="ko-KR" sz="700" b="1" dirty="0" err="1"/>
+                <a:t>n</a:t>
+              </a:r>
+              <a:r>
+                <a:rPr lang="en-US" altLang="ko-KR" sz="700" b="1" baseline="-25000" dirty="0" err="1"/>
+                <a:t>t</a:t>
+              </a:r>
+              <a:endParaRPr lang="ko-KR" altLang="en-US" sz="700" b="1" baseline="-25000" dirty="0"/>
+            </a:p>
+          </p:txBody>
+        </p:sp>
+        <p:sp>
+          <p:nvSpPr>
+            <p:cNvPr id="340" name="TextBox 339">
+              <a:extLst>
+                <a:ext uri="{FF2B5EF4-FFF2-40B4-BE49-F238E27FC236}">
+                  <a16:creationId xmlns:a16="http://schemas.microsoft.com/office/drawing/2014/main" id="{A092FB95-3CFD-EA9D-410B-F92547721757}"/>
+                </a:ext>
+              </a:extLst>
+            </p:cNvPr>
+            <p:cNvSpPr txBox="1"/>
+            <p:nvPr/>
+          </p:nvSpPr>
+          <p:spPr>
+            <a:xfrm>
+              <a:off x="1337549" y="1906859"/>
+              <a:ext cx="360492" cy="200055"/>
+            </a:xfrm>
+            <a:prstGeom prst="rect">
+              <a:avLst/>
+            </a:prstGeom>
+            <a:noFill/>
+          </p:spPr>
+          <p:txBody>
+            <a:bodyPr wrap="square" rtlCol="0">
+              <a:spAutoFit/>
+            </a:bodyPr>
+            <a:lstStyle/>
+            <a:p>
+              <a:r>
+                <a:rPr lang="en-US" altLang="ko-KR" sz="700" b="1" dirty="0">
+                  <a:latin typeface="Arial" panose="020B0604020202020204" pitchFamily="34" charset="0"/>
+                  <a:cs typeface="Arial" panose="020B0604020202020204" pitchFamily="34" charset="0"/>
+                </a:rPr>
+                <a:t>(b)</a:t>
+              </a:r>
+              <a:endParaRPr lang="ko-KR" altLang="en-US" sz="700" b="1" dirty="0">
+                <a:latin typeface="Arial" panose="020B0604020202020204" pitchFamily="34" charset="0"/>
+                <a:cs typeface="Arial" panose="020B0604020202020204" pitchFamily="34" charset="0"/>
+              </a:endParaRPr>
+            </a:p>
+          </p:txBody>
+        </p:sp>
+        <p:cxnSp>
+          <p:nvCxnSpPr>
+            <p:cNvPr id="289" name="직선 화살표 연결선 288">
+              <a:extLst>
+                <a:ext uri="{FF2B5EF4-FFF2-40B4-BE49-F238E27FC236}">
+                  <a16:creationId xmlns:a16="http://schemas.microsoft.com/office/drawing/2014/main" id="{BF7303CF-4083-ABBE-6FCF-C2DABD2F6544}"/>
+                </a:ext>
+              </a:extLst>
+            </p:cNvPr>
+            <p:cNvCxnSpPr>
+              <a:cxnSpLocks/>
+            </p:cNvCxnSpPr>
+            <p:nvPr/>
+          </p:nvCxnSpPr>
+          <p:spPr>
+            <a:xfrm>
+              <a:off x="2135189" y="2166866"/>
+              <a:ext cx="760771" cy="0"/>
+            </a:xfrm>
+            <a:prstGeom prst="straightConnector1">
+              <a:avLst/>
+            </a:prstGeom>
+            <a:ln w="9525">
               <a:solidFill>
                 <a:schemeClr val="tx1"/>
               </a:solidFill>
+              <a:headEnd type="triangle" w="sm" len="sm"/>
+              <a:tailEnd type="triangle" w="sm" len="sm"/>
             </a:ln>
           </p:spPr>
           <p:style>
             <a:lnRef idx="2">
-              <a:schemeClr val="accent1">
-                <a:shade val="15000"/>
-              </a:schemeClr>
+              <a:schemeClr val="accent1"/>
             </a:lnRef>
-            <a:fillRef idx="1">
+            <a:fillRef idx="0">
               <a:schemeClr val="accent1"/>
             </a:fillRef>
-            <a:effectRef idx="0">
+            <a:effectRef idx="1">
               <a:schemeClr val="accent1"/>
             </a:effectRef>
             <a:fontRef idx="minor">
-              <a:schemeClr val="lt1"/>
+              <a:schemeClr val="tx1"/>
             </a:fontRef>
           </p:style>
+        </p:cxnSp>
+        <p:sp>
+          <p:nvSpPr>
+            <p:cNvPr id="305" name="TextBox 304">
+              <a:extLst>
+                <a:ext uri="{FF2B5EF4-FFF2-40B4-BE49-F238E27FC236}">
+                  <a16:creationId xmlns:a16="http://schemas.microsoft.com/office/drawing/2014/main" id="{EC124455-F295-98AF-7E49-DFD62B80281D}"/>
+                </a:ext>
+              </a:extLst>
+            </p:cNvPr>
+            <p:cNvSpPr txBox="1"/>
+            <p:nvPr/>
+          </p:nvSpPr>
+          <p:spPr>
+            <a:xfrm>
+              <a:off x="2311925" y="1997375"/>
+              <a:ext cx="407298" cy="215444"/>
+            </a:xfrm>
+            <a:prstGeom prst="rect">
+              <a:avLst/>
+            </a:prstGeom>
+            <a:noFill/>
+          </p:spPr>
           <p:txBody>
-            <a:bodyPr rtlCol="0" anchor="ctr"/>
+            <a:bodyPr wrap="square" rtlCol="0">
+              <a:spAutoFit/>
+            </a:bodyPr>
             <a:lstStyle/>
             <a:p>
               <a:pPr algn="ctr"/>
-              <a:endParaRPr lang="ko-KR" altLang="en-US"/>
+              <a:r>
+                <a:rPr lang="en-US" altLang="ko-KR" sz="800"/>
+                <a:t>t</a:t>
+              </a:r>
+              <a:r>
+                <a:rPr lang="en-US" altLang="ko-KR" sz="800" baseline="-25000"/>
+                <a:t>CTN</a:t>
+              </a:r>
+              <a:endParaRPr lang="ko-KR" altLang="en-US" sz="800" baseline="-25000"/>
             </a:p>
           </p:txBody>
         </p:sp>
-        <p:grpSp>
-          <p:nvGrpSpPr>
-            <p:cNvPr id="8" name="그룹 7">
+        <p:cxnSp>
+          <p:nvCxnSpPr>
+            <p:cNvPr id="541" name="직선 연결선 540">
               <a:extLst>
                 <a:ext uri="{FF2B5EF4-FFF2-40B4-BE49-F238E27FC236}">
-                  <a16:creationId xmlns:a16="http://schemas.microsoft.com/office/drawing/2014/main" id="{0EE53E30-3C7D-C6EA-4661-9633E6715C21}"/>
+                  <a16:creationId xmlns:a16="http://schemas.microsoft.com/office/drawing/2014/main" id="{B56972B8-31DD-C20F-602D-A49D0AAD5ACE}"/>
                 </a:ext>
               </a:extLst>
             </p:cNvPr>
-            <p:cNvGrpSpPr/>
+            <p:cNvCxnSpPr>
+              <a:cxnSpLocks/>
+            </p:cNvCxnSpPr>
             <p:nvPr/>
-          </p:nvGrpSpPr>
-          <p:grpSpPr>
-            <a:xfrm>
-              <a:off x="1337549" y="1906859"/>
-              <a:ext cx="1731170" cy="1167341"/>
-              <a:chOff x="1337549" y="1906859"/>
-              <a:chExt cx="1731170" cy="1167341"/>
+          </p:nvCxnSpPr>
+          <p:spPr>
+            <a:xfrm flipV="1">
+              <a:off x="2169702" y="2196967"/>
+              <a:ext cx="0" cy="324000"/>
             </a:xfrm>
-          </p:grpSpPr>
-          <p:cxnSp>
-            <p:nvCxnSpPr>
-              <p:cNvPr id="300" name="직선 연결선 299">
-                <a:extLst>
-                  <a:ext uri="{FF2B5EF4-FFF2-40B4-BE49-F238E27FC236}">
-                    <a16:creationId xmlns:a16="http://schemas.microsoft.com/office/drawing/2014/main" id="{774A86F0-C443-DA34-8985-53F1D3C638BB}"/>
-                  </a:ext>
-                </a:extLst>
-              </p:cNvPr>
-              <p:cNvCxnSpPr>
-                <a:cxnSpLocks/>
-              </p:cNvCxnSpPr>
-              <p:nvPr/>
-            </p:nvCxnSpPr>
-            <p:spPr>
-              <a:xfrm>
-                <a:off x="2126659" y="2092625"/>
-                <a:ext cx="0" cy="981575"/>
-              </a:xfrm>
-              <a:prstGeom prst="line">
-                <a:avLst/>
-              </a:prstGeom>
-              <a:ln w="6350">
-                <a:solidFill>
-                  <a:schemeClr val="tx1"/>
-                </a:solidFill>
-                <a:prstDash val="dash"/>
-              </a:ln>
-            </p:spPr>
-            <p:style>
-              <a:lnRef idx="2">
-                <a:schemeClr val="accent1"/>
-              </a:lnRef>
-              <a:fillRef idx="0">
-                <a:schemeClr val="accent1"/>
-              </a:fillRef>
-              <a:effectRef idx="1">
-                <a:schemeClr val="accent1"/>
-              </a:effectRef>
-              <a:fontRef idx="minor">
-                <a:schemeClr val="tx1"/>
-              </a:fontRef>
-            </p:style>
-          </p:cxnSp>
-          <p:cxnSp>
-            <p:nvCxnSpPr>
-              <p:cNvPr id="301" name="직선 연결선 300">
-                <a:extLst>
-                  <a:ext uri="{FF2B5EF4-FFF2-40B4-BE49-F238E27FC236}">
-                    <a16:creationId xmlns:a16="http://schemas.microsoft.com/office/drawing/2014/main" id="{AE1A7C84-B0B6-9860-FA27-6C833DB2F93A}"/>
-                  </a:ext>
-                </a:extLst>
-              </p:cNvPr>
-              <p:cNvCxnSpPr>
-                <a:cxnSpLocks/>
-              </p:cNvCxnSpPr>
-              <p:nvPr/>
-            </p:nvCxnSpPr>
-            <p:spPr>
-              <a:xfrm>
-                <a:off x="2895007" y="2057400"/>
-                <a:ext cx="0" cy="1008751"/>
-              </a:xfrm>
-              <a:prstGeom prst="line">
-                <a:avLst/>
-              </a:prstGeom>
-              <a:ln w="6350">
-                <a:solidFill>
-                  <a:schemeClr val="tx1"/>
-                </a:solidFill>
-                <a:prstDash val="dash"/>
-              </a:ln>
-            </p:spPr>
-            <p:style>
-              <a:lnRef idx="2">
-                <a:schemeClr val="accent1"/>
-              </a:lnRef>
-              <a:fillRef idx="0">
-                <a:schemeClr val="accent1"/>
-              </a:fillRef>
-              <a:effectRef idx="1">
-                <a:schemeClr val="accent1"/>
-              </a:effectRef>
-              <a:fontRef idx="minor">
-                <a:schemeClr val="tx1"/>
-              </a:fontRef>
-            </p:style>
-          </p:cxnSp>
-          <p:cxnSp>
-            <p:nvCxnSpPr>
-              <p:cNvPr id="16" name="직선 화살표 연결선 15">
-                <a:extLst>
-                  <a:ext uri="{FF2B5EF4-FFF2-40B4-BE49-F238E27FC236}">
-                    <a16:creationId xmlns:a16="http://schemas.microsoft.com/office/drawing/2014/main" id="{819B03E9-80AF-7243-754C-5E0F2216C4DD}"/>
-                  </a:ext>
-                </a:extLst>
-              </p:cNvPr>
-              <p:cNvCxnSpPr>
-                <a:cxnSpLocks/>
-              </p:cNvCxnSpPr>
-              <p:nvPr/>
-            </p:nvCxnSpPr>
-            <p:spPr>
-              <a:xfrm>
-                <a:off x="2004533" y="2403460"/>
-                <a:ext cx="1064186" cy="0"/>
-              </a:xfrm>
-              <a:prstGeom prst="straightConnector1">
-                <a:avLst/>
-              </a:prstGeom>
-              <a:ln>
-                <a:solidFill>
-                  <a:schemeClr val="tx1"/>
-                </a:solidFill>
-                <a:tailEnd type="triangle"/>
-              </a:ln>
-            </p:spPr>
-            <p:style>
-              <a:lnRef idx="2">
-                <a:schemeClr val="accent1"/>
-              </a:lnRef>
-              <a:fillRef idx="0">
-                <a:schemeClr val="accent1"/>
-              </a:fillRef>
-              <a:effectRef idx="1">
-                <a:schemeClr val="accent1"/>
-              </a:effectRef>
-              <a:fontRef idx="minor">
-                <a:schemeClr val="tx1"/>
-              </a:fontRef>
-            </p:style>
-          </p:cxnSp>
-          <p:sp>
-            <p:nvSpPr>
-              <p:cNvPr id="283" name="TextBox 282">
-                <a:extLst>
-                  <a:ext uri="{FF2B5EF4-FFF2-40B4-BE49-F238E27FC236}">
-                    <a16:creationId xmlns:a16="http://schemas.microsoft.com/office/drawing/2014/main" id="{2EF5FDA5-D0D5-4482-17FF-7298970615AE}"/>
-                  </a:ext>
-                </a:extLst>
-              </p:cNvPr>
-              <p:cNvSpPr txBox="1"/>
-              <p:nvPr/>
-            </p:nvSpPr>
-            <p:spPr>
-              <a:xfrm>
-                <a:off x="2421390" y="2281509"/>
-                <a:ext cx="72136" cy="107722"/>
-              </a:xfrm>
-              <a:prstGeom prst="rect">
-                <a:avLst/>
-              </a:prstGeom>
-              <a:noFill/>
-            </p:spPr>
-            <p:txBody>
-              <a:bodyPr wrap="none" lIns="0" tIns="0" rIns="0" bIns="0" rtlCol="0">
-                <a:spAutoFit/>
-              </a:bodyPr>
-              <a:lstStyle/>
-              <a:p>
-                <a:pPr algn="ctr"/>
-                <a:r>
-                  <a:rPr lang="en-US" altLang="ko-KR" sz="700" b="1" dirty="0" err="1"/>
-                  <a:t>n</a:t>
-                </a:r>
-                <a:r>
-                  <a:rPr lang="en-US" altLang="ko-KR" sz="700" b="1" baseline="-25000" dirty="0" err="1"/>
-                  <a:t>t</a:t>
-                </a:r>
-                <a:endParaRPr lang="ko-KR" altLang="en-US" sz="700" b="1" baseline="-25000" dirty="0"/>
-              </a:p>
-            </p:txBody>
-          </p:sp>
-          <p:sp>
-            <p:nvSpPr>
-              <p:cNvPr id="340" name="TextBox 339">
-                <a:extLst>
-                  <a:ext uri="{FF2B5EF4-FFF2-40B4-BE49-F238E27FC236}">
-                    <a16:creationId xmlns:a16="http://schemas.microsoft.com/office/drawing/2014/main" id="{A092FB95-3CFD-EA9D-410B-F92547721757}"/>
-                  </a:ext>
-                </a:extLst>
-              </p:cNvPr>
-              <p:cNvSpPr txBox="1"/>
-              <p:nvPr/>
-            </p:nvSpPr>
-            <p:spPr>
-              <a:xfrm>
-                <a:off x="1337549" y="1906859"/>
-                <a:ext cx="360492" cy="200055"/>
-              </a:xfrm>
-              <a:prstGeom prst="rect">
-                <a:avLst/>
-              </a:prstGeom>
-              <a:noFill/>
-            </p:spPr>
-            <p:txBody>
-              <a:bodyPr wrap="square" rtlCol="0">
-                <a:spAutoFit/>
-              </a:bodyPr>
-              <a:lstStyle/>
-              <a:p>
-                <a:r>
-                  <a:rPr lang="en-US" altLang="ko-KR" sz="700" b="1" dirty="0">
-                    <a:latin typeface="Arial" panose="020B0604020202020204" pitchFamily="34" charset="0"/>
-                    <a:cs typeface="Arial" panose="020B0604020202020204" pitchFamily="34" charset="0"/>
-                  </a:rPr>
-                  <a:t>(b)</a:t>
-                </a:r>
-                <a:endParaRPr lang="ko-KR" altLang="en-US" sz="700" b="1" dirty="0">
-                  <a:latin typeface="Arial" panose="020B0604020202020204" pitchFamily="34" charset="0"/>
-                  <a:cs typeface="Arial" panose="020B0604020202020204" pitchFamily="34" charset="0"/>
-                </a:endParaRPr>
-              </a:p>
-            </p:txBody>
-          </p:sp>
-          <p:cxnSp>
-            <p:nvCxnSpPr>
-              <p:cNvPr id="289" name="직선 화살표 연결선 288">
-                <a:extLst>
-                  <a:ext uri="{FF2B5EF4-FFF2-40B4-BE49-F238E27FC236}">
-                    <a16:creationId xmlns:a16="http://schemas.microsoft.com/office/drawing/2014/main" id="{BF7303CF-4083-ABBE-6FCF-C2DABD2F6544}"/>
-                  </a:ext>
-                </a:extLst>
-              </p:cNvPr>
-              <p:cNvCxnSpPr>
-                <a:cxnSpLocks/>
-              </p:cNvCxnSpPr>
-              <p:nvPr/>
-            </p:nvCxnSpPr>
-            <p:spPr>
-              <a:xfrm>
-                <a:off x="2135189" y="2166866"/>
-                <a:ext cx="760771" cy="0"/>
-              </a:xfrm>
-              <a:prstGeom prst="straightConnector1">
-                <a:avLst/>
-              </a:prstGeom>
-              <a:ln w="9525">
-                <a:solidFill>
-                  <a:schemeClr val="tx1"/>
-                </a:solidFill>
-                <a:headEnd type="triangle" w="sm" len="sm"/>
-                <a:tailEnd type="triangle" w="sm" len="sm"/>
-              </a:ln>
-            </p:spPr>
-            <p:style>
-              <a:lnRef idx="2">
-                <a:schemeClr val="accent1"/>
-              </a:lnRef>
-              <a:fillRef idx="0">
-                <a:schemeClr val="accent1"/>
-              </a:fillRef>
-              <a:effectRef idx="1">
-                <a:schemeClr val="accent1"/>
-              </a:effectRef>
-              <a:fontRef idx="minor">
-                <a:schemeClr val="tx1"/>
-              </a:fontRef>
-            </p:style>
-          </p:cxnSp>
-          <p:sp>
-            <p:nvSpPr>
-              <p:cNvPr id="305" name="TextBox 304">
-                <a:extLst>
-                  <a:ext uri="{FF2B5EF4-FFF2-40B4-BE49-F238E27FC236}">
-                    <a16:creationId xmlns:a16="http://schemas.microsoft.com/office/drawing/2014/main" id="{EC124455-F295-98AF-7E49-DFD62B80281D}"/>
-                  </a:ext>
-                </a:extLst>
-              </p:cNvPr>
-              <p:cNvSpPr txBox="1"/>
-              <p:nvPr/>
-            </p:nvSpPr>
-            <p:spPr>
-              <a:xfrm>
-                <a:off x="2311925" y="1997375"/>
-                <a:ext cx="407298" cy="215444"/>
-              </a:xfrm>
-              <a:prstGeom prst="rect">
-                <a:avLst/>
-              </a:prstGeom>
-              <a:noFill/>
-            </p:spPr>
-            <p:txBody>
-              <a:bodyPr wrap="square" rtlCol="0">
-                <a:spAutoFit/>
-              </a:bodyPr>
-              <a:lstStyle/>
-              <a:p>
-                <a:pPr algn="ctr"/>
-                <a:r>
-                  <a:rPr lang="en-US" altLang="ko-KR" sz="800"/>
-                  <a:t>t</a:t>
-                </a:r>
-                <a:r>
-                  <a:rPr lang="en-US" altLang="ko-KR" sz="800" baseline="-25000"/>
-                  <a:t>CTN</a:t>
-                </a:r>
-                <a:endParaRPr lang="ko-KR" altLang="en-US" sz="800" baseline="-25000"/>
-              </a:p>
-            </p:txBody>
-          </p:sp>
-          <p:cxnSp>
-            <p:nvCxnSpPr>
-              <p:cNvPr id="541" name="직선 연결선 540">
-                <a:extLst>
-                  <a:ext uri="{FF2B5EF4-FFF2-40B4-BE49-F238E27FC236}">
-                    <a16:creationId xmlns:a16="http://schemas.microsoft.com/office/drawing/2014/main" id="{B56972B8-31DD-C20F-602D-A49D0AAD5ACE}"/>
-                  </a:ext>
-                </a:extLst>
-              </p:cNvPr>
-              <p:cNvCxnSpPr>
-                <a:cxnSpLocks/>
-              </p:cNvCxnSpPr>
-              <p:nvPr/>
-            </p:nvCxnSpPr>
-            <p:spPr>
-              <a:xfrm flipV="1">
-                <a:off x="2169702" y="2196967"/>
-                <a:ext cx="0" cy="324000"/>
-              </a:xfrm>
-              <a:prstGeom prst="line">
-                <a:avLst/>
-              </a:prstGeom>
-              <a:ln w="3175">
-                <a:prstDash val="dash"/>
-              </a:ln>
-            </p:spPr>
-            <p:style>
-              <a:lnRef idx="2">
-                <a:schemeClr val="accent1"/>
-              </a:lnRef>
-              <a:fillRef idx="0">
-                <a:schemeClr val="accent1"/>
-              </a:fillRef>
-              <a:effectRef idx="1">
-                <a:schemeClr val="accent1"/>
-              </a:effectRef>
-              <a:fontRef idx="minor">
-                <a:schemeClr val="tx1"/>
-              </a:fontRef>
-            </p:style>
-          </p:cxnSp>
-          <p:cxnSp>
-            <p:nvCxnSpPr>
-              <p:cNvPr id="542" name="직선 연결선 541">
-                <a:extLst>
-                  <a:ext uri="{FF2B5EF4-FFF2-40B4-BE49-F238E27FC236}">
-                    <a16:creationId xmlns:a16="http://schemas.microsoft.com/office/drawing/2014/main" id="{6D248263-98BD-D746-842D-E51F3DDDA3F1}"/>
-                  </a:ext>
-                </a:extLst>
-              </p:cNvPr>
-              <p:cNvCxnSpPr>
-                <a:cxnSpLocks/>
-              </p:cNvCxnSpPr>
-              <p:nvPr/>
-            </p:nvCxnSpPr>
-            <p:spPr>
-              <a:xfrm flipV="1">
-                <a:off x="2215705" y="2196967"/>
-                <a:ext cx="0" cy="324000"/>
-              </a:xfrm>
-              <a:prstGeom prst="line">
-                <a:avLst/>
-              </a:prstGeom>
-              <a:ln w="3175">
-                <a:prstDash val="dash"/>
-              </a:ln>
-            </p:spPr>
-            <p:style>
-              <a:lnRef idx="2">
-                <a:schemeClr val="accent1"/>
-              </a:lnRef>
-              <a:fillRef idx="0">
-                <a:schemeClr val="accent1"/>
-              </a:fillRef>
-              <a:effectRef idx="1">
-                <a:schemeClr val="accent1"/>
-              </a:effectRef>
-              <a:fontRef idx="minor">
-                <a:schemeClr val="tx1"/>
-              </a:fontRef>
-            </p:style>
-          </p:cxnSp>
-          <p:cxnSp>
-            <p:nvCxnSpPr>
-              <p:cNvPr id="546" name="직선 연결선 545">
-                <a:extLst>
-                  <a:ext uri="{FF2B5EF4-FFF2-40B4-BE49-F238E27FC236}">
-                    <a16:creationId xmlns:a16="http://schemas.microsoft.com/office/drawing/2014/main" id="{8B0B6F77-0AA7-642D-AE13-C4441142C942}"/>
-                  </a:ext>
-                </a:extLst>
-              </p:cNvPr>
-              <p:cNvCxnSpPr>
-                <a:cxnSpLocks/>
-              </p:cNvCxnSpPr>
-              <p:nvPr/>
-            </p:nvCxnSpPr>
-            <p:spPr>
-              <a:xfrm flipV="1">
-                <a:off x="2261708" y="2196967"/>
-                <a:ext cx="0" cy="324000"/>
-              </a:xfrm>
-              <a:prstGeom prst="line">
-                <a:avLst/>
-              </a:prstGeom>
-              <a:ln w="3175">
-                <a:prstDash val="dash"/>
-              </a:ln>
-            </p:spPr>
-            <p:style>
-              <a:lnRef idx="2">
-                <a:schemeClr val="accent1"/>
-              </a:lnRef>
-              <a:fillRef idx="0">
-                <a:schemeClr val="accent1"/>
-              </a:fillRef>
-              <a:effectRef idx="1">
-                <a:schemeClr val="accent1"/>
-              </a:effectRef>
-              <a:fontRef idx="minor">
-                <a:schemeClr val="tx1"/>
-              </a:fontRef>
-            </p:style>
-          </p:cxnSp>
-          <p:cxnSp>
-            <p:nvCxnSpPr>
-              <p:cNvPr id="549" name="직선 연결선 548">
-                <a:extLst>
-                  <a:ext uri="{FF2B5EF4-FFF2-40B4-BE49-F238E27FC236}">
-                    <a16:creationId xmlns:a16="http://schemas.microsoft.com/office/drawing/2014/main" id="{96BB6338-B3BA-D9DF-7D39-0503C83479CE}"/>
-                  </a:ext>
-                </a:extLst>
-              </p:cNvPr>
-              <p:cNvCxnSpPr>
-                <a:cxnSpLocks/>
-              </p:cNvCxnSpPr>
-              <p:nvPr/>
-            </p:nvCxnSpPr>
-            <p:spPr>
-              <a:xfrm flipV="1">
-                <a:off x="2852337" y="2092625"/>
-                <a:ext cx="0" cy="412467"/>
-              </a:xfrm>
-              <a:prstGeom prst="line">
-                <a:avLst/>
-              </a:prstGeom>
-              <a:ln w="3175">
-                <a:prstDash val="dash"/>
-              </a:ln>
-            </p:spPr>
-            <p:style>
-              <a:lnRef idx="2">
-                <a:schemeClr val="accent1"/>
-              </a:lnRef>
-              <a:fillRef idx="0">
-                <a:schemeClr val="accent1"/>
-              </a:fillRef>
-              <a:effectRef idx="1">
-                <a:schemeClr val="accent1"/>
-              </a:effectRef>
-              <a:fontRef idx="minor">
-                <a:schemeClr val="tx1"/>
-              </a:fontRef>
-            </p:style>
-          </p:cxnSp>
-          <p:cxnSp>
-            <p:nvCxnSpPr>
-              <p:cNvPr id="582" name="직선 연결선 581">
-                <a:extLst>
-                  <a:ext uri="{FF2B5EF4-FFF2-40B4-BE49-F238E27FC236}">
-                    <a16:creationId xmlns:a16="http://schemas.microsoft.com/office/drawing/2014/main" id="{8C26E27A-63D4-A7D4-55CC-FDFA523EC57B}"/>
-                  </a:ext>
-                </a:extLst>
-              </p:cNvPr>
-              <p:cNvCxnSpPr>
-                <a:cxnSpLocks/>
-              </p:cNvCxnSpPr>
-              <p:nvPr/>
-            </p:nvCxnSpPr>
-            <p:spPr>
-              <a:xfrm flipV="1">
-                <a:off x="2807609" y="2092625"/>
-                <a:ext cx="0" cy="412467"/>
-              </a:xfrm>
-              <a:prstGeom prst="line">
-                <a:avLst/>
-              </a:prstGeom>
-              <a:ln w="3175">
-                <a:prstDash val="dash"/>
-              </a:ln>
-            </p:spPr>
-            <p:style>
-              <a:lnRef idx="2">
-                <a:schemeClr val="accent1"/>
-              </a:lnRef>
-              <a:fillRef idx="0">
-                <a:schemeClr val="accent1"/>
-              </a:fillRef>
-              <a:effectRef idx="1">
-                <a:schemeClr val="accent1"/>
-              </a:effectRef>
-              <a:fontRef idx="minor">
-                <a:schemeClr val="tx1"/>
-              </a:fontRef>
-            </p:style>
-          </p:cxnSp>
-        </p:grpSp>
+            <a:prstGeom prst="line">
+              <a:avLst/>
+            </a:prstGeom>
+            <a:ln w="3175">
+              <a:prstDash val="dash"/>
+            </a:ln>
+          </p:spPr>
+          <p:style>
+            <a:lnRef idx="2">
+              <a:schemeClr val="accent1"/>
+            </a:lnRef>
+            <a:fillRef idx="0">
+              <a:schemeClr val="accent1"/>
+            </a:fillRef>
+            <a:effectRef idx="1">
+              <a:schemeClr val="accent1"/>
+            </a:effectRef>
+            <a:fontRef idx="minor">
+              <a:schemeClr val="tx1"/>
+            </a:fontRef>
+          </p:style>
+        </p:cxnSp>
+        <p:cxnSp>
+          <p:nvCxnSpPr>
+            <p:cNvPr id="542" name="직선 연결선 541">
+              <a:extLst>
+                <a:ext uri="{FF2B5EF4-FFF2-40B4-BE49-F238E27FC236}">
+                  <a16:creationId xmlns:a16="http://schemas.microsoft.com/office/drawing/2014/main" id="{6D248263-98BD-D746-842D-E51F3DDDA3F1}"/>
+                </a:ext>
+              </a:extLst>
+            </p:cNvPr>
+            <p:cNvCxnSpPr>
+              <a:cxnSpLocks/>
+            </p:cNvCxnSpPr>
+            <p:nvPr/>
+          </p:nvCxnSpPr>
+          <p:spPr>
+            <a:xfrm flipV="1">
+              <a:off x="2215705" y="2196967"/>
+              <a:ext cx="0" cy="324000"/>
+            </a:xfrm>
+            <a:prstGeom prst="line">
+              <a:avLst/>
+            </a:prstGeom>
+            <a:ln w="3175">
+              <a:prstDash val="dash"/>
+            </a:ln>
+          </p:spPr>
+          <p:style>
+            <a:lnRef idx="2">
+              <a:schemeClr val="accent1"/>
+            </a:lnRef>
+            <a:fillRef idx="0">
+              <a:schemeClr val="accent1"/>
+            </a:fillRef>
+            <a:effectRef idx="1">
+              <a:schemeClr val="accent1"/>
+            </a:effectRef>
+            <a:fontRef idx="minor">
+              <a:schemeClr val="tx1"/>
+            </a:fontRef>
+          </p:style>
+        </p:cxnSp>
+        <p:cxnSp>
+          <p:nvCxnSpPr>
+            <p:cNvPr id="546" name="직선 연결선 545">
+              <a:extLst>
+                <a:ext uri="{FF2B5EF4-FFF2-40B4-BE49-F238E27FC236}">
+                  <a16:creationId xmlns:a16="http://schemas.microsoft.com/office/drawing/2014/main" id="{8B0B6F77-0AA7-642D-AE13-C4441142C942}"/>
+                </a:ext>
+              </a:extLst>
+            </p:cNvPr>
+            <p:cNvCxnSpPr>
+              <a:cxnSpLocks/>
+            </p:cNvCxnSpPr>
+            <p:nvPr/>
+          </p:nvCxnSpPr>
+          <p:spPr>
+            <a:xfrm flipV="1">
+              <a:off x="2261708" y="2196967"/>
+              <a:ext cx="0" cy="324000"/>
+            </a:xfrm>
+            <a:prstGeom prst="line">
+              <a:avLst/>
+            </a:prstGeom>
+            <a:ln w="3175">
+              <a:prstDash val="dash"/>
+            </a:ln>
+          </p:spPr>
+          <p:style>
+            <a:lnRef idx="2">
+              <a:schemeClr val="accent1"/>
+            </a:lnRef>
+            <a:fillRef idx="0">
+              <a:schemeClr val="accent1"/>
+            </a:fillRef>
+            <a:effectRef idx="1">
+              <a:schemeClr val="accent1"/>
+            </a:effectRef>
+            <a:fontRef idx="minor">
+              <a:schemeClr val="tx1"/>
+            </a:fontRef>
+          </p:style>
+        </p:cxnSp>
+        <p:cxnSp>
+          <p:nvCxnSpPr>
+            <p:cNvPr id="549" name="직선 연결선 548">
+              <a:extLst>
+                <a:ext uri="{FF2B5EF4-FFF2-40B4-BE49-F238E27FC236}">
+                  <a16:creationId xmlns:a16="http://schemas.microsoft.com/office/drawing/2014/main" id="{96BB6338-B3BA-D9DF-7D39-0503C83479CE}"/>
+                </a:ext>
+              </a:extLst>
+            </p:cNvPr>
+            <p:cNvCxnSpPr>
+              <a:cxnSpLocks/>
+            </p:cNvCxnSpPr>
+            <p:nvPr/>
+          </p:nvCxnSpPr>
+          <p:spPr>
+            <a:xfrm flipV="1">
+              <a:off x="2852337" y="2044700"/>
+              <a:ext cx="0" cy="460392"/>
+            </a:xfrm>
+            <a:prstGeom prst="line">
+              <a:avLst/>
+            </a:prstGeom>
+            <a:ln w="3175">
+              <a:prstDash val="dash"/>
+            </a:ln>
+          </p:spPr>
+          <p:style>
+            <a:lnRef idx="2">
+              <a:schemeClr val="accent1"/>
+            </a:lnRef>
+            <a:fillRef idx="0">
+              <a:schemeClr val="accent1"/>
+            </a:fillRef>
+            <a:effectRef idx="1">
+              <a:schemeClr val="accent1"/>
+            </a:effectRef>
+            <a:fontRef idx="minor">
+              <a:schemeClr val="tx1"/>
+            </a:fontRef>
+          </p:style>
+        </p:cxnSp>
+        <p:cxnSp>
+          <p:nvCxnSpPr>
+            <p:cNvPr id="582" name="직선 연결선 581">
+              <a:extLst>
+                <a:ext uri="{FF2B5EF4-FFF2-40B4-BE49-F238E27FC236}">
+                  <a16:creationId xmlns:a16="http://schemas.microsoft.com/office/drawing/2014/main" id="{8C26E27A-63D4-A7D4-55CC-FDFA523EC57B}"/>
+                </a:ext>
+              </a:extLst>
+            </p:cNvPr>
+            <p:cNvCxnSpPr>
+              <a:cxnSpLocks/>
+            </p:cNvCxnSpPr>
+            <p:nvPr/>
+          </p:nvCxnSpPr>
+          <p:spPr>
+            <a:xfrm flipV="1">
+              <a:off x="2807609" y="2041525"/>
+              <a:ext cx="0" cy="463567"/>
+            </a:xfrm>
+            <a:prstGeom prst="line">
+              <a:avLst/>
+            </a:prstGeom>
+            <a:ln w="3175">
+              <a:prstDash val="dash"/>
+            </a:ln>
+          </p:spPr>
+          <p:style>
+            <a:lnRef idx="2">
+              <a:schemeClr val="accent1"/>
+            </a:lnRef>
+            <a:fillRef idx="0">
+              <a:schemeClr val="accent1"/>
+            </a:fillRef>
+            <a:effectRef idx="1">
+              <a:schemeClr val="accent1"/>
+            </a:effectRef>
+            <a:fontRef idx="minor">
+              <a:schemeClr val="tx1"/>
+            </a:fontRef>
+          </p:style>
+        </p:cxnSp>
       </p:grpSp>
       <p:grpSp>
         <p:nvGrpSpPr>
@@ -11620,6 +11547,92 @@
           </a:p>
         </p:txBody>
       </p:sp>
+      <p:cxnSp>
+        <p:nvCxnSpPr>
+          <p:cNvPr id="6" name="직선 화살표 연결선 5">
+            <a:extLst>
+              <a:ext uri="{FF2B5EF4-FFF2-40B4-BE49-F238E27FC236}">
+                <a16:creationId xmlns:a16="http://schemas.microsoft.com/office/drawing/2014/main" id="{0FB7BBB2-2391-E4F6-630E-ED942CA5F2E8}"/>
+              </a:ext>
+            </a:extLst>
+          </p:cNvPr>
+          <p:cNvCxnSpPr>
+            <a:cxnSpLocks/>
+          </p:cNvCxnSpPr>
+          <p:nvPr/>
+        </p:nvCxnSpPr>
+        <p:spPr>
+          <a:xfrm>
+            <a:off x="4000810" y="2597734"/>
+            <a:ext cx="821003" cy="0"/>
+          </a:xfrm>
+          <a:prstGeom prst="straightConnector1">
+            <a:avLst/>
+          </a:prstGeom>
+          <a:ln>
+            <a:solidFill>
+              <a:schemeClr val="tx1"/>
+            </a:solidFill>
+            <a:tailEnd type="triangle"/>
+          </a:ln>
+        </p:spPr>
+        <p:style>
+          <a:lnRef idx="2">
+            <a:schemeClr val="accent1"/>
+          </a:lnRef>
+          <a:fillRef idx="0">
+            <a:schemeClr val="accent1"/>
+          </a:fillRef>
+          <a:effectRef idx="1">
+            <a:schemeClr val="accent1"/>
+          </a:effectRef>
+          <a:fontRef idx="minor">
+            <a:schemeClr val="tx1"/>
+          </a:fontRef>
+        </p:style>
+      </p:cxnSp>
+      <p:sp>
+        <p:nvSpPr>
+          <p:cNvPr id="7" name="TextBox 6">
+            <a:extLst>
+              <a:ext uri="{FF2B5EF4-FFF2-40B4-BE49-F238E27FC236}">
+                <a16:creationId xmlns:a16="http://schemas.microsoft.com/office/drawing/2014/main" id="{E61A42CE-A2B0-6011-6A37-5E29295602F9}"/>
+              </a:ext>
+            </a:extLst>
+          </p:cNvPr>
+          <p:cNvSpPr txBox="1"/>
+          <p:nvPr/>
+        </p:nvSpPr>
+        <p:spPr>
+          <a:xfrm>
+            <a:off x="2901778" y="2019899"/>
+            <a:ext cx="685972" cy="369332"/>
+          </a:xfrm>
+          <a:prstGeom prst="rect">
+            <a:avLst/>
+          </a:prstGeom>
+          <a:noFill/>
+        </p:spPr>
+        <p:txBody>
+          <a:bodyPr wrap="square" rtlCol="0">
+            <a:spAutoFit/>
+          </a:bodyPr>
+          <a:lstStyle/>
+          <a:p>
+            <a:r>
+              <a:rPr lang="en-US" altLang="ko-KR" sz="600" dirty="0">
+                <a:latin typeface="Arial" panose="020B0604020202020204" pitchFamily="34" charset="0"/>
+                <a:cs typeface="Arial" panose="020B0604020202020204" pitchFamily="34" charset="0"/>
+              </a:rPr>
+              <a:t>extracted from TCAD after program</a:t>
+            </a:r>
+            <a:endParaRPr lang="ko-KR" altLang="en-US" sz="600" dirty="0">
+              <a:latin typeface="Arial" panose="020B0604020202020204" pitchFamily="34" charset="0"/>
+              <a:cs typeface="Arial" panose="020B0604020202020204" pitchFamily="34" charset="0"/>
+            </a:endParaRPr>
+          </a:p>
+        </p:txBody>
+      </p:sp>
     </p:spTree>
     <p:extLst>
       <p:ext uri="{BB962C8B-B14F-4D97-AF65-F5344CB8AC3E}">
@@ -13101,8 +13114,8 @@
           </a:graphicData>
         </a:graphic>
       </p:graphicFrame>
-      <mc:AlternateContent xmlns:mc="http://schemas.openxmlformats.org/markup-compatibility/2006">
-        <mc:Choice xmlns:a14="http://schemas.microsoft.com/office/drawing/2010/main" Requires="a14">
+      <mc:AlternateContent xmlns:mc="http://schemas.openxmlformats.org/markup-compatibility/2006" xmlns:a14="http://schemas.microsoft.com/office/drawing/2010/main">
+        <mc:Choice Requires="a14">
           <p:sp>
             <p:nvSpPr>
               <p:cNvPr id="7" name="TextBox 6">
@@ -13362,7 +13375,7 @@
             </p:txBody>
           </p:sp>
         </mc:Choice>
-        <mc:Fallback>
+        <mc:Fallback xmlns="">
           <p:sp>
             <p:nvSpPr>
               <p:cNvPr id="7" name="TextBox 6">
@@ -13407,8 +13420,8 @@
           </p:sp>
         </mc:Fallback>
       </mc:AlternateContent>
-      <mc:AlternateContent xmlns:mc="http://schemas.openxmlformats.org/markup-compatibility/2006">
-        <mc:Choice xmlns:a14="http://schemas.microsoft.com/office/drawing/2010/main" Requires="a14">
+      <mc:AlternateContent xmlns:mc="http://schemas.openxmlformats.org/markup-compatibility/2006" xmlns:a14="http://schemas.microsoft.com/office/drawing/2010/main">
+        <mc:Choice Requires="a14">
           <p:sp>
             <p:nvSpPr>
               <p:cNvPr id="11" name="TextBox 10">
@@ -13668,7 +13681,7 @@
             </p:txBody>
           </p:sp>
         </mc:Choice>
-        <mc:Fallback>
+        <mc:Fallback xmlns="">
           <p:sp>
             <p:nvSpPr>
               <p:cNvPr id="11" name="TextBox 10">
@@ -17577,7 +17590,7 @@
           <p:nvPr>
             <p:extLst>
               <p:ext uri="{D42A27DB-BD31-4B8C-83A1-F6EECF244321}">
-                <p14:modId xmlns:p14="http://schemas.microsoft.com/office/powerpoint/2010/main" val="59738941"/>
+                <p14:modId xmlns:p14="http://schemas.microsoft.com/office/powerpoint/2010/main" val="2228131588"/>
               </p:ext>
             </p:extLst>
           </p:nvPr>
@@ -17640,7 +17653,7 @@
           <p:nvPr>
             <p:extLst>
               <p:ext uri="{D42A27DB-BD31-4B8C-83A1-F6EECF244321}">
-                <p14:modId xmlns:p14="http://schemas.microsoft.com/office/powerpoint/2010/main" val="2221784782"/>
+                <p14:modId xmlns:p14="http://schemas.microsoft.com/office/powerpoint/2010/main" val="4053105877"/>
               </p:ext>
             </p:extLst>
           </p:nvPr>
@@ -17890,6 +17903,186 @@
           </a:p>
         </p:txBody>
       </p:sp>
+      <p:graphicFrame>
+        <p:nvGraphicFramePr>
+          <p:cNvPr id="10" name="개체 9">
+            <a:extLst>
+              <a:ext uri="{FF2B5EF4-FFF2-40B4-BE49-F238E27FC236}">
+                <a16:creationId xmlns:a16="http://schemas.microsoft.com/office/drawing/2014/main" id="{F9A0EE38-6A53-B057-7E1B-37BE7D311465}"/>
+              </a:ext>
+            </a:extLst>
+          </p:cNvPr>
+          <p:cNvGraphicFramePr>
+            <a:graphicFrameLocks noChangeAspect="1"/>
+          </p:cNvGraphicFramePr>
+          <p:nvPr>
+            <p:extLst>
+              <p:ext uri="{D42A27DB-BD31-4B8C-83A1-F6EECF244321}">
+                <p14:modId xmlns:p14="http://schemas.microsoft.com/office/powerpoint/2010/main" val="1866029071"/>
+              </p:ext>
+            </p:extLst>
+          </p:nvPr>
+        </p:nvGraphicFramePr>
+        <p:xfrm>
+          <a:off x="621910" y="4611192"/>
+          <a:ext cx="1368826" cy="966753"/>
+        </p:xfrm>
+        <a:graphic>
+          <a:graphicData uri="http://schemas.openxmlformats.org/presentationml/2006/ole">
+            <mc:AlternateContent xmlns:mc="http://schemas.openxmlformats.org/markup-compatibility/2006">
+              <mc:Choice xmlns:v="urn:schemas-microsoft-com:vml" Requires="v">
+                <p:oleObj name="Graph" r:id="rId6" imgW="6842908" imgH="4833106" progId="Origin50.Graph">
+                  <p:embed/>
+                </p:oleObj>
+              </mc:Choice>
+              <mc:Fallback>
+                <p:oleObj name="Graph" r:id="rId6" imgW="6842908" imgH="4833106" progId="Origin50.Graph">
+                  <p:embed/>
+                  <p:pic>
+                    <p:nvPicPr>
+                      <p:cNvPr id="2" name="개체 1">
+                        <a:extLst>
+                          <a:ext uri="{FF2B5EF4-FFF2-40B4-BE49-F238E27FC236}">
+                            <a16:creationId xmlns:a16="http://schemas.microsoft.com/office/drawing/2014/main" id="{BB03A6A1-3821-096C-9A54-669D85ABAA1D}"/>
+                          </a:ext>
+                        </a:extLst>
+                      </p:cNvPr>
+                      <p:cNvPicPr/>
+                      <p:nvPr/>
+                    </p:nvPicPr>
+                    <p:blipFill>
+                      <a:blip r:embed="rId7"/>
+                      <a:stretch>
+                        <a:fillRect/>
+                      </a:stretch>
+                    </p:blipFill>
+                    <p:spPr>
+                      <a:xfrm>
+                        <a:off x="621910" y="4611192"/>
+                        <a:ext cx="1368826" cy="966753"/>
+                      </a:xfrm>
+                      <a:prstGeom prst="rect">
+                        <a:avLst/>
+                      </a:prstGeom>
+                    </p:spPr>
+                  </p:pic>
+                </p:oleObj>
+              </mc:Fallback>
+            </mc:AlternateContent>
+          </a:graphicData>
+        </a:graphic>
+      </p:graphicFrame>
+      <p:sp>
+        <p:nvSpPr>
+          <p:cNvPr id="16" name="TextBox 15">
+            <a:extLst>
+              <a:ext uri="{FF2B5EF4-FFF2-40B4-BE49-F238E27FC236}">
+                <a16:creationId xmlns:a16="http://schemas.microsoft.com/office/drawing/2014/main" id="{79ECB351-78D9-14B2-F483-81AF4E01F1E3}"/>
+              </a:ext>
+            </a:extLst>
+          </p:cNvPr>
+          <p:cNvSpPr txBox="1"/>
+          <p:nvPr/>
+        </p:nvSpPr>
+        <p:spPr>
+          <a:xfrm>
+            <a:off x="660818" y="4554622"/>
+            <a:ext cx="360492" cy="200055"/>
+          </a:xfrm>
+          <a:prstGeom prst="rect">
+            <a:avLst/>
+          </a:prstGeom>
+          <a:noFill/>
+        </p:spPr>
+        <p:txBody>
+          <a:bodyPr wrap="square" rtlCol="0">
+            <a:spAutoFit/>
+          </a:bodyPr>
+          <a:lstStyle/>
+          <a:p>
+            <a:r>
+              <a:rPr lang="en-US" altLang="ko-KR" sz="700" b="1" dirty="0">
+                <a:latin typeface="Arial" panose="020B0604020202020204" pitchFamily="34" charset="0"/>
+                <a:cs typeface="Arial" panose="020B0604020202020204" pitchFamily="34" charset="0"/>
+              </a:rPr>
+              <a:t>(c)</a:t>
+            </a:r>
+            <a:endParaRPr lang="ko-KR" altLang="en-US" sz="700" b="1" dirty="0">
+              <a:latin typeface="Arial" panose="020B0604020202020204" pitchFamily="34" charset="0"/>
+              <a:cs typeface="Arial" panose="020B0604020202020204" pitchFamily="34" charset="0"/>
+            </a:endParaRPr>
+          </a:p>
+        </p:txBody>
+      </p:sp>
+      <p:graphicFrame>
+        <p:nvGraphicFramePr>
+          <p:cNvPr id="18" name="개체 17">
+            <a:extLst>
+              <a:ext uri="{FF2B5EF4-FFF2-40B4-BE49-F238E27FC236}">
+                <a16:creationId xmlns:a16="http://schemas.microsoft.com/office/drawing/2014/main" id="{2151DF35-4304-861B-6F61-97E3DA66E024}"/>
+              </a:ext>
+            </a:extLst>
+          </p:cNvPr>
+          <p:cNvGraphicFramePr>
+            <a:graphicFrameLocks noChangeAspect="1"/>
+          </p:cNvGraphicFramePr>
+          <p:nvPr>
+            <p:extLst>
+              <p:ext uri="{D42A27DB-BD31-4B8C-83A1-F6EECF244321}">
+                <p14:modId xmlns:p14="http://schemas.microsoft.com/office/powerpoint/2010/main" val="2142816315"/>
+              </p:ext>
+            </p:extLst>
+          </p:nvPr>
+        </p:nvGraphicFramePr>
+        <p:xfrm>
+          <a:off x="1661610" y="4611192"/>
+          <a:ext cx="1368826" cy="966753"/>
+        </p:xfrm>
+        <a:graphic>
+          <a:graphicData uri="http://schemas.openxmlformats.org/presentationml/2006/ole">
+            <mc:AlternateContent xmlns:mc="http://schemas.openxmlformats.org/markup-compatibility/2006">
+              <mc:Choice xmlns:v="urn:schemas-microsoft-com:vml" Requires="v">
+                <p:oleObj name="Graph" r:id="rId4" imgW="6842908" imgH="4833106" progId="Origin50.Graph">
+                  <p:embed/>
+                </p:oleObj>
+              </mc:Choice>
+              <mc:Fallback>
+                <p:oleObj name="Graph" r:id="rId4" imgW="6842908" imgH="4833106" progId="Origin50.Graph">
+                  <p:embed/>
+                  <p:pic>
+                    <p:nvPicPr>
+                      <p:cNvPr id="11" name="개체 10">
+                        <a:extLst>
+                          <a:ext uri="{FF2B5EF4-FFF2-40B4-BE49-F238E27FC236}">
+                            <a16:creationId xmlns:a16="http://schemas.microsoft.com/office/drawing/2014/main" id="{45DCE902-A050-7E69-600D-ADDFB21A3BA3}"/>
+                          </a:ext>
+                        </a:extLst>
+                      </p:cNvPr>
+                      <p:cNvPicPr/>
+                      <p:nvPr/>
+                    </p:nvPicPr>
+                    <p:blipFill>
+                      <a:blip r:embed="rId5"/>
+                      <a:stretch>
+                        <a:fillRect/>
+                      </a:stretch>
+                    </p:blipFill>
+                    <p:spPr>
+                      <a:xfrm>
+                        <a:off x="1661610" y="4611192"/>
+                        <a:ext cx="1368826" cy="966753"/>
+                      </a:xfrm>
+                      <a:prstGeom prst="rect">
+                        <a:avLst/>
+                      </a:prstGeom>
+                    </p:spPr>
+                  </p:pic>
+                </p:oleObj>
+              </mc:Fallback>
+            </mc:AlternateContent>
+          </a:graphicData>
+        </a:graphic>
+      </p:graphicFrame>
     </p:spTree>
     <p:extLst>
       <p:ext uri="{BB962C8B-B14F-4D97-AF65-F5344CB8AC3E}">

</xml_diff>

<commit_message>
commit made to correct directory
</commit_message>
<xml_diff>
--- a/figures/Figures-EDL202605-manuscript.pptx
+++ b/figures/Figures-EDL202605-manuscript.pptx
@@ -16452,6 +16452,132 @@
           <a:chExt cx="0" cy="0"/>
         </a:xfrm>
       </p:grpSpPr>
+      <p:graphicFrame>
+        <p:nvGraphicFramePr>
+          <p:cNvPr id="22" name="개체 21">
+            <a:extLst>
+              <a:ext uri="{FF2B5EF4-FFF2-40B4-BE49-F238E27FC236}">
+                <a16:creationId xmlns:a16="http://schemas.microsoft.com/office/drawing/2014/main" id="{9B932EBC-BE98-DEB4-B20E-D2E162841300}"/>
+              </a:ext>
+            </a:extLst>
+          </p:cNvPr>
+          <p:cNvGraphicFramePr>
+            <a:graphicFrameLocks noChangeAspect="1"/>
+          </p:cNvGraphicFramePr>
+          <p:nvPr>
+            <p:extLst>
+              <p:ext uri="{D42A27DB-BD31-4B8C-83A1-F6EECF244321}">
+                <p14:modId xmlns:p14="http://schemas.microsoft.com/office/powerpoint/2010/main" val="1614913580"/>
+              </p:ext>
+            </p:extLst>
+          </p:nvPr>
+        </p:nvGraphicFramePr>
+        <p:xfrm>
+          <a:off x="684633" y="4657201"/>
+          <a:ext cx="1825761" cy="961630"/>
+        </p:xfrm>
+        <a:graphic>
+          <a:graphicData uri="http://schemas.openxmlformats.org/presentationml/2006/ole">
+            <mc:AlternateContent xmlns:mc="http://schemas.openxmlformats.org/markup-compatibility/2006">
+              <mc:Choice xmlns:v="urn:schemas-microsoft-com:vml" Requires="v">
+                <p:oleObj name="Graph" r:id="rId2" imgW="6510977" imgH="3429000" progId="Origin50.Graph">
+                  <p:embed/>
+                </p:oleObj>
+              </mc:Choice>
+              <mc:Fallback>
+                <p:oleObj name="Graph" r:id="rId2" imgW="6510977" imgH="3429000" progId="Origin50.Graph">
+                  <p:embed/>
+                  <p:pic>
+                    <p:nvPicPr>
+                      <p:cNvPr id="0" name=""/>
+                      <p:cNvPicPr/>
+                      <p:nvPr/>
+                    </p:nvPicPr>
+                    <p:blipFill>
+                      <a:blip r:embed="rId3"/>
+                      <a:stretch>
+                        <a:fillRect/>
+                      </a:stretch>
+                    </p:blipFill>
+                    <p:spPr>
+                      <a:xfrm>
+                        <a:off x="684633" y="4657201"/>
+                        <a:ext cx="1825761" cy="961630"/>
+                      </a:xfrm>
+                      <a:prstGeom prst="rect">
+                        <a:avLst/>
+                      </a:prstGeom>
+                    </p:spPr>
+                  </p:pic>
+                </p:oleObj>
+              </mc:Fallback>
+            </mc:AlternateContent>
+          </a:graphicData>
+        </a:graphic>
+      </p:graphicFrame>
+      <p:graphicFrame>
+        <p:nvGraphicFramePr>
+          <p:cNvPr id="21" name="개체 20">
+            <a:extLst>
+              <a:ext uri="{FF2B5EF4-FFF2-40B4-BE49-F238E27FC236}">
+                <a16:creationId xmlns:a16="http://schemas.microsoft.com/office/drawing/2014/main" id="{A25E9AFC-6346-36F5-83D8-68949C6A3956}"/>
+              </a:ext>
+            </a:extLst>
+          </p:cNvPr>
+          <p:cNvGraphicFramePr>
+            <a:graphicFrameLocks noChangeAspect="1"/>
+          </p:cNvGraphicFramePr>
+          <p:nvPr>
+            <p:extLst>
+              <p:ext uri="{D42A27DB-BD31-4B8C-83A1-F6EECF244321}">
+                <p14:modId xmlns:p14="http://schemas.microsoft.com/office/powerpoint/2010/main" val="3012110154"/>
+              </p:ext>
+            </p:extLst>
+          </p:nvPr>
+        </p:nvGraphicFramePr>
+        <p:xfrm>
+          <a:off x="2340771" y="4606864"/>
+          <a:ext cx="814542" cy="814165"/>
+        </p:xfrm>
+        <a:graphic>
+          <a:graphicData uri="http://schemas.openxmlformats.org/presentationml/2006/ole">
+            <mc:AlternateContent xmlns:mc="http://schemas.openxmlformats.org/markup-compatibility/2006">
+              <mc:Choice xmlns:v="urn:schemas-microsoft-com:vml" Requires="v">
+                <p:oleObj name="Graph" r:id="rId4" imgW="3430915" imgH="3429000" progId="Origin50.Graph">
+                  <p:embed/>
+                </p:oleObj>
+              </mc:Choice>
+              <mc:Fallback>
+                <p:oleObj name="Graph" r:id="rId4" imgW="3430915" imgH="3429000" progId="Origin50.Graph">
+                  <p:embed/>
+                  <p:pic>
+                    <p:nvPicPr>
+                      <p:cNvPr id="0" name=""/>
+                      <p:cNvPicPr/>
+                      <p:nvPr/>
+                    </p:nvPicPr>
+                    <p:blipFill>
+                      <a:blip r:embed="rId5"/>
+                      <a:stretch>
+                        <a:fillRect/>
+                      </a:stretch>
+                    </p:blipFill>
+                    <p:spPr>
+                      <a:xfrm>
+                        <a:off x="2340771" y="4606864"/>
+                        <a:ext cx="814542" cy="814165"/>
+                      </a:xfrm>
+                      <a:prstGeom prst="rect">
+                        <a:avLst/>
+                      </a:prstGeom>
+                    </p:spPr>
+                  </p:pic>
+                </p:oleObj>
+              </mc:Fallback>
+            </mc:AlternateContent>
+          </a:graphicData>
+        </a:graphic>
+      </p:graphicFrame>
       <p:sp>
         <p:nvSpPr>
           <p:cNvPr id="15" name="제목 1">
@@ -16501,7 +16627,7 @@
           <p:nvPr/>
         </p:nvPicPr>
         <p:blipFill>
-          <a:blip r:embed="rId2"/>
+          <a:blip r:embed="rId6"/>
           <a:stretch>
             <a:fillRect/>
           </a:stretch>
@@ -16810,7 +16936,7 @@
           <p:nvPr/>
         </p:nvPicPr>
         <p:blipFill>
-          <a:blip r:embed="rId3"/>
+          <a:blip r:embed="rId7"/>
           <a:stretch>
             <a:fillRect/>
           </a:stretch>
@@ -16882,7 +17008,7 @@
           <p:nvPr/>
         </p:nvPicPr>
         <p:blipFill>
-          <a:blip r:embed="rId3"/>
+          <a:blip r:embed="rId7"/>
           <a:stretch>
             <a:fillRect/>
           </a:stretch>
@@ -17590,25 +17716,25 @@
           <p:nvPr>
             <p:extLst>
               <p:ext uri="{D42A27DB-BD31-4B8C-83A1-F6EECF244321}">
-                <p14:modId xmlns:p14="http://schemas.microsoft.com/office/powerpoint/2010/main" val="2228131588"/>
+                <p14:modId xmlns:p14="http://schemas.microsoft.com/office/powerpoint/2010/main" val="1103446016"/>
               </p:ext>
             </p:extLst>
           </p:nvPr>
         </p:nvGraphicFramePr>
         <p:xfrm>
-          <a:off x="1661610" y="3745073"/>
+          <a:off x="1826710" y="3745073"/>
           <a:ext cx="1368826" cy="966753"/>
         </p:xfrm>
         <a:graphic>
           <a:graphicData uri="http://schemas.openxmlformats.org/presentationml/2006/ole">
             <mc:AlternateContent xmlns:mc="http://schemas.openxmlformats.org/markup-compatibility/2006">
               <mc:Choice xmlns:v="urn:schemas-microsoft-com:vml" Requires="v">
-                <p:oleObj name="Graph" r:id="rId4" imgW="6842908" imgH="4833106" progId="Origin50.Graph">
+                <p:oleObj name="Graph" r:id="rId8" imgW="6842908" imgH="4833106" progId="Origin50.Graph">
                   <p:embed/>
                 </p:oleObj>
               </mc:Choice>
               <mc:Fallback>
-                <p:oleObj name="Graph" r:id="rId4" imgW="6842908" imgH="4833106" progId="Origin50.Graph">
+                <p:oleObj name="Graph" r:id="rId8" imgW="6842908" imgH="4833106" progId="Origin50.Graph">
                   <p:embed/>
                   <p:pic>
                     <p:nvPicPr>
@@ -17617,14 +17743,14 @@
                       <p:nvPr/>
                     </p:nvPicPr>
                     <p:blipFill>
-                      <a:blip r:embed="rId5"/>
+                      <a:blip r:embed="rId9"/>
                       <a:stretch>
                         <a:fillRect/>
                       </a:stretch>
                     </p:blipFill>
                     <p:spPr>
                       <a:xfrm>
-                        <a:off x="1661610" y="3745073"/>
+                        <a:off x="1826710" y="3745073"/>
                         <a:ext cx="1368826" cy="966753"/>
                       </a:xfrm>
                       <a:prstGeom prst="rect">
@@ -17653,25 +17779,25 @@
           <p:nvPr>
             <p:extLst>
               <p:ext uri="{D42A27DB-BD31-4B8C-83A1-F6EECF244321}">
-                <p14:modId xmlns:p14="http://schemas.microsoft.com/office/powerpoint/2010/main" val="4053105877"/>
+                <p14:modId xmlns:p14="http://schemas.microsoft.com/office/powerpoint/2010/main" val="40449132"/>
               </p:ext>
             </p:extLst>
           </p:nvPr>
         </p:nvGraphicFramePr>
         <p:xfrm>
-          <a:off x="621910" y="3745073"/>
-          <a:ext cx="1368826" cy="966753"/>
+          <a:off x="737074" y="3756161"/>
+          <a:ext cx="1368826" cy="961630"/>
         </p:xfrm>
         <a:graphic>
           <a:graphicData uri="http://schemas.openxmlformats.org/presentationml/2006/ole">
             <mc:AlternateContent xmlns:mc="http://schemas.openxmlformats.org/markup-compatibility/2006">
               <mc:Choice xmlns:v="urn:schemas-microsoft-com:vml" Requires="v">
-                <p:oleObj name="Graph" r:id="rId6" imgW="6842908" imgH="4833106" progId="Origin50.Graph">
+                <p:oleObj name="Graph" r:id="rId10" imgW="4722409" imgH="3317966" progId="Origin50.Graph">
                   <p:embed/>
                 </p:oleObj>
               </mc:Choice>
               <mc:Fallback>
-                <p:oleObj name="Graph" r:id="rId6" imgW="6842908" imgH="4833106" progId="Origin50.Graph">
+                <p:oleObj name="Graph" r:id="rId10" imgW="4722409" imgH="3317966" progId="Origin50.Graph">
                   <p:embed/>
                   <p:pic>
                     <p:nvPicPr>
@@ -17680,15 +17806,15 @@
                       <p:nvPr/>
                     </p:nvPicPr>
                     <p:blipFill>
-                      <a:blip r:embed="rId7"/>
+                      <a:blip r:embed="rId11"/>
                       <a:stretch>
                         <a:fillRect/>
                       </a:stretch>
                     </p:blipFill>
                     <p:spPr>
                       <a:xfrm>
-                        <a:off x="621910" y="3745073"/>
-                        <a:ext cx="1368826" cy="966753"/>
+                        <a:off x="737074" y="3756161"/>
+                        <a:ext cx="1368826" cy="961630"/>
                       </a:xfrm>
                       <a:prstGeom prst="rect">
                         <a:avLst/>
@@ -17799,7 +17925,7 @@
         </p:nvSpPr>
         <p:spPr>
           <a:xfrm rot="19517270">
-            <a:off x="2444436" y="4020006"/>
+            <a:off x="2609536" y="4020006"/>
             <a:ext cx="534272" cy="45719"/>
           </a:xfrm>
           <a:prstGeom prst="rightArrow">
@@ -17848,7 +17974,7 @@
         </p:nvSpPr>
         <p:spPr>
           <a:xfrm>
-            <a:off x="2066766" y="4139636"/>
+            <a:off x="2231866" y="4139636"/>
             <a:ext cx="814542" cy="215444"/>
           </a:xfrm>
           <a:prstGeom prst="rect">
@@ -17903,75 +18029,6 @@
           </a:p>
         </p:txBody>
       </p:sp>
-      <p:graphicFrame>
-        <p:nvGraphicFramePr>
-          <p:cNvPr id="10" name="개체 9">
-            <a:extLst>
-              <a:ext uri="{FF2B5EF4-FFF2-40B4-BE49-F238E27FC236}">
-                <a16:creationId xmlns:a16="http://schemas.microsoft.com/office/drawing/2014/main" id="{F9A0EE38-6A53-B057-7E1B-37BE7D311465}"/>
-              </a:ext>
-            </a:extLst>
-          </p:cNvPr>
-          <p:cNvGraphicFramePr>
-            <a:graphicFrameLocks noChangeAspect="1"/>
-          </p:cNvGraphicFramePr>
-          <p:nvPr>
-            <p:extLst>
-              <p:ext uri="{D42A27DB-BD31-4B8C-83A1-F6EECF244321}">
-                <p14:modId xmlns:p14="http://schemas.microsoft.com/office/powerpoint/2010/main" val="1866029071"/>
-              </p:ext>
-            </p:extLst>
-          </p:nvPr>
-        </p:nvGraphicFramePr>
-        <p:xfrm>
-          <a:off x="621910" y="4611192"/>
-          <a:ext cx="1368826" cy="966753"/>
-        </p:xfrm>
-        <a:graphic>
-          <a:graphicData uri="http://schemas.openxmlformats.org/presentationml/2006/ole">
-            <mc:AlternateContent xmlns:mc="http://schemas.openxmlformats.org/markup-compatibility/2006">
-              <mc:Choice xmlns:v="urn:schemas-microsoft-com:vml" Requires="v">
-                <p:oleObj name="Graph" r:id="rId6" imgW="6842908" imgH="4833106" progId="Origin50.Graph">
-                  <p:embed/>
-                </p:oleObj>
-              </mc:Choice>
-              <mc:Fallback>
-                <p:oleObj name="Graph" r:id="rId6" imgW="6842908" imgH="4833106" progId="Origin50.Graph">
-                  <p:embed/>
-                  <p:pic>
-                    <p:nvPicPr>
-                      <p:cNvPr id="2" name="개체 1">
-                        <a:extLst>
-                          <a:ext uri="{FF2B5EF4-FFF2-40B4-BE49-F238E27FC236}">
-                            <a16:creationId xmlns:a16="http://schemas.microsoft.com/office/drawing/2014/main" id="{BB03A6A1-3821-096C-9A54-669D85ABAA1D}"/>
-                          </a:ext>
-                        </a:extLst>
-                      </p:cNvPr>
-                      <p:cNvPicPr/>
-                      <p:nvPr/>
-                    </p:nvPicPr>
-                    <p:blipFill>
-                      <a:blip r:embed="rId7"/>
-                      <a:stretch>
-                        <a:fillRect/>
-                      </a:stretch>
-                    </p:blipFill>
-                    <p:spPr>
-                      <a:xfrm>
-                        <a:off x="621910" y="4611192"/>
-                        <a:ext cx="1368826" cy="966753"/>
-                      </a:xfrm>
-                      <a:prstGeom prst="rect">
-                        <a:avLst/>
-                      </a:prstGeom>
-                    </p:spPr>
-                  </p:pic>
-                </p:oleObj>
-              </mc:Fallback>
-            </mc:AlternateContent>
-          </a:graphicData>
-        </a:graphic>
-      </p:graphicFrame>
       <p:sp>
         <p:nvSpPr>
           <p:cNvPr id="16" name="TextBox 15">
@@ -17986,7 +18043,7 @@
         </p:nvSpPr>
         <p:spPr>
           <a:xfrm>
-            <a:off x="660818" y="4554622"/>
+            <a:off x="660818" y="4621297"/>
             <a:ext cx="360492" cy="200055"/>
           </a:xfrm>
           <a:prstGeom prst="rect">
@@ -18014,75 +18071,146 @@
           </a:p>
         </p:txBody>
       </p:sp>
-      <p:graphicFrame>
-        <p:nvGraphicFramePr>
-          <p:cNvPr id="18" name="개체 17">
+      <p:sp>
+        <p:nvSpPr>
+          <p:cNvPr id="25" name="직사각형 24">
             <a:extLst>
               <a:ext uri="{FF2B5EF4-FFF2-40B4-BE49-F238E27FC236}">
-                <a16:creationId xmlns:a16="http://schemas.microsoft.com/office/drawing/2014/main" id="{2151DF35-4304-861B-6F61-97E3DA66E024}"/>
+                <a16:creationId xmlns:a16="http://schemas.microsoft.com/office/drawing/2014/main" id="{E9A47ABE-95C0-677B-CB4E-DB6643E6FF7F}"/>
               </a:ext>
             </a:extLst>
           </p:cNvPr>
-          <p:cNvGraphicFramePr>
-            <a:graphicFrameLocks noChangeAspect="1"/>
-          </p:cNvGraphicFramePr>
-          <p:nvPr>
-            <p:extLst>
-              <p:ext uri="{D42A27DB-BD31-4B8C-83A1-F6EECF244321}">
-                <p14:modId xmlns:p14="http://schemas.microsoft.com/office/powerpoint/2010/main" val="2142816315"/>
-              </p:ext>
-            </p:extLst>
-          </p:nvPr>
-        </p:nvGraphicFramePr>
-        <p:xfrm>
-          <a:off x="1661610" y="4611192"/>
-          <a:ext cx="1368826" cy="966753"/>
-        </p:xfrm>
-        <a:graphic>
-          <a:graphicData uri="http://schemas.openxmlformats.org/presentationml/2006/ole">
-            <mc:AlternateContent xmlns:mc="http://schemas.openxmlformats.org/markup-compatibility/2006">
-              <mc:Choice xmlns:v="urn:schemas-microsoft-com:vml" Requires="v">
-                <p:oleObj name="Graph" r:id="rId4" imgW="6842908" imgH="4833106" progId="Origin50.Graph">
-                  <p:embed/>
-                </p:oleObj>
-              </mc:Choice>
-              <mc:Fallback>
-                <p:oleObj name="Graph" r:id="rId4" imgW="6842908" imgH="4833106" progId="Origin50.Graph">
-                  <p:embed/>
-                  <p:pic>
-                    <p:nvPicPr>
-                      <p:cNvPr id="11" name="개체 10">
-                        <a:extLst>
-                          <a:ext uri="{FF2B5EF4-FFF2-40B4-BE49-F238E27FC236}">
-                            <a16:creationId xmlns:a16="http://schemas.microsoft.com/office/drawing/2014/main" id="{45DCE902-A050-7E69-600D-ADDFB21A3BA3}"/>
-                          </a:ext>
-                        </a:extLst>
-                      </p:cNvPr>
-                      <p:cNvPicPr/>
-                      <p:nvPr/>
-                    </p:nvPicPr>
-                    <p:blipFill>
-                      <a:blip r:embed="rId5"/>
-                      <a:stretch>
-                        <a:fillRect/>
-                      </a:stretch>
-                    </p:blipFill>
-                    <p:spPr>
-                      <a:xfrm>
-                        <a:off x="1661610" y="4611192"/>
-                        <a:ext cx="1368826" cy="966753"/>
-                      </a:xfrm>
-                      <a:prstGeom prst="rect">
-                        <a:avLst/>
-                      </a:prstGeom>
-                    </p:spPr>
-                  </p:pic>
-                </p:oleObj>
-              </mc:Fallback>
-            </mc:AlternateContent>
-          </a:graphicData>
-        </a:graphic>
-      </p:graphicFrame>
+          <p:cNvSpPr/>
+          <p:nvPr/>
+        </p:nvSpPr>
+        <p:spPr>
+          <a:xfrm>
+            <a:off x="2012949" y="5149850"/>
+            <a:ext cx="238665" cy="242259"/>
+          </a:xfrm>
+          <a:prstGeom prst="rect">
+            <a:avLst/>
+          </a:prstGeom>
+          <a:noFill/>
+          <a:ln w="6350">
+            <a:solidFill>
+              <a:schemeClr val="tx1"/>
+            </a:solidFill>
+          </a:ln>
+        </p:spPr>
+        <p:style>
+          <a:lnRef idx="2">
+            <a:schemeClr val="accent1">
+              <a:shade val="15000"/>
+            </a:schemeClr>
+          </a:lnRef>
+          <a:fillRef idx="1">
+            <a:schemeClr val="accent1"/>
+          </a:fillRef>
+          <a:effectRef idx="0">
+            <a:schemeClr val="accent1"/>
+          </a:effectRef>
+          <a:fontRef idx="minor">
+            <a:schemeClr val="lt1"/>
+          </a:fontRef>
+        </p:style>
+        <p:txBody>
+          <a:bodyPr rtlCol="0" anchor="ctr"/>
+          <a:lstStyle/>
+          <a:p>
+            <a:pPr algn="ctr"/>
+            <a:endParaRPr lang="ko-KR" altLang="en-US"/>
+          </a:p>
+        </p:txBody>
+      </p:sp>
+      <p:cxnSp>
+        <p:nvCxnSpPr>
+          <p:cNvPr id="27" name="직선 연결선 26">
+            <a:extLst>
+              <a:ext uri="{FF2B5EF4-FFF2-40B4-BE49-F238E27FC236}">
+                <a16:creationId xmlns:a16="http://schemas.microsoft.com/office/drawing/2014/main" id="{528E910E-B2B4-A2E9-7351-CA30BE9DE009}"/>
+              </a:ext>
+            </a:extLst>
+          </p:cNvPr>
+          <p:cNvCxnSpPr>
+            <a:cxnSpLocks/>
+          </p:cNvCxnSpPr>
+          <p:nvPr/>
+        </p:nvCxnSpPr>
+        <p:spPr>
+          <a:xfrm flipV="1">
+            <a:off x="2251614" y="4781550"/>
+            <a:ext cx="234411" cy="368300"/>
+          </a:xfrm>
+          <a:prstGeom prst="line">
+            <a:avLst/>
+          </a:prstGeom>
+          <a:ln w="6350">
+            <a:solidFill>
+              <a:schemeClr val="tx1"/>
+            </a:solidFill>
+            <a:prstDash val="sysDash"/>
+          </a:ln>
+        </p:spPr>
+        <p:style>
+          <a:lnRef idx="2">
+            <a:schemeClr val="accent1"/>
+          </a:lnRef>
+          <a:fillRef idx="0">
+            <a:schemeClr val="accent1"/>
+          </a:fillRef>
+          <a:effectRef idx="1">
+            <a:schemeClr val="accent1"/>
+          </a:effectRef>
+          <a:fontRef idx="minor">
+            <a:schemeClr val="tx1"/>
+          </a:fontRef>
+        </p:style>
+      </p:cxnSp>
+      <p:cxnSp>
+        <p:nvCxnSpPr>
+          <p:cNvPr id="29" name="직선 연결선 28">
+            <a:extLst>
+              <a:ext uri="{FF2B5EF4-FFF2-40B4-BE49-F238E27FC236}">
+                <a16:creationId xmlns:a16="http://schemas.microsoft.com/office/drawing/2014/main" id="{BC106F22-67FA-AE1F-0DC2-529C21D90753}"/>
+              </a:ext>
+            </a:extLst>
+          </p:cNvPr>
+          <p:cNvCxnSpPr>
+            <a:cxnSpLocks/>
+          </p:cNvCxnSpPr>
+          <p:nvPr/>
+        </p:nvCxnSpPr>
+        <p:spPr>
+          <a:xfrm flipV="1">
+            <a:off x="2251614" y="5353246"/>
+            <a:ext cx="234411" cy="38863"/>
+          </a:xfrm>
+          <a:prstGeom prst="line">
+            <a:avLst/>
+          </a:prstGeom>
+          <a:ln w="6350">
+            <a:solidFill>
+              <a:schemeClr val="tx1"/>
+            </a:solidFill>
+            <a:prstDash val="sysDash"/>
+          </a:ln>
+        </p:spPr>
+        <p:style>
+          <a:lnRef idx="2">
+            <a:schemeClr val="accent1"/>
+          </a:lnRef>
+          <a:fillRef idx="0">
+            <a:schemeClr val="accent1"/>
+          </a:fillRef>
+          <a:effectRef idx="1">
+            <a:schemeClr val="accent1"/>
+          </a:effectRef>
+          <a:fontRef idx="minor">
+            <a:schemeClr val="tx1"/>
+          </a:fontRef>
+        </p:style>
+      </p:cxnSp>
     </p:spTree>
     <p:extLst>
       <p:ext uri="{BB962C8B-B14F-4D97-AF65-F5344CB8AC3E}">

</xml_diff>

<commit_message>
Revision submission revised manuscript for MAJOR is ready in first. Need careful overview before revision submission.
</commit_message>
<xml_diff>
--- a/figures/Figures-EDL202605-manuscript.pptx
+++ b/figures/Figures-EDL202605-manuscript.pptx
@@ -5,13 +5,14 @@
     <p:sldMasterId id="2147483660" r:id="rId1"/>
   </p:sldMasterIdLst>
   <p:notesMasterIdLst>
-    <p:notesMasterId r:id="rId6"/>
+    <p:notesMasterId r:id="rId7"/>
   </p:notesMasterIdLst>
   <p:sldIdLst>
     <p:sldId id="256" r:id="rId2"/>
     <p:sldId id="294" r:id="rId3"/>
     <p:sldId id="298" r:id="rId4"/>
     <p:sldId id="297" r:id="rId5"/>
+    <p:sldId id="299" r:id="rId6"/>
   </p:sldIdLst>
   <p:sldSz cx="6858000" cy="9906000" type="A4"/>
   <p:notesSz cx="6858000" cy="9144000"/>
@@ -208,7 +209,7 @@
           <a:p>
             <a:fld id="{AA311422-0C2E-42D7-924E-F365B5A34ABC}" type="datetimeFigureOut">
               <a:rPr lang="ko-KR" altLang="en-US" smtClean="0"/>
-              <a:t>2026-06-07</a:t>
+              <a:t>2026-06-09</a:t>
             </a:fld>
             <a:endParaRPr lang="ko-KR" altLang="en-US"/>
           </a:p>
@@ -606,7 +607,7 @@
           <a:p>
             <a:fld id="{038C53AF-CD6D-418E-B451-BA3CFECC6915}" type="datetimeFigureOut">
               <a:rPr lang="ko-KR" altLang="en-US" smtClean="0"/>
-              <a:t>2026-06-07</a:t>
+              <a:t>2026-06-09</a:t>
             </a:fld>
             <a:endParaRPr lang="ko-KR" altLang="en-US"/>
           </a:p>
@@ -776,7 +777,7 @@
           <a:p>
             <a:fld id="{038C53AF-CD6D-418E-B451-BA3CFECC6915}" type="datetimeFigureOut">
               <a:rPr lang="ko-KR" altLang="en-US" smtClean="0"/>
-              <a:t>2026-06-07</a:t>
+              <a:t>2026-06-09</a:t>
             </a:fld>
             <a:endParaRPr lang="ko-KR" altLang="en-US"/>
           </a:p>
@@ -956,7 +957,7 @@
           <a:p>
             <a:fld id="{038C53AF-CD6D-418E-B451-BA3CFECC6915}" type="datetimeFigureOut">
               <a:rPr lang="ko-KR" altLang="en-US" smtClean="0"/>
-              <a:t>2026-06-07</a:t>
+              <a:t>2026-06-09</a:t>
             </a:fld>
             <a:endParaRPr lang="ko-KR" altLang="en-US"/>
           </a:p>
@@ -1126,7 +1127,7 @@
           <a:p>
             <a:fld id="{038C53AF-CD6D-418E-B451-BA3CFECC6915}" type="datetimeFigureOut">
               <a:rPr lang="ko-KR" altLang="en-US" smtClean="0"/>
-              <a:t>2026-06-07</a:t>
+              <a:t>2026-06-09</a:t>
             </a:fld>
             <a:endParaRPr lang="ko-KR" altLang="en-US"/>
           </a:p>
@@ -1184,6 +1185,22 @@
   <p:clrMapOvr>
     <a:masterClrMapping/>
   </p:clrMapOvr>
+  <p:extLst>
+    <p:ext uri="{DCECCB84-F9BA-43D5-87BE-67443E8EF086}">
+      <p15:sldGuideLst xmlns:p15="http://schemas.microsoft.com/office/powerpoint/2012/main">
+        <p15:guide id="1" orient="horz" pos="3120" userDrawn="1">
+          <p15:clr>
+            <a:srgbClr val="FBAE40"/>
+          </p15:clr>
+        </p15:guide>
+        <p15:guide id="2" pos="2160" userDrawn="1">
+          <p15:clr>
+            <a:srgbClr val="FBAE40"/>
+          </p15:clr>
+        </p15:guide>
+      </p15:sldGuideLst>
+    </p:ext>
+  </p:extLst>
 </p:sldLayout>
 </file>
 
@@ -1372,7 +1389,7 @@
           <a:p>
             <a:fld id="{038C53AF-CD6D-418E-B451-BA3CFECC6915}" type="datetimeFigureOut">
               <a:rPr lang="ko-KR" altLang="en-US" smtClean="0"/>
-              <a:t>2026-06-07</a:t>
+              <a:t>2026-06-09</a:t>
             </a:fld>
             <a:endParaRPr lang="ko-KR" altLang="en-US"/>
           </a:p>
@@ -1604,7 +1621,7 @@
           <a:p>
             <a:fld id="{038C53AF-CD6D-418E-B451-BA3CFECC6915}" type="datetimeFigureOut">
               <a:rPr lang="ko-KR" altLang="en-US" smtClean="0"/>
-              <a:t>2026-06-07</a:t>
+              <a:t>2026-06-09</a:t>
             </a:fld>
             <a:endParaRPr lang="ko-KR" altLang="en-US"/>
           </a:p>
@@ -1971,7 +1988,7 @@
           <a:p>
             <a:fld id="{038C53AF-CD6D-418E-B451-BA3CFECC6915}" type="datetimeFigureOut">
               <a:rPr lang="ko-KR" altLang="en-US" smtClean="0"/>
-              <a:t>2026-06-07</a:t>
+              <a:t>2026-06-09</a:t>
             </a:fld>
             <a:endParaRPr lang="ko-KR" altLang="en-US"/>
           </a:p>
@@ -2089,7 +2106,7 @@
           <a:p>
             <a:fld id="{038C53AF-CD6D-418E-B451-BA3CFECC6915}" type="datetimeFigureOut">
               <a:rPr lang="ko-KR" altLang="en-US" smtClean="0"/>
-              <a:t>2026-06-07</a:t>
+              <a:t>2026-06-09</a:t>
             </a:fld>
             <a:endParaRPr lang="ko-KR" altLang="en-US"/>
           </a:p>
@@ -2184,7 +2201,7 @@
           <a:p>
             <a:fld id="{038C53AF-CD6D-418E-B451-BA3CFECC6915}" type="datetimeFigureOut">
               <a:rPr lang="ko-KR" altLang="en-US" smtClean="0"/>
-              <a:t>2026-06-07</a:t>
+              <a:t>2026-06-09</a:t>
             </a:fld>
             <a:endParaRPr lang="ko-KR" altLang="en-US"/>
           </a:p>
@@ -2461,7 +2478,7 @@
           <a:p>
             <a:fld id="{038C53AF-CD6D-418E-B451-BA3CFECC6915}" type="datetimeFigureOut">
               <a:rPr lang="ko-KR" altLang="en-US" smtClean="0"/>
-              <a:t>2026-06-07</a:t>
+              <a:t>2026-06-09</a:t>
             </a:fld>
             <a:endParaRPr lang="ko-KR" altLang="en-US"/>
           </a:p>
@@ -2718,7 +2735,7 @@
           <a:p>
             <a:fld id="{038C53AF-CD6D-418E-B451-BA3CFECC6915}" type="datetimeFigureOut">
               <a:rPr lang="ko-KR" altLang="en-US" smtClean="0"/>
-              <a:t>2026-06-07</a:t>
+              <a:t>2026-06-09</a:t>
             </a:fld>
             <a:endParaRPr lang="ko-KR" altLang="en-US"/>
           </a:p>
@@ -2931,7 +2948,7 @@
           <a:p>
             <a:fld id="{038C53AF-CD6D-418E-B451-BA3CFECC6915}" type="datetimeFigureOut">
               <a:rPr lang="ko-KR" altLang="en-US" smtClean="0"/>
-              <a:t>2026-06-07</a:t>
+              <a:t>2026-06-09</a:t>
             </a:fld>
             <a:endParaRPr lang="ko-KR" altLang="en-US"/>
           </a:p>
@@ -11748,7 +11765,7 @@
           <p:nvPr>
             <p:extLst>
               <p:ext uri="{D42A27DB-BD31-4B8C-83A1-F6EECF244321}">
-                <p14:modId xmlns:p14="http://schemas.microsoft.com/office/powerpoint/2010/main" val="301811885"/>
+                <p14:modId xmlns:p14="http://schemas.microsoft.com/office/powerpoint/2010/main" val="1966354765"/>
               </p:ext>
             </p:extLst>
           </p:nvPr>
@@ -13060,7 +13077,7 @@
           <p:nvPr>
             <p:extLst>
               <p:ext uri="{D42A27DB-BD31-4B8C-83A1-F6EECF244321}">
-                <p14:modId xmlns:p14="http://schemas.microsoft.com/office/powerpoint/2010/main" val="4059224792"/>
+                <p14:modId xmlns:p14="http://schemas.microsoft.com/office/powerpoint/2010/main" val="3932695148"/>
               </p:ext>
             </p:extLst>
           </p:nvPr>
@@ -13114,8 +13131,8 @@
           </a:graphicData>
         </a:graphic>
       </p:graphicFrame>
-      <mc:AlternateContent xmlns:mc="http://schemas.openxmlformats.org/markup-compatibility/2006" xmlns:a14="http://schemas.microsoft.com/office/drawing/2010/main">
-        <mc:Choice Requires="a14">
+      <mc:AlternateContent xmlns:mc="http://schemas.openxmlformats.org/markup-compatibility/2006">
+        <mc:Choice xmlns:a14="http://schemas.microsoft.com/office/drawing/2010/main" Requires="a14">
           <p:sp>
             <p:nvSpPr>
               <p:cNvPr id="7" name="TextBox 6">
@@ -13375,7 +13392,7 @@
             </p:txBody>
           </p:sp>
         </mc:Choice>
-        <mc:Fallback xmlns="">
+        <mc:Fallback>
           <p:sp>
             <p:nvSpPr>
               <p:cNvPr id="7" name="TextBox 6">
@@ -13420,8 +13437,8 @@
           </p:sp>
         </mc:Fallback>
       </mc:AlternateContent>
-      <mc:AlternateContent xmlns:mc="http://schemas.openxmlformats.org/markup-compatibility/2006" xmlns:a14="http://schemas.microsoft.com/office/drawing/2010/main">
-        <mc:Choice Requires="a14">
+      <mc:AlternateContent xmlns:mc="http://schemas.openxmlformats.org/markup-compatibility/2006">
+        <mc:Choice xmlns:a14="http://schemas.microsoft.com/office/drawing/2010/main" Requires="a14">
           <p:sp>
             <p:nvSpPr>
               <p:cNvPr id="11" name="TextBox 10">
@@ -13681,7 +13698,7 @@
             </p:txBody>
           </p:sp>
         </mc:Choice>
-        <mc:Fallback xmlns="">
+        <mc:Fallback>
           <p:sp>
             <p:nvSpPr>
               <p:cNvPr id="11" name="TextBox 10">
@@ -13973,7 +13990,7 @@
           <p:nvPr>
             <p:extLst>
               <p:ext uri="{D42A27DB-BD31-4B8C-83A1-F6EECF244321}">
-                <p14:modId xmlns:p14="http://schemas.microsoft.com/office/powerpoint/2010/main" val="2942027410"/>
+                <p14:modId xmlns:p14="http://schemas.microsoft.com/office/powerpoint/2010/main" val="1195729805"/>
               </p:ext>
             </p:extLst>
           </p:nvPr>
@@ -15258,7 +15275,7 @@
           <p:nvPr>
             <p:extLst>
               <p:ext uri="{D42A27DB-BD31-4B8C-83A1-F6EECF244321}">
-                <p14:modId xmlns:p14="http://schemas.microsoft.com/office/powerpoint/2010/main" val="2755199149"/>
+                <p14:modId xmlns:p14="http://schemas.microsoft.com/office/powerpoint/2010/main" val="859739522"/>
               </p:ext>
             </p:extLst>
           </p:nvPr>
@@ -15491,8 +15508,8 @@
         </p:nvSpPr>
         <p:spPr>
           <a:xfrm>
-            <a:off x="1364141" y="3282160"/>
-            <a:ext cx="744510" cy="523220"/>
+            <a:off x="1364141" y="3187716"/>
+            <a:ext cx="670565" cy="630942"/>
           </a:xfrm>
           <a:prstGeom prst="rect">
             <a:avLst/>
@@ -15510,7 +15527,7 @@
                 <a:latin typeface="Arial" panose="020B0604020202020204" pitchFamily="34" charset="0"/>
                 <a:cs typeface="Arial" panose="020B0604020202020204" pitchFamily="34" charset="0"/>
               </a:rPr>
-              <a:t>Radial charge distribution modeled as [6], [7]</a:t>
+              <a:t>TCAD-aligned model consistent with [6], [7]</a:t>
             </a:r>
             <a:endParaRPr lang="ko-KR" altLang="en-US" sz="700" dirty="0">
               <a:latin typeface="Arial" panose="020B0604020202020204" pitchFamily="34" charset="0"/>
@@ -15534,7 +15551,7 @@
           <p:nvPr>
             <p:extLst>
               <p:ext uri="{D42A27DB-BD31-4B8C-83A1-F6EECF244321}">
-                <p14:modId xmlns:p14="http://schemas.microsoft.com/office/powerpoint/2010/main" val="3994320999"/>
+                <p14:modId xmlns:p14="http://schemas.microsoft.com/office/powerpoint/2010/main" val="1970585430"/>
               </p:ext>
             </p:extLst>
           </p:nvPr>
@@ -16664,7 +16681,7 @@
         </p:nvGraphicFramePr>
         <p:xfrm>
           <a:off x="4966814" y="3838582"/>
-          <a:ext cx="1490637" cy="563880"/>
+          <a:ext cx="1490637" cy="670560"/>
         </p:xfrm>
         <a:graphic>
           <a:graphicData uri="http://schemas.openxmlformats.org/drawingml/2006/table">
@@ -18224,6 +18241,605 @@
 </p:sld>
 </file>
 
+<file path=ppt/slides/slide5.xml><?xml version="1.0" encoding="utf-8"?>
+<p:sld xmlns:a="http://schemas.openxmlformats.org/drawingml/2006/main" xmlns:r="http://schemas.openxmlformats.org/officeDocument/2006/relationships" xmlns:p="http://schemas.openxmlformats.org/presentationml/2006/main">
+  <p:cSld>
+    <p:spTree>
+      <p:nvGrpSpPr>
+        <p:cNvPr id="1" name=""/>
+        <p:cNvGrpSpPr/>
+        <p:nvPr/>
+      </p:nvGrpSpPr>
+      <p:grpSpPr>
+        <a:xfrm>
+          <a:off x="0" y="0"/>
+          <a:ext cx="0" cy="0"/>
+          <a:chOff x="0" y="0"/>
+          <a:chExt cx="0" cy="0"/>
+        </a:xfrm>
+      </p:grpSpPr>
+      <p:graphicFrame>
+        <p:nvGraphicFramePr>
+          <p:cNvPr id="32" name="개체 31">
+            <a:extLst>
+              <a:ext uri="{FF2B5EF4-FFF2-40B4-BE49-F238E27FC236}">
+                <a16:creationId xmlns:a16="http://schemas.microsoft.com/office/drawing/2014/main" id="{182D6282-E3E8-909A-1F25-13A2D96A3A66}"/>
+              </a:ext>
+            </a:extLst>
+          </p:cNvPr>
+          <p:cNvGraphicFramePr>
+            <a:graphicFrameLocks noChangeAspect="1"/>
+          </p:cNvGraphicFramePr>
+          <p:nvPr>
+            <p:extLst>
+              <p:ext uri="{D42A27DB-BD31-4B8C-83A1-F6EECF244321}">
+                <p14:modId xmlns:p14="http://schemas.microsoft.com/office/powerpoint/2010/main" val="2733173846"/>
+              </p:ext>
+            </p:extLst>
+          </p:nvPr>
+        </p:nvGraphicFramePr>
+        <p:xfrm>
+          <a:off x="1132234" y="8040978"/>
+          <a:ext cx="2487612" cy="1758259"/>
+        </p:xfrm>
+        <a:graphic>
+          <a:graphicData uri="http://schemas.openxmlformats.org/presentationml/2006/ole">
+            <mc:AlternateContent xmlns:mc="http://schemas.openxmlformats.org/markup-compatibility/2006">
+              <mc:Choice xmlns:v="urn:schemas-microsoft-com:vml" Requires="v">
+                <p:oleObj name="Graph" r:id="rId2" imgW="4851068" imgH="3429000" progId="Origin50.Graph">
+                  <p:embed/>
+                </p:oleObj>
+              </mc:Choice>
+              <mc:Fallback>
+                <p:oleObj name="Graph" r:id="rId2" imgW="4851068" imgH="3429000" progId="Origin50.Graph">
+                  <p:embed/>
+                  <p:pic>
+                    <p:nvPicPr>
+                      <p:cNvPr id="0" name=""/>
+                      <p:cNvPicPr/>
+                      <p:nvPr/>
+                    </p:nvPicPr>
+                    <p:blipFill>
+                      <a:blip r:embed="rId3"/>
+                      <a:stretch>
+                        <a:fillRect/>
+                      </a:stretch>
+                    </p:blipFill>
+                    <p:spPr>
+                      <a:xfrm>
+                        <a:off x="1132234" y="8040978"/>
+                        <a:ext cx="2487612" cy="1758259"/>
+                      </a:xfrm>
+                      <a:prstGeom prst="rect">
+                        <a:avLst/>
+                      </a:prstGeom>
+                    </p:spPr>
+                  </p:pic>
+                </p:oleObj>
+              </mc:Fallback>
+            </mc:AlternateContent>
+          </a:graphicData>
+        </a:graphic>
+      </p:graphicFrame>
+      <p:graphicFrame>
+        <p:nvGraphicFramePr>
+          <p:cNvPr id="31" name="개체 30">
+            <a:extLst>
+              <a:ext uri="{FF2B5EF4-FFF2-40B4-BE49-F238E27FC236}">
+                <a16:creationId xmlns:a16="http://schemas.microsoft.com/office/drawing/2014/main" id="{BDB953E9-D719-F718-37AF-E462B8A91AF9}"/>
+              </a:ext>
+            </a:extLst>
+          </p:cNvPr>
+          <p:cNvGraphicFramePr>
+            <a:graphicFrameLocks noChangeAspect="1"/>
+          </p:cNvGraphicFramePr>
+          <p:nvPr>
+            <p:extLst>
+              <p:ext uri="{D42A27DB-BD31-4B8C-83A1-F6EECF244321}">
+                <p14:modId xmlns:p14="http://schemas.microsoft.com/office/powerpoint/2010/main" val="2583750849"/>
+              </p:ext>
+            </p:extLst>
+          </p:nvPr>
+        </p:nvGraphicFramePr>
+        <p:xfrm>
+          <a:off x="3530599" y="8041552"/>
+          <a:ext cx="2487613" cy="1757685"/>
+        </p:xfrm>
+        <a:graphic>
+          <a:graphicData uri="http://schemas.openxmlformats.org/presentationml/2006/ole">
+            <mc:AlternateContent xmlns:mc="http://schemas.openxmlformats.org/markup-compatibility/2006">
+              <mc:Choice xmlns:v="urn:schemas-microsoft-com:vml" Requires="v">
+                <p:oleObj name="Graph" r:id="rId4" imgW="4852293" imgH="3429000" progId="Origin50.Graph">
+                  <p:embed/>
+                </p:oleObj>
+              </mc:Choice>
+              <mc:Fallback>
+                <p:oleObj name="Graph" r:id="rId4" imgW="4852293" imgH="3429000" progId="Origin50.Graph">
+                  <p:embed/>
+                  <p:pic>
+                    <p:nvPicPr>
+                      <p:cNvPr id="0" name=""/>
+                      <p:cNvPicPr/>
+                      <p:nvPr/>
+                    </p:nvPicPr>
+                    <p:blipFill>
+                      <a:blip r:embed="rId5"/>
+                      <a:stretch>
+                        <a:fillRect/>
+                      </a:stretch>
+                    </p:blipFill>
+                    <p:spPr>
+                      <a:xfrm>
+                        <a:off x="3530599" y="8041552"/>
+                        <a:ext cx="2487613" cy="1757685"/>
+                      </a:xfrm>
+                      <a:prstGeom prst="rect">
+                        <a:avLst/>
+                      </a:prstGeom>
+                    </p:spPr>
+                  </p:pic>
+                </p:oleObj>
+              </mc:Fallback>
+            </mc:AlternateContent>
+          </a:graphicData>
+        </a:graphic>
+      </p:graphicFrame>
+      <p:sp>
+        <p:nvSpPr>
+          <p:cNvPr id="2" name="제목 1">
+            <a:extLst>
+              <a:ext uri="{FF2B5EF4-FFF2-40B4-BE49-F238E27FC236}">
+                <a16:creationId xmlns:a16="http://schemas.microsoft.com/office/drawing/2014/main" id="{F04D3859-0CF6-1300-F0C2-CADA24F78307}"/>
+              </a:ext>
+            </a:extLst>
+          </p:cNvPr>
+          <p:cNvSpPr>
+            <a:spLocks noGrp="1"/>
+          </p:cNvSpPr>
+          <p:nvPr>
+            <p:ph type="title"/>
+          </p:nvPr>
+        </p:nvSpPr>
+        <p:spPr/>
+        <p:txBody>
+          <a:bodyPr/>
+          <a:lstStyle/>
+          <a:p>
+            <a:r>
+              <a:rPr lang="en-US" altLang="ko-KR" dirty="0"/>
+              <a:t>Revision</a:t>
+            </a:r>
+            <a:endParaRPr lang="ko-KR" altLang="en-US" dirty="0"/>
+          </a:p>
+        </p:txBody>
+      </p:sp>
+      <p:graphicFrame>
+        <p:nvGraphicFramePr>
+          <p:cNvPr id="4" name="개체 3">
+            <a:extLst>
+              <a:ext uri="{FF2B5EF4-FFF2-40B4-BE49-F238E27FC236}">
+                <a16:creationId xmlns:a16="http://schemas.microsoft.com/office/drawing/2014/main" id="{8AC4FE14-0D79-E56D-1C85-BEDED72A21C0}"/>
+              </a:ext>
+            </a:extLst>
+          </p:cNvPr>
+          <p:cNvGraphicFramePr>
+            <a:graphicFrameLocks noChangeAspect="1"/>
+          </p:cNvGraphicFramePr>
+          <p:nvPr>
+            <p:extLst>
+              <p:ext uri="{D42A27DB-BD31-4B8C-83A1-F6EECF244321}">
+                <p14:modId xmlns:p14="http://schemas.microsoft.com/office/powerpoint/2010/main" val="941247928"/>
+              </p:ext>
+            </p:extLst>
+          </p:nvPr>
+        </p:nvGraphicFramePr>
+        <p:xfrm>
+          <a:off x="802548" y="2597417"/>
+          <a:ext cx="2561299" cy="1809750"/>
+        </p:xfrm>
+        <a:graphic>
+          <a:graphicData uri="http://schemas.openxmlformats.org/presentationml/2006/ole">
+            <mc:AlternateContent xmlns:mc="http://schemas.openxmlformats.org/markup-compatibility/2006">
+              <mc:Choice xmlns:v="urn:schemas-microsoft-com:vml" Requires="v">
+                <p:oleObj name="Graph" r:id="rId6" imgW="4852293" imgH="3429000" progId="Origin50.Graph">
+                  <p:embed/>
+                </p:oleObj>
+              </mc:Choice>
+              <mc:Fallback>
+                <p:oleObj name="Graph" r:id="rId6" imgW="4852293" imgH="3429000" progId="Origin50.Graph">
+                  <p:embed/>
+                  <p:pic>
+                    <p:nvPicPr>
+                      <p:cNvPr id="0" name=""/>
+                      <p:cNvPicPr/>
+                      <p:nvPr/>
+                    </p:nvPicPr>
+                    <p:blipFill>
+                      <a:blip r:embed="rId7"/>
+                      <a:stretch>
+                        <a:fillRect/>
+                      </a:stretch>
+                    </p:blipFill>
+                    <p:spPr>
+                      <a:xfrm>
+                        <a:off x="802548" y="2597417"/>
+                        <a:ext cx="2561299" cy="1809750"/>
+                      </a:xfrm>
+                      <a:prstGeom prst="rect">
+                        <a:avLst/>
+                      </a:prstGeom>
+                    </p:spPr>
+                  </p:pic>
+                </p:oleObj>
+              </mc:Fallback>
+            </mc:AlternateContent>
+          </a:graphicData>
+        </a:graphic>
+      </p:graphicFrame>
+      <p:graphicFrame>
+        <p:nvGraphicFramePr>
+          <p:cNvPr id="5" name="개체 4">
+            <a:extLst>
+              <a:ext uri="{FF2B5EF4-FFF2-40B4-BE49-F238E27FC236}">
+                <a16:creationId xmlns:a16="http://schemas.microsoft.com/office/drawing/2014/main" id="{9ABD4DAC-BDDE-593E-7E10-7C3357AD30F1}"/>
+              </a:ext>
+            </a:extLst>
+          </p:cNvPr>
+          <p:cNvGraphicFramePr>
+            <a:graphicFrameLocks noChangeAspect="1"/>
+          </p:cNvGraphicFramePr>
+          <p:nvPr>
+            <p:extLst>
+              <p:ext uri="{D42A27DB-BD31-4B8C-83A1-F6EECF244321}">
+                <p14:modId xmlns:p14="http://schemas.microsoft.com/office/powerpoint/2010/main" val="3121292718"/>
+              </p:ext>
+            </p:extLst>
+          </p:nvPr>
+        </p:nvGraphicFramePr>
+        <p:xfrm>
+          <a:off x="3594530" y="2597417"/>
+          <a:ext cx="2561299" cy="1809750"/>
+        </p:xfrm>
+        <a:graphic>
+          <a:graphicData uri="http://schemas.openxmlformats.org/presentationml/2006/ole">
+            <mc:AlternateContent xmlns:mc="http://schemas.openxmlformats.org/markup-compatibility/2006">
+              <mc:Choice xmlns:v="urn:schemas-microsoft-com:vml" Requires="v">
+                <p:oleObj name="Graph" r:id="rId8" imgW="4852293" imgH="3429000" progId="Origin50.Graph">
+                  <p:embed/>
+                </p:oleObj>
+              </mc:Choice>
+              <mc:Fallback>
+                <p:oleObj name="Graph" r:id="rId8" imgW="4852293" imgH="3429000" progId="Origin50.Graph">
+                  <p:embed/>
+                  <p:pic>
+                    <p:nvPicPr>
+                      <p:cNvPr id="0" name=""/>
+                      <p:cNvPicPr/>
+                      <p:nvPr/>
+                    </p:nvPicPr>
+                    <p:blipFill>
+                      <a:blip r:embed="rId9"/>
+                      <a:stretch>
+                        <a:fillRect/>
+                      </a:stretch>
+                    </p:blipFill>
+                    <p:spPr>
+                      <a:xfrm>
+                        <a:off x="3594530" y="2597417"/>
+                        <a:ext cx="2561299" cy="1809750"/>
+                      </a:xfrm>
+                      <a:prstGeom prst="rect">
+                        <a:avLst/>
+                      </a:prstGeom>
+                    </p:spPr>
+                  </p:pic>
+                </p:oleObj>
+              </mc:Fallback>
+            </mc:AlternateContent>
+          </a:graphicData>
+        </a:graphic>
+      </p:graphicFrame>
+      <p:sp>
+        <p:nvSpPr>
+          <p:cNvPr id="7" name="TextBox 6">
+            <a:extLst>
+              <a:ext uri="{FF2B5EF4-FFF2-40B4-BE49-F238E27FC236}">
+                <a16:creationId xmlns:a16="http://schemas.microsoft.com/office/drawing/2014/main" id="{FE23A317-EEB9-0A7A-AC50-9BE82E16C416}"/>
+              </a:ext>
+            </a:extLst>
+          </p:cNvPr>
+          <p:cNvSpPr txBox="1"/>
+          <p:nvPr/>
+        </p:nvSpPr>
+        <p:spPr>
+          <a:xfrm>
+            <a:off x="728663" y="2205038"/>
+            <a:ext cx="2105025" cy="369332"/>
+          </a:xfrm>
+          <a:prstGeom prst="rect">
+            <a:avLst/>
+          </a:prstGeom>
+          <a:noFill/>
+        </p:spPr>
+        <p:txBody>
+          <a:bodyPr wrap="square" rtlCol="0">
+            <a:spAutoFit/>
+          </a:bodyPr>
+          <a:lstStyle/>
+          <a:p>
+            <a:r>
+              <a:rPr lang="en-US" altLang="ko-KR" dirty="0"/>
+              <a:t>R1</a:t>
+            </a:r>
+            <a:endParaRPr lang="ko-KR" altLang="en-US" dirty="0"/>
+          </a:p>
+        </p:txBody>
+      </p:sp>
+      <p:sp>
+        <p:nvSpPr>
+          <p:cNvPr id="8" name="TextBox 7">
+            <a:extLst>
+              <a:ext uri="{FF2B5EF4-FFF2-40B4-BE49-F238E27FC236}">
+                <a16:creationId xmlns:a16="http://schemas.microsoft.com/office/drawing/2014/main" id="{8BCE7BD2-FCEB-2A0F-9F53-6DC4EAA608CE}"/>
+              </a:ext>
+            </a:extLst>
+          </p:cNvPr>
+          <p:cNvSpPr txBox="1"/>
+          <p:nvPr/>
+        </p:nvSpPr>
+        <p:spPr>
+          <a:xfrm>
+            <a:off x="728663" y="4695826"/>
+            <a:ext cx="2105025" cy="369332"/>
+          </a:xfrm>
+          <a:prstGeom prst="rect">
+            <a:avLst/>
+          </a:prstGeom>
+          <a:noFill/>
+        </p:spPr>
+        <p:txBody>
+          <a:bodyPr wrap="square" rtlCol="0">
+            <a:spAutoFit/>
+          </a:bodyPr>
+          <a:lstStyle/>
+          <a:p>
+            <a:r>
+              <a:rPr lang="en-US" altLang="ko-KR" dirty="0"/>
+              <a:t>R2</a:t>
+            </a:r>
+            <a:endParaRPr lang="ko-KR" altLang="en-US" dirty="0"/>
+          </a:p>
+        </p:txBody>
+      </p:sp>
+      <p:pic>
+        <p:nvPicPr>
+          <p:cNvPr id="10" name="그림 9">
+            <a:extLst>
+              <a:ext uri="{FF2B5EF4-FFF2-40B4-BE49-F238E27FC236}">
+                <a16:creationId xmlns:a16="http://schemas.microsoft.com/office/drawing/2014/main" id="{360D860C-1B2F-0997-E176-C066E529825A}"/>
+              </a:ext>
+            </a:extLst>
+          </p:cNvPr>
+          <p:cNvPicPr>
+            <a:picLocks noChangeAspect="1"/>
+          </p:cNvPicPr>
+          <p:nvPr/>
+        </p:nvPicPr>
+        <p:blipFill>
+          <a:blip r:embed="rId10"/>
+          <a:stretch>
+            <a:fillRect/>
+          </a:stretch>
+        </p:blipFill>
+        <p:spPr>
+          <a:xfrm>
+            <a:off x="1323975" y="6084624"/>
+            <a:ext cx="2534148" cy="601632"/>
+          </a:xfrm>
+          <a:prstGeom prst="rect">
+            <a:avLst/>
+          </a:prstGeom>
+        </p:spPr>
+      </p:pic>
+      <p:pic>
+        <p:nvPicPr>
+          <p:cNvPr id="12" name="그림 11">
+            <a:extLst>
+              <a:ext uri="{FF2B5EF4-FFF2-40B4-BE49-F238E27FC236}">
+                <a16:creationId xmlns:a16="http://schemas.microsoft.com/office/drawing/2014/main" id="{AF43AFDB-EF8D-169F-46B2-1E6201A6B247}"/>
+              </a:ext>
+            </a:extLst>
+          </p:cNvPr>
+          <p:cNvPicPr>
+            <a:picLocks noChangeAspect="1"/>
+          </p:cNvPicPr>
+          <p:nvPr/>
+        </p:nvPicPr>
+        <p:blipFill>
+          <a:blip r:embed="rId11"/>
+          <a:stretch>
+            <a:fillRect/>
+          </a:stretch>
+        </p:blipFill>
+        <p:spPr>
+          <a:xfrm>
+            <a:off x="1323082" y="5065157"/>
+            <a:ext cx="2105918" cy="678417"/>
+          </a:xfrm>
+          <a:prstGeom prst="rect">
+            <a:avLst/>
+          </a:prstGeom>
+        </p:spPr>
+      </p:pic>
+      <p:pic>
+        <p:nvPicPr>
+          <p:cNvPr id="14" name="그림 13">
+            <a:extLst>
+              <a:ext uri="{FF2B5EF4-FFF2-40B4-BE49-F238E27FC236}">
+                <a16:creationId xmlns:a16="http://schemas.microsoft.com/office/drawing/2014/main" id="{8C9C9B69-3016-63E8-CDE0-6D69A6AC3F62}"/>
+              </a:ext>
+            </a:extLst>
+          </p:cNvPr>
+          <p:cNvPicPr>
+            <a:picLocks noChangeAspect="1"/>
+          </p:cNvPicPr>
+          <p:nvPr/>
+        </p:nvPicPr>
+        <p:blipFill>
+          <a:blip r:embed="rId12"/>
+          <a:stretch>
+            <a:fillRect/>
+          </a:stretch>
+        </p:blipFill>
+        <p:spPr>
+          <a:xfrm>
+            <a:off x="4023419" y="5065158"/>
+            <a:ext cx="2255826" cy="1693891"/>
+          </a:xfrm>
+          <a:prstGeom prst="rect">
+            <a:avLst/>
+          </a:prstGeom>
+        </p:spPr>
+      </p:pic>
+      <p:pic>
+        <p:nvPicPr>
+          <p:cNvPr id="18" name="그림 17">
+            <a:extLst>
+              <a:ext uri="{FF2B5EF4-FFF2-40B4-BE49-F238E27FC236}">
+                <a16:creationId xmlns:a16="http://schemas.microsoft.com/office/drawing/2014/main" id="{9421D93C-2F81-B08A-CA28-EA331F5CB090}"/>
+              </a:ext>
+            </a:extLst>
+          </p:cNvPr>
+          <p:cNvPicPr>
+            <a:picLocks noChangeAspect="1"/>
+          </p:cNvPicPr>
+          <p:nvPr/>
+        </p:nvPicPr>
+        <p:blipFill>
+          <a:blip r:embed="rId13"/>
+          <a:stretch>
+            <a:fillRect/>
+          </a:stretch>
+        </p:blipFill>
+        <p:spPr>
+          <a:xfrm>
+            <a:off x="1192149" y="7215958"/>
+            <a:ext cx="2024062" cy="556617"/>
+          </a:xfrm>
+          <a:prstGeom prst="rect">
+            <a:avLst/>
+          </a:prstGeom>
+        </p:spPr>
+      </p:pic>
+      <p:pic>
+        <p:nvPicPr>
+          <p:cNvPr id="21" name="그림 20">
+            <a:extLst>
+              <a:ext uri="{FF2B5EF4-FFF2-40B4-BE49-F238E27FC236}">
+                <a16:creationId xmlns:a16="http://schemas.microsoft.com/office/drawing/2014/main" id="{AF169C83-0465-0405-CD21-F0226488F1E1}"/>
+              </a:ext>
+            </a:extLst>
+          </p:cNvPr>
+          <p:cNvPicPr>
+            <a:picLocks noChangeAspect="1"/>
+          </p:cNvPicPr>
+          <p:nvPr/>
+        </p:nvPicPr>
+        <p:blipFill>
+          <a:blip r:embed="rId14"/>
+          <a:stretch>
+            <a:fillRect/>
+          </a:stretch>
+        </p:blipFill>
+        <p:spPr>
+          <a:xfrm>
+            <a:off x="3363847" y="7101028"/>
+            <a:ext cx="1519238" cy="671547"/>
+          </a:xfrm>
+          <a:prstGeom prst="rect">
+            <a:avLst/>
+          </a:prstGeom>
+        </p:spPr>
+      </p:pic>
+      <p:pic>
+        <p:nvPicPr>
+          <p:cNvPr id="27" name="그림 26">
+            <a:extLst>
+              <a:ext uri="{FF2B5EF4-FFF2-40B4-BE49-F238E27FC236}">
+                <a16:creationId xmlns:a16="http://schemas.microsoft.com/office/drawing/2014/main" id="{5F2166DA-CF82-D53D-9C7F-39BFD7F9DCDE}"/>
+              </a:ext>
+            </a:extLst>
+          </p:cNvPr>
+          <p:cNvPicPr>
+            <a:picLocks noChangeAspect="1"/>
+          </p:cNvPicPr>
+          <p:nvPr/>
+        </p:nvPicPr>
+        <p:blipFill>
+          <a:blip r:embed="rId15"/>
+          <a:stretch>
+            <a:fillRect/>
+          </a:stretch>
+        </p:blipFill>
+        <p:spPr>
+          <a:xfrm>
+            <a:off x="1192149" y="6835895"/>
+            <a:ext cx="936691" cy="297433"/>
+          </a:xfrm>
+          <a:prstGeom prst="rect">
+            <a:avLst/>
+          </a:prstGeom>
+        </p:spPr>
+      </p:pic>
+      <p:sp>
+        <p:nvSpPr>
+          <p:cNvPr id="28" name="TextBox 27">
+            <a:extLst>
+              <a:ext uri="{FF2B5EF4-FFF2-40B4-BE49-F238E27FC236}">
+                <a16:creationId xmlns:a16="http://schemas.microsoft.com/office/drawing/2014/main" id="{7CC37169-323F-3464-3DA1-4B47F5950A44}"/>
+              </a:ext>
+            </a:extLst>
+          </p:cNvPr>
+          <p:cNvSpPr txBox="1"/>
+          <p:nvPr/>
+        </p:nvSpPr>
+        <p:spPr>
+          <a:xfrm>
+            <a:off x="728663" y="7775194"/>
+            <a:ext cx="2105025" cy="369332"/>
+          </a:xfrm>
+          <a:prstGeom prst="rect">
+            <a:avLst/>
+          </a:prstGeom>
+          <a:noFill/>
+        </p:spPr>
+        <p:txBody>
+          <a:bodyPr wrap="square" rtlCol="0">
+            <a:spAutoFit/>
+          </a:bodyPr>
+          <a:lstStyle/>
+          <a:p>
+            <a:r>
+              <a:rPr lang="en-US" altLang="ko-KR" dirty="0"/>
+              <a:t>R3</a:t>
+            </a:r>
+            <a:endParaRPr lang="ko-KR" altLang="en-US" dirty="0"/>
+          </a:p>
+        </p:txBody>
+      </p:sp>
+    </p:spTree>
+    <p:extLst>
+      <p:ext uri="{BB962C8B-B14F-4D97-AF65-F5344CB8AC3E}">
+        <p14:creationId xmlns:p14="http://schemas.microsoft.com/office/powerpoint/2010/main" val="3971423683"/>
+      </p:ext>
+    </p:extLst>
+  </p:cSld>
+  <p:clrMapOvr>
+    <a:masterClrMapping/>
+  </p:clrMapOvr>
+</p:sld>
+</file>
+
 <file path=ppt/theme/theme1.xml><?xml version="1.0" encoding="utf-8"?>
 <a:theme xmlns:a="http://schemas.openxmlformats.org/drawingml/2006/main" name="Office 테마">
   <a:themeElements>
@@ -18265,110 +18881,16 @@
         <a:srgbClr val="96607D"/>
       </a:folHlink>
     </a:clrScheme>
-    <a:fontScheme name="Office 테마">
+    <a:fontScheme name="사용자 지정 2">
       <a:majorFont>
-        <a:latin typeface="Aptos Display" panose="02110004020202020204"/>
-        <a:ea typeface=""/>
+        <a:latin typeface="Arial Nova"/>
+        <a:ea typeface="맑은 고딕"/>
         <a:cs typeface=""/>
-        <a:font script="Jpan" typeface="游ゴシック Light"/>
-        <a:font script="Hang" typeface="맑은 고딕"/>
-        <a:font script="Hans" typeface="等线 Light"/>
-        <a:font script="Hant" typeface="新細明體"/>
-        <a:font script="Arab" typeface="Times New Roman"/>
-        <a:font script="Hebr" typeface="Times New Roman"/>
-        <a:font script="Thai" typeface="Angsana New"/>
-        <a:font script="Ethi" typeface="Nyala"/>
-        <a:font script="Beng" typeface="Vrinda"/>
-        <a:font script="Gujr" typeface="Shruti"/>
-        <a:font script="Khmr" typeface="MoolBoran"/>
-        <a:font script="Knda" typeface="Tunga"/>
-        <a:font script="Guru" typeface="Raavi"/>
-        <a:font script="Cans" typeface="Euphemia"/>
-        <a:font script="Cher" typeface="Plantagenet Cherokee"/>
-        <a:font script="Yiii" typeface="Microsoft Yi Baiti"/>
-        <a:font script="Tibt" typeface="Microsoft Himalaya"/>
-        <a:font script="Thaa" typeface="MV Boli"/>
-        <a:font script="Deva" typeface="Mangal"/>
-        <a:font script="Telu" typeface="Gautami"/>
-        <a:font script="Taml" typeface="Latha"/>
-        <a:font script="Syrc" typeface="Estrangelo Edessa"/>
-        <a:font script="Orya" typeface="Kalinga"/>
-        <a:font script="Mlym" typeface="Kartika"/>
-        <a:font script="Laoo" typeface="DokChampa"/>
-        <a:font script="Sinh" typeface="Iskoola Pota"/>
-        <a:font script="Mong" typeface="Mongolian Baiti"/>
-        <a:font script="Viet" typeface="Times New Roman"/>
-        <a:font script="Uigh" typeface="Microsoft Uighur"/>
-        <a:font script="Geor" typeface="Sylfaen"/>
-        <a:font script="Armn" typeface="Arial"/>
-        <a:font script="Bugi" typeface="Leelawadee UI"/>
-        <a:font script="Bopo" typeface="Microsoft JhengHei"/>
-        <a:font script="Java" typeface="Javanese Text"/>
-        <a:font script="Lisu" typeface="Segoe UI"/>
-        <a:font script="Mymr" typeface="Myanmar Text"/>
-        <a:font script="Nkoo" typeface="Ebrima"/>
-        <a:font script="Olck" typeface="Nirmala UI"/>
-        <a:font script="Osma" typeface="Ebrima"/>
-        <a:font script="Phag" typeface="Phagspa"/>
-        <a:font script="Syrn" typeface="Estrangelo Edessa"/>
-        <a:font script="Syrj" typeface="Estrangelo Edessa"/>
-        <a:font script="Syre" typeface="Estrangelo Edessa"/>
-        <a:font script="Sora" typeface="Nirmala UI"/>
-        <a:font script="Tale" typeface="Microsoft Tai Le"/>
-        <a:font script="Talu" typeface="Microsoft New Tai Lue"/>
-        <a:font script="Tfng" typeface="Ebrima"/>
       </a:majorFont>
       <a:minorFont>
-        <a:latin typeface="Aptos" panose="02110004020202020204"/>
-        <a:ea typeface=""/>
+        <a:latin typeface="Arial"/>
+        <a:ea typeface="맑은 고딕"/>
         <a:cs typeface=""/>
-        <a:font script="Jpan" typeface="游ゴシック"/>
-        <a:font script="Hang" typeface="맑은 고딕"/>
-        <a:font script="Hans" typeface="等线"/>
-        <a:font script="Hant" typeface="新細明體"/>
-        <a:font script="Arab" typeface="Arial"/>
-        <a:font script="Hebr" typeface="Arial"/>
-        <a:font script="Thai" typeface="Cordia New"/>
-        <a:font script="Ethi" typeface="Nyala"/>
-        <a:font script="Beng" typeface="Vrinda"/>
-        <a:font script="Gujr" typeface="Shruti"/>
-        <a:font script="Khmr" typeface="DaunPenh"/>
-        <a:font script="Knda" typeface="Tunga"/>
-        <a:font script="Guru" typeface="Raavi"/>
-        <a:font script="Cans" typeface="Euphemia"/>
-        <a:font script="Cher" typeface="Plantagenet Cherokee"/>
-        <a:font script="Yiii" typeface="Microsoft Yi Baiti"/>
-        <a:font script="Tibt" typeface="Microsoft Himalaya"/>
-        <a:font script="Thaa" typeface="MV Boli"/>
-        <a:font script="Deva" typeface="Mangal"/>
-        <a:font script="Telu" typeface="Gautami"/>
-        <a:font script="Taml" typeface="Latha"/>
-        <a:font script="Syrc" typeface="Estrangelo Edessa"/>
-        <a:font script="Orya" typeface="Kalinga"/>
-        <a:font script="Mlym" typeface="Kartika"/>
-        <a:font script="Laoo" typeface="DokChampa"/>
-        <a:font script="Sinh" typeface="Iskoola Pota"/>
-        <a:font script="Mong" typeface="Mongolian Baiti"/>
-        <a:font script="Viet" typeface="Arial"/>
-        <a:font script="Uigh" typeface="Microsoft Uighur"/>
-        <a:font script="Geor" typeface="Sylfaen"/>
-        <a:font script="Armn" typeface="Arial"/>
-        <a:font script="Bugi" typeface="Leelawadee UI"/>
-        <a:font script="Bopo" typeface="Microsoft JhengHei"/>
-        <a:font script="Java" typeface="Javanese Text"/>
-        <a:font script="Lisu" typeface="Segoe UI"/>
-        <a:font script="Mymr" typeface="Myanmar Text"/>
-        <a:font script="Nkoo" typeface="Ebrima"/>
-        <a:font script="Olck" typeface="Nirmala UI"/>
-        <a:font script="Osma" typeface="Ebrima"/>
-        <a:font script="Phag" typeface="Phagspa"/>
-        <a:font script="Syrn" typeface="Estrangelo Edessa"/>
-        <a:font script="Syrj" typeface="Estrangelo Edessa"/>
-        <a:font script="Syre" typeface="Estrangelo Edessa"/>
-        <a:font script="Sora" typeface="Nirmala UI"/>
-        <a:font script="Tale" typeface="Microsoft Tai Le"/>
-        <a:font script="Talu" typeface="Microsoft New Tai Lue"/>
-        <a:font script="Tfng" typeface="Ebrima"/>
       </a:minorFont>
     </a:fontScheme>
     <a:fmtScheme name="Office 테마">

</xml_diff>

<commit_message>
First proof reading done, resubmission upload first trial. Not yet final submission.
</commit_message>
<xml_diff>
--- a/figures/Figures-EDL202605-manuscript.pptx
+++ b/figures/Figures-EDL202605-manuscript.pptx
@@ -209,7 +209,7 @@
           <a:p>
             <a:fld id="{AA311422-0C2E-42D7-924E-F365B5A34ABC}" type="datetimeFigureOut">
               <a:rPr lang="ko-KR" altLang="en-US" smtClean="0"/>
-              <a:t>2026-06-09</a:t>
+              <a:t>2026-06-10</a:t>
             </a:fld>
             <a:endParaRPr lang="ko-KR" altLang="en-US"/>
           </a:p>
@@ -607,7 +607,7 @@
           <a:p>
             <a:fld id="{038C53AF-CD6D-418E-B451-BA3CFECC6915}" type="datetimeFigureOut">
               <a:rPr lang="ko-KR" altLang="en-US" smtClean="0"/>
-              <a:t>2026-06-09</a:t>
+              <a:t>2026-06-10</a:t>
             </a:fld>
             <a:endParaRPr lang="ko-KR" altLang="en-US"/>
           </a:p>
@@ -777,7 +777,7 @@
           <a:p>
             <a:fld id="{038C53AF-CD6D-418E-B451-BA3CFECC6915}" type="datetimeFigureOut">
               <a:rPr lang="ko-KR" altLang="en-US" smtClean="0"/>
-              <a:t>2026-06-09</a:t>
+              <a:t>2026-06-10</a:t>
             </a:fld>
             <a:endParaRPr lang="ko-KR" altLang="en-US"/>
           </a:p>
@@ -957,7 +957,7 @@
           <a:p>
             <a:fld id="{038C53AF-CD6D-418E-B451-BA3CFECC6915}" type="datetimeFigureOut">
               <a:rPr lang="ko-KR" altLang="en-US" smtClean="0"/>
-              <a:t>2026-06-09</a:t>
+              <a:t>2026-06-10</a:t>
             </a:fld>
             <a:endParaRPr lang="ko-KR" altLang="en-US"/>
           </a:p>
@@ -1127,7 +1127,7 @@
           <a:p>
             <a:fld id="{038C53AF-CD6D-418E-B451-BA3CFECC6915}" type="datetimeFigureOut">
               <a:rPr lang="ko-KR" altLang="en-US" smtClean="0"/>
-              <a:t>2026-06-09</a:t>
+              <a:t>2026-06-10</a:t>
             </a:fld>
             <a:endParaRPr lang="ko-KR" altLang="en-US"/>
           </a:p>
@@ -1389,7 +1389,7 @@
           <a:p>
             <a:fld id="{038C53AF-CD6D-418E-B451-BA3CFECC6915}" type="datetimeFigureOut">
               <a:rPr lang="ko-KR" altLang="en-US" smtClean="0"/>
-              <a:t>2026-06-09</a:t>
+              <a:t>2026-06-10</a:t>
             </a:fld>
             <a:endParaRPr lang="ko-KR" altLang="en-US"/>
           </a:p>
@@ -1621,7 +1621,7 @@
           <a:p>
             <a:fld id="{038C53AF-CD6D-418E-B451-BA3CFECC6915}" type="datetimeFigureOut">
               <a:rPr lang="ko-KR" altLang="en-US" smtClean="0"/>
-              <a:t>2026-06-09</a:t>
+              <a:t>2026-06-10</a:t>
             </a:fld>
             <a:endParaRPr lang="ko-KR" altLang="en-US"/>
           </a:p>
@@ -1988,7 +1988,7 @@
           <a:p>
             <a:fld id="{038C53AF-CD6D-418E-B451-BA3CFECC6915}" type="datetimeFigureOut">
               <a:rPr lang="ko-KR" altLang="en-US" smtClean="0"/>
-              <a:t>2026-06-09</a:t>
+              <a:t>2026-06-10</a:t>
             </a:fld>
             <a:endParaRPr lang="ko-KR" altLang="en-US"/>
           </a:p>
@@ -2106,7 +2106,7 @@
           <a:p>
             <a:fld id="{038C53AF-CD6D-418E-B451-BA3CFECC6915}" type="datetimeFigureOut">
               <a:rPr lang="ko-KR" altLang="en-US" smtClean="0"/>
-              <a:t>2026-06-09</a:t>
+              <a:t>2026-06-10</a:t>
             </a:fld>
             <a:endParaRPr lang="ko-KR" altLang="en-US"/>
           </a:p>
@@ -2201,7 +2201,7 @@
           <a:p>
             <a:fld id="{038C53AF-CD6D-418E-B451-BA3CFECC6915}" type="datetimeFigureOut">
               <a:rPr lang="ko-KR" altLang="en-US" smtClean="0"/>
-              <a:t>2026-06-09</a:t>
+              <a:t>2026-06-10</a:t>
             </a:fld>
             <a:endParaRPr lang="ko-KR" altLang="en-US"/>
           </a:p>
@@ -2478,7 +2478,7 @@
           <a:p>
             <a:fld id="{038C53AF-CD6D-418E-B451-BA3CFECC6915}" type="datetimeFigureOut">
               <a:rPr lang="ko-KR" altLang="en-US" smtClean="0"/>
-              <a:t>2026-06-09</a:t>
+              <a:t>2026-06-10</a:t>
             </a:fld>
             <a:endParaRPr lang="ko-KR" altLang="en-US"/>
           </a:p>
@@ -2735,7 +2735,7 @@
           <a:p>
             <a:fld id="{038C53AF-CD6D-418E-B451-BA3CFECC6915}" type="datetimeFigureOut">
               <a:rPr lang="ko-KR" altLang="en-US" smtClean="0"/>
-              <a:t>2026-06-09</a:t>
+              <a:t>2026-06-10</a:t>
             </a:fld>
             <a:endParaRPr lang="ko-KR" altLang="en-US"/>
           </a:p>
@@ -2948,7 +2948,7 @@
           <a:p>
             <a:fld id="{038C53AF-CD6D-418E-B451-BA3CFECC6915}" type="datetimeFigureOut">
               <a:rPr lang="ko-KR" altLang="en-US" smtClean="0"/>
-              <a:t>2026-06-09</a:t>
+              <a:t>2026-06-10</a:t>
             </a:fld>
             <a:endParaRPr lang="ko-KR" altLang="en-US"/>
           </a:p>
@@ -13131,8 +13131,8 @@
           </a:graphicData>
         </a:graphic>
       </p:graphicFrame>
-      <mc:AlternateContent xmlns:mc="http://schemas.openxmlformats.org/markup-compatibility/2006">
-        <mc:Choice xmlns:a14="http://schemas.microsoft.com/office/drawing/2010/main" Requires="a14">
+      <mc:AlternateContent xmlns:mc="http://schemas.openxmlformats.org/markup-compatibility/2006" xmlns:a14="http://schemas.microsoft.com/office/drawing/2010/main">
+        <mc:Choice Requires="a14">
           <p:sp>
             <p:nvSpPr>
               <p:cNvPr id="7" name="TextBox 6">
@@ -13392,7 +13392,7 @@
             </p:txBody>
           </p:sp>
         </mc:Choice>
-        <mc:Fallback>
+        <mc:Fallback xmlns="">
           <p:sp>
             <p:nvSpPr>
               <p:cNvPr id="7" name="TextBox 6">
@@ -13437,8 +13437,8 @@
           </p:sp>
         </mc:Fallback>
       </mc:AlternateContent>
-      <mc:AlternateContent xmlns:mc="http://schemas.openxmlformats.org/markup-compatibility/2006">
-        <mc:Choice xmlns:a14="http://schemas.microsoft.com/office/drawing/2010/main" Requires="a14">
+      <mc:AlternateContent xmlns:mc="http://schemas.openxmlformats.org/markup-compatibility/2006" xmlns:a14="http://schemas.microsoft.com/office/drawing/2010/main">
+        <mc:Choice Requires="a14">
           <p:sp>
             <p:nvSpPr>
               <p:cNvPr id="11" name="TextBox 10">
@@ -13698,7 +13698,7 @@
             </p:txBody>
           </p:sp>
         </mc:Choice>
-        <mc:Fallback>
+        <mc:Fallback xmlns="">
           <p:sp>
             <p:nvSpPr>
               <p:cNvPr id="11" name="TextBox 10">
@@ -16484,7 +16484,7 @@
           <p:nvPr>
             <p:extLst>
               <p:ext uri="{D42A27DB-BD31-4B8C-83A1-F6EECF244321}">
-                <p14:modId xmlns:p14="http://schemas.microsoft.com/office/powerpoint/2010/main" val="1614913580"/>
+                <p14:modId xmlns:p14="http://schemas.microsoft.com/office/powerpoint/2010/main" val="3875591607"/>
               </p:ext>
             </p:extLst>
           </p:nvPr>
@@ -16547,7 +16547,7 @@
           <p:nvPr>
             <p:extLst>
               <p:ext uri="{D42A27DB-BD31-4B8C-83A1-F6EECF244321}">
-                <p14:modId xmlns:p14="http://schemas.microsoft.com/office/powerpoint/2010/main" val="3012110154"/>
+                <p14:modId xmlns:p14="http://schemas.microsoft.com/office/powerpoint/2010/main" val="2736184986"/>
               </p:ext>
             </p:extLst>
           </p:nvPr>
@@ -18568,8 +18568,8 @@
           <a:lstStyle/>
           <a:p>
             <a:r>
-              <a:rPr lang="en-US" altLang="ko-KR" dirty="0"/>
-              <a:t>R1</a:t>
+              <a:rPr lang="en-US" altLang="ko-KR"/>
+              <a:t>R1-1</a:t>
             </a:r>
             <a:endParaRPr lang="ko-KR" altLang="en-US" dirty="0"/>
           </a:p>
@@ -18821,7 +18821,7 @@
           <a:p>
             <a:r>
               <a:rPr lang="en-US" altLang="ko-KR" dirty="0"/>
-              <a:t>R3</a:t>
+              <a:t>R1-6</a:t>
             </a:r>
             <a:endParaRPr lang="ko-KR" altLang="en-US" dirty="0"/>
           </a:p>

</xml_diff>

<commit_message>
Final submission finished after minor changes in response file especially 1-3.
</commit_message>
<xml_diff>
--- a/figures/Figures-EDL202605-manuscript.pptx
+++ b/figures/Figures-EDL202605-manuscript.pptx
@@ -209,7 +209,7 @@
           <a:p>
             <a:fld id="{AA311422-0C2E-42D7-924E-F365B5A34ABC}" type="datetimeFigureOut">
               <a:rPr lang="ko-KR" altLang="en-US" smtClean="0"/>
-              <a:t>2026-06-10</a:t>
+              <a:t>2026-06-11</a:t>
             </a:fld>
             <a:endParaRPr lang="ko-KR" altLang="en-US"/>
           </a:p>
@@ -607,7 +607,7 @@
           <a:p>
             <a:fld id="{038C53AF-CD6D-418E-B451-BA3CFECC6915}" type="datetimeFigureOut">
               <a:rPr lang="ko-KR" altLang="en-US" smtClean="0"/>
-              <a:t>2026-06-10</a:t>
+              <a:t>2026-06-11</a:t>
             </a:fld>
             <a:endParaRPr lang="ko-KR" altLang="en-US"/>
           </a:p>
@@ -777,7 +777,7 @@
           <a:p>
             <a:fld id="{038C53AF-CD6D-418E-B451-BA3CFECC6915}" type="datetimeFigureOut">
               <a:rPr lang="ko-KR" altLang="en-US" smtClean="0"/>
-              <a:t>2026-06-10</a:t>
+              <a:t>2026-06-11</a:t>
             </a:fld>
             <a:endParaRPr lang="ko-KR" altLang="en-US"/>
           </a:p>
@@ -957,7 +957,7 @@
           <a:p>
             <a:fld id="{038C53AF-CD6D-418E-B451-BA3CFECC6915}" type="datetimeFigureOut">
               <a:rPr lang="ko-KR" altLang="en-US" smtClean="0"/>
-              <a:t>2026-06-10</a:t>
+              <a:t>2026-06-11</a:t>
             </a:fld>
             <a:endParaRPr lang="ko-KR" altLang="en-US"/>
           </a:p>
@@ -1127,7 +1127,7 @@
           <a:p>
             <a:fld id="{038C53AF-CD6D-418E-B451-BA3CFECC6915}" type="datetimeFigureOut">
               <a:rPr lang="ko-KR" altLang="en-US" smtClean="0"/>
-              <a:t>2026-06-10</a:t>
+              <a:t>2026-06-11</a:t>
             </a:fld>
             <a:endParaRPr lang="ko-KR" altLang="en-US"/>
           </a:p>
@@ -1389,7 +1389,7 @@
           <a:p>
             <a:fld id="{038C53AF-CD6D-418E-B451-BA3CFECC6915}" type="datetimeFigureOut">
               <a:rPr lang="ko-KR" altLang="en-US" smtClean="0"/>
-              <a:t>2026-06-10</a:t>
+              <a:t>2026-06-11</a:t>
             </a:fld>
             <a:endParaRPr lang="ko-KR" altLang="en-US"/>
           </a:p>
@@ -1621,7 +1621,7 @@
           <a:p>
             <a:fld id="{038C53AF-CD6D-418E-B451-BA3CFECC6915}" type="datetimeFigureOut">
               <a:rPr lang="ko-KR" altLang="en-US" smtClean="0"/>
-              <a:t>2026-06-10</a:t>
+              <a:t>2026-06-11</a:t>
             </a:fld>
             <a:endParaRPr lang="ko-KR" altLang="en-US"/>
           </a:p>
@@ -1988,7 +1988,7 @@
           <a:p>
             <a:fld id="{038C53AF-CD6D-418E-B451-BA3CFECC6915}" type="datetimeFigureOut">
               <a:rPr lang="ko-KR" altLang="en-US" smtClean="0"/>
-              <a:t>2026-06-10</a:t>
+              <a:t>2026-06-11</a:t>
             </a:fld>
             <a:endParaRPr lang="ko-KR" altLang="en-US"/>
           </a:p>
@@ -2106,7 +2106,7 @@
           <a:p>
             <a:fld id="{038C53AF-CD6D-418E-B451-BA3CFECC6915}" type="datetimeFigureOut">
               <a:rPr lang="ko-KR" altLang="en-US" smtClean="0"/>
-              <a:t>2026-06-10</a:t>
+              <a:t>2026-06-11</a:t>
             </a:fld>
             <a:endParaRPr lang="ko-KR" altLang="en-US"/>
           </a:p>
@@ -2201,7 +2201,7 @@
           <a:p>
             <a:fld id="{038C53AF-CD6D-418E-B451-BA3CFECC6915}" type="datetimeFigureOut">
               <a:rPr lang="ko-KR" altLang="en-US" smtClean="0"/>
-              <a:t>2026-06-10</a:t>
+              <a:t>2026-06-11</a:t>
             </a:fld>
             <a:endParaRPr lang="ko-KR" altLang="en-US"/>
           </a:p>
@@ -2478,7 +2478,7 @@
           <a:p>
             <a:fld id="{038C53AF-CD6D-418E-B451-BA3CFECC6915}" type="datetimeFigureOut">
               <a:rPr lang="ko-KR" altLang="en-US" smtClean="0"/>
-              <a:t>2026-06-10</a:t>
+              <a:t>2026-06-11</a:t>
             </a:fld>
             <a:endParaRPr lang="ko-KR" altLang="en-US"/>
           </a:p>
@@ -2735,7 +2735,7 @@
           <a:p>
             <a:fld id="{038C53AF-CD6D-418E-B451-BA3CFECC6915}" type="datetimeFigureOut">
               <a:rPr lang="ko-KR" altLang="en-US" smtClean="0"/>
-              <a:t>2026-06-10</a:t>
+              <a:t>2026-06-11</a:t>
             </a:fld>
             <a:endParaRPr lang="ko-KR" altLang="en-US"/>
           </a:p>
@@ -2948,7 +2948,7 @@
           <a:p>
             <a:fld id="{038C53AF-CD6D-418E-B451-BA3CFECC6915}" type="datetimeFigureOut">
               <a:rPr lang="ko-KR" altLang="en-US" smtClean="0"/>
-              <a:t>2026-06-10</a:t>
+              <a:t>2026-06-11</a:t>
             </a:fld>
             <a:endParaRPr lang="ko-KR" altLang="en-US"/>
           </a:p>
@@ -11765,7 +11765,7 @@
           <p:nvPr>
             <p:extLst>
               <p:ext uri="{D42A27DB-BD31-4B8C-83A1-F6EECF244321}">
-                <p14:modId xmlns:p14="http://schemas.microsoft.com/office/powerpoint/2010/main" val="1966354765"/>
+                <p14:modId xmlns:p14="http://schemas.microsoft.com/office/powerpoint/2010/main" val="2427854764"/>
               </p:ext>
             </p:extLst>
           </p:nvPr>
@@ -12081,10 +12081,8 @@
                       <a:headEnd type="none" w="med" len="med"/>
                       <a:tailEnd type="none" w="med" len="med"/>
                     </a:lnL>
-                    <a:lnR w="3175" cap="flat" cmpd="sng" algn="ctr">
-                      <a:solidFill>
-                        <a:schemeClr val="bg1"/>
-                      </a:solidFill>
+                    <a:lnR w="12700" cap="flat" cmpd="sng" algn="ctr">
+                      <a:noFill/>
                       <a:prstDash val="solid"/>
                       <a:round/>
                       <a:headEnd type="none" w="med" len="med"/>
@@ -12130,10 +12128,8 @@
                     </a:p>
                   </a:txBody>
                   <a:tcPr anchor="ctr">
-                    <a:lnL w="3175" cap="flat" cmpd="sng" algn="ctr">
-                      <a:solidFill>
-                        <a:schemeClr val="bg1"/>
-                      </a:solidFill>
+                    <a:lnL w="12700" cap="flat" cmpd="sng" algn="ctr">
+                      <a:noFill/>
                       <a:prstDash val="solid"/>
                       <a:round/>
                       <a:headEnd type="none" w="med" len="med"/>
@@ -12276,10 +12272,8 @@
                       <a:headEnd type="none" w="med" len="med"/>
                       <a:tailEnd type="none" w="med" len="med"/>
                     </a:lnL>
-                    <a:lnR w="3175" cap="flat" cmpd="sng" algn="ctr">
-                      <a:solidFill>
-                        <a:schemeClr val="bg1"/>
-                      </a:solidFill>
+                    <a:lnR w="12700" cap="flat" cmpd="sng" algn="ctr">
+                      <a:noFill/>
                       <a:prstDash val="solid"/>
                       <a:round/>
                       <a:headEnd type="none" w="med" len="med"/>
@@ -12325,10 +12319,8 @@
                     </a:p>
                   </a:txBody>
                   <a:tcPr anchor="ctr">
-                    <a:lnL w="3175" cap="flat" cmpd="sng" algn="ctr">
-                      <a:solidFill>
-                        <a:schemeClr val="bg1"/>
-                      </a:solidFill>
+                    <a:lnL w="12700" cap="flat" cmpd="sng" algn="ctr">
+                      <a:noFill/>
                       <a:prstDash val="solid"/>
                       <a:round/>
                       <a:headEnd type="none" w="med" len="med"/>
@@ -12464,10 +12456,8 @@
                       <a:headEnd type="none" w="med" len="med"/>
                       <a:tailEnd type="none" w="med" len="med"/>
                     </a:lnL>
-                    <a:lnR w="3175" cap="flat" cmpd="sng" algn="ctr">
-                      <a:solidFill>
-                        <a:schemeClr val="bg1"/>
-                      </a:solidFill>
+                    <a:lnR w="12700" cap="flat" cmpd="sng" algn="ctr">
+                      <a:noFill/>
                       <a:prstDash val="solid"/>
                       <a:round/>
                       <a:headEnd type="none" w="med" len="med"/>
@@ -12513,10 +12503,8 @@
                     </a:p>
                   </a:txBody>
                   <a:tcPr anchor="ctr">
-                    <a:lnL w="3175" cap="flat" cmpd="sng" algn="ctr">
-                      <a:solidFill>
-                        <a:schemeClr val="bg1"/>
-                      </a:solidFill>
+                    <a:lnL w="12700" cap="flat" cmpd="sng" algn="ctr">
+                      <a:noFill/>
                       <a:prstDash val="solid"/>
                       <a:round/>
                       <a:headEnd type="none" w="med" len="med"/>
@@ -12659,10 +12647,8 @@
                       <a:headEnd type="none" w="med" len="med"/>
                       <a:tailEnd type="none" w="med" len="med"/>
                     </a:lnL>
-                    <a:lnR w="3175" cap="flat" cmpd="sng" algn="ctr">
-                      <a:solidFill>
-                        <a:schemeClr val="bg1"/>
-                      </a:solidFill>
+                    <a:lnR w="12700" cap="flat" cmpd="sng" algn="ctr">
+                      <a:noFill/>
                       <a:prstDash val="solid"/>
                       <a:round/>
                       <a:headEnd type="none" w="med" len="med"/>
@@ -12708,10 +12694,8 @@
                     </a:p>
                   </a:txBody>
                   <a:tcPr anchor="ctr">
-                    <a:lnL w="3175" cap="flat" cmpd="sng" algn="ctr">
-                      <a:solidFill>
-                        <a:schemeClr val="bg1"/>
-                      </a:solidFill>
+                    <a:lnL w="12700" cap="flat" cmpd="sng" algn="ctr">
+                      <a:noFill/>
                       <a:prstDash val="solid"/>
                       <a:round/>
                       <a:headEnd type="none" w="med" len="med"/>
@@ -13077,7 +13061,7 @@
           <p:nvPr>
             <p:extLst>
               <p:ext uri="{D42A27DB-BD31-4B8C-83A1-F6EECF244321}">
-                <p14:modId xmlns:p14="http://schemas.microsoft.com/office/powerpoint/2010/main" val="3932695148"/>
+                <p14:modId xmlns:p14="http://schemas.microsoft.com/office/powerpoint/2010/main" val="364808345"/>
               </p:ext>
             </p:extLst>
           </p:nvPr>
@@ -13131,8 +13115,8 @@
           </a:graphicData>
         </a:graphic>
       </p:graphicFrame>
-      <mc:AlternateContent xmlns:mc="http://schemas.openxmlformats.org/markup-compatibility/2006" xmlns:a14="http://schemas.microsoft.com/office/drawing/2010/main">
-        <mc:Choice Requires="a14">
+      <mc:AlternateContent xmlns:mc="http://schemas.openxmlformats.org/markup-compatibility/2006">
+        <mc:Choice xmlns:a14="http://schemas.microsoft.com/office/drawing/2010/main" Requires="a14">
           <p:sp>
             <p:nvSpPr>
               <p:cNvPr id="7" name="TextBox 6">
@@ -13392,7 +13376,7 @@
             </p:txBody>
           </p:sp>
         </mc:Choice>
-        <mc:Fallback xmlns="">
+        <mc:Fallback>
           <p:sp>
             <p:nvSpPr>
               <p:cNvPr id="7" name="TextBox 6">
@@ -13437,8 +13421,8 @@
           </p:sp>
         </mc:Fallback>
       </mc:AlternateContent>
-      <mc:AlternateContent xmlns:mc="http://schemas.openxmlformats.org/markup-compatibility/2006" xmlns:a14="http://schemas.microsoft.com/office/drawing/2010/main">
-        <mc:Choice Requires="a14">
+      <mc:AlternateContent xmlns:mc="http://schemas.openxmlformats.org/markup-compatibility/2006">
+        <mc:Choice xmlns:a14="http://schemas.microsoft.com/office/drawing/2010/main" Requires="a14">
           <p:sp>
             <p:nvSpPr>
               <p:cNvPr id="11" name="TextBox 10">
@@ -13698,7 +13682,7 @@
             </p:txBody>
           </p:sp>
         </mc:Choice>
-        <mc:Fallback xmlns="">
+        <mc:Fallback>
           <p:sp>
             <p:nvSpPr>
               <p:cNvPr id="11" name="TextBox 10">
@@ -13990,7 +13974,7 @@
           <p:nvPr>
             <p:extLst>
               <p:ext uri="{D42A27DB-BD31-4B8C-83A1-F6EECF244321}">
-                <p14:modId xmlns:p14="http://schemas.microsoft.com/office/powerpoint/2010/main" val="1195729805"/>
+                <p14:modId xmlns:p14="http://schemas.microsoft.com/office/powerpoint/2010/main" val="950365911"/>
               </p:ext>
             </p:extLst>
           </p:nvPr>
@@ -14291,9 +14275,7 @@
                       <a:tailEnd type="none" w="med" len="med"/>
                     </a:lnL>
                     <a:lnR w="3175" cap="flat" cmpd="sng" algn="ctr">
-                      <a:solidFill>
-                        <a:schemeClr val="bg1"/>
-                      </a:solidFill>
+                      <a:noFill/>
                       <a:prstDash val="solid"/>
                       <a:round/>
                       <a:headEnd type="none" w="med" len="med"/>
@@ -14354,9 +14336,7 @@
                   </a:txBody>
                   <a:tcPr anchor="ctr">
                     <a:lnL w="3175" cap="flat" cmpd="sng" algn="ctr">
-                      <a:solidFill>
-                        <a:schemeClr val="bg1"/>
-                      </a:solidFill>
+                      <a:noFill/>
                       <a:prstDash val="solid"/>
                       <a:round/>
                       <a:headEnd type="none" w="med" len="med"/>
@@ -14493,9 +14473,7 @@
                       <a:tailEnd type="none" w="med" len="med"/>
                     </a:lnL>
                     <a:lnR w="3175" cap="flat" cmpd="sng" algn="ctr">
-                      <a:solidFill>
-                        <a:schemeClr val="bg1"/>
-                      </a:solidFill>
+                      <a:noFill/>
                       <a:prstDash val="solid"/>
                       <a:round/>
                       <a:headEnd type="none" w="med" len="med"/>
@@ -14563,9 +14541,7 @@
                   </a:txBody>
                   <a:tcPr anchor="ctr">
                     <a:lnL w="3175" cap="flat" cmpd="sng" algn="ctr">
-                      <a:solidFill>
-                        <a:schemeClr val="bg1"/>
-                      </a:solidFill>
+                      <a:noFill/>
                       <a:prstDash val="solid"/>
                       <a:round/>
                       <a:headEnd type="none" w="med" len="med"/>
@@ -14723,9 +14699,7 @@
                       <a:tailEnd type="none" w="med" len="med"/>
                     </a:lnL>
                     <a:lnR w="3175" cap="flat" cmpd="sng" algn="ctr">
-                      <a:solidFill>
-                        <a:schemeClr val="bg1"/>
-                      </a:solidFill>
+                      <a:noFill/>
                       <a:prstDash val="solid"/>
                       <a:round/>
                       <a:headEnd type="none" w="med" len="med"/>
@@ -14772,9 +14746,7 @@
                   </a:txBody>
                   <a:tcPr anchor="ctr">
                     <a:lnL w="3175" cap="flat" cmpd="sng" algn="ctr">
-                      <a:solidFill>
-                        <a:schemeClr val="bg1"/>
-                      </a:solidFill>
+                      <a:noFill/>
                       <a:prstDash val="solid"/>
                       <a:round/>
                       <a:headEnd type="none" w="med" len="med"/>
@@ -14918,9 +14890,7 @@
                       <a:tailEnd type="none" w="med" len="med"/>
                     </a:lnL>
                     <a:lnR w="3175" cap="flat" cmpd="sng" algn="ctr">
-                      <a:solidFill>
-                        <a:schemeClr val="bg1"/>
-                      </a:solidFill>
+                      <a:noFill/>
                       <a:prstDash val="solid"/>
                       <a:round/>
                       <a:headEnd type="none" w="med" len="med"/>
@@ -14967,9 +14937,7 @@
                   </a:txBody>
                   <a:tcPr anchor="ctr">
                     <a:lnL w="3175" cap="flat" cmpd="sng" algn="ctr">
-                      <a:solidFill>
-                        <a:schemeClr val="bg1"/>
-                      </a:solidFill>
+                      <a:noFill/>
                       <a:prstDash val="solid"/>
                       <a:round/>
                       <a:headEnd type="none" w="med" len="med"/>
@@ -15275,7 +15243,7 @@
           <p:nvPr>
             <p:extLst>
               <p:ext uri="{D42A27DB-BD31-4B8C-83A1-F6EECF244321}">
-                <p14:modId xmlns:p14="http://schemas.microsoft.com/office/powerpoint/2010/main" val="859739522"/>
+                <p14:modId xmlns:p14="http://schemas.microsoft.com/office/powerpoint/2010/main" val="2988533916"/>
               </p:ext>
             </p:extLst>
           </p:nvPr>
@@ -15551,7 +15519,7 @@
           <p:nvPr>
             <p:extLst>
               <p:ext uri="{D42A27DB-BD31-4B8C-83A1-F6EECF244321}">
-                <p14:modId xmlns:p14="http://schemas.microsoft.com/office/powerpoint/2010/main" val="1970585430"/>
+                <p14:modId xmlns:p14="http://schemas.microsoft.com/office/powerpoint/2010/main" val="404958159"/>
               </p:ext>
             </p:extLst>
           </p:nvPr>
@@ -15874,10 +15842,8 @@
                       <a:headEnd type="none" w="med" len="med"/>
                       <a:tailEnd type="none" w="med" len="med"/>
                     </a:lnL>
-                    <a:lnR w="3175" cap="flat" cmpd="sng" algn="ctr">
-                      <a:solidFill>
-                        <a:schemeClr val="bg1"/>
-                      </a:solidFill>
+                    <a:lnR w="12700" cap="flat" cmpd="sng" algn="ctr">
+                      <a:noFill/>
                       <a:prstDash val="solid"/>
                       <a:round/>
                       <a:headEnd type="none" w="med" len="med"/>
@@ -15937,10 +15903,8 @@
                     </a:p>
                   </a:txBody>
                   <a:tcPr anchor="ctr">
-                    <a:lnL w="3175" cap="flat" cmpd="sng" algn="ctr">
-                      <a:solidFill>
-                        <a:schemeClr val="bg1"/>
-                      </a:solidFill>
+                    <a:lnL w="12700" cap="flat" cmpd="sng" algn="ctr">
+                      <a:noFill/>
                       <a:prstDash val="solid"/>
                       <a:round/>
                       <a:headEnd type="none" w="med" len="med"/>
@@ -16083,10 +16047,8 @@
                       <a:headEnd type="none" w="med" len="med"/>
                       <a:tailEnd type="none" w="med" len="med"/>
                     </a:lnL>
-                    <a:lnR w="3175" cap="flat" cmpd="sng" algn="ctr">
-                      <a:solidFill>
-                        <a:schemeClr val="bg1"/>
-                      </a:solidFill>
+                    <a:lnR w="12700" cap="flat" cmpd="sng" algn="ctr">
+                      <a:noFill/>
                       <a:prstDash val="solid"/>
                       <a:round/>
                       <a:headEnd type="none" w="med" len="med"/>
@@ -16146,10 +16108,8 @@
                     </a:p>
                   </a:txBody>
                   <a:tcPr anchor="ctr">
-                    <a:lnL w="3175" cap="flat" cmpd="sng" algn="ctr">
-                      <a:solidFill>
-                        <a:schemeClr val="bg1"/>
-                      </a:solidFill>
+                    <a:lnL w="12700" cap="flat" cmpd="sng" algn="ctr">
+                      <a:noFill/>
                       <a:prstDash val="solid"/>
                       <a:round/>
                       <a:headEnd type="none" w="med" len="med"/>

</xml_diff>